<commit_message>
Manuscript writing AI generated in parts and integrated. Figure fitting draft left in quick, Fig. 2(b) needs more implementation. Almost ready to be manuscript submission
</commit_message>
<xml_diff>
--- a/figures/Figures-EDL202602-manuscript.pptx
+++ b/figures/Figures-EDL202602-manuscript.pptx
@@ -1409,7 +1409,7 @@
           <a:p>
             <a:fld id="{AA311422-0C2E-42D7-924E-F365B5A34ABC}" type="datetimeFigureOut">
               <a:rPr lang="ko-KR" altLang="en-US" smtClean="0"/>
-              <a:t>2026-01-26</a:t>
+              <a:t>2026-01-28</a:t>
             </a:fld>
             <a:endParaRPr lang="ko-KR" altLang="en-US"/>
           </a:p>
@@ -1807,7 +1807,7 @@
           <a:p>
             <a:fld id="{038C53AF-CD6D-418E-B451-BA3CFECC6915}" type="datetimeFigureOut">
               <a:rPr lang="ko-KR" altLang="en-US" smtClean="0"/>
-              <a:t>2026-01-26</a:t>
+              <a:t>2026-01-28</a:t>
             </a:fld>
             <a:endParaRPr lang="ko-KR" altLang="en-US"/>
           </a:p>
@@ -1977,7 +1977,7 @@
           <a:p>
             <a:fld id="{038C53AF-CD6D-418E-B451-BA3CFECC6915}" type="datetimeFigureOut">
               <a:rPr lang="ko-KR" altLang="en-US" smtClean="0"/>
-              <a:t>2026-01-26</a:t>
+              <a:t>2026-01-28</a:t>
             </a:fld>
             <a:endParaRPr lang="ko-KR" altLang="en-US"/>
           </a:p>
@@ -2157,7 +2157,7 @@
           <a:p>
             <a:fld id="{038C53AF-CD6D-418E-B451-BA3CFECC6915}" type="datetimeFigureOut">
               <a:rPr lang="ko-KR" altLang="en-US" smtClean="0"/>
-              <a:t>2026-01-26</a:t>
+              <a:t>2026-01-28</a:t>
             </a:fld>
             <a:endParaRPr lang="ko-KR" altLang="en-US"/>
           </a:p>
@@ -2327,7 +2327,7 @@
           <a:p>
             <a:fld id="{038C53AF-CD6D-418E-B451-BA3CFECC6915}" type="datetimeFigureOut">
               <a:rPr lang="ko-KR" altLang="en-US" smtClean="0"/>
-              <a:t>2026-01-26</a:t>
+              <a:t>2026-01-28</a:t>
             </a:fld>
             <a:endParaRPr lang="ko-KR" altLang="en-US"/>
           </a:p>
@@ -2573,7 +2573,7 @@
           <a:p>
             <a:fld id="{038C53AF-CD6D-418E-B451-BA3CFECC6915}" type="datetimeFigureOut">
               <a:rPr lang="ko-KR" altLang="en-US" smtClean="0"/>
-              <a:t>2026-01-26</a:t>
+              <a:t>2026-01-28</a:t>
             </a:fld>
             <a:endParaRPr lang="ko-KR" altLang="en-US"/>
           </a:p>
@@ -2805,7 +2805,7 @@
           <a:p>
             <a:fld id="{038C53AF-CD6D-418E-B451-BA3CFECC6915}" type="datetimeFigureOut">
               <a:rPr lang="ko-KR" altLang="en-US" smtClean="0"/>
-              <a:t>2026-01-26</a:t>
+              <a:t>2026-01-28</a:t>
             </a:fld>
             <a:endParaRPr lang="ko-KR" altLang="en-US"/>
           </a:p>
@@ -3172,7 +3172,7 @@
           <a:p>
             <a:fld id="{038C53AF-CD6D-418E-B451-BA3CFECC6915}" type="datetimeFigureOut">
               <a:rPr lang="ko-KR" altLang="en-US" smtClean="0"/>
-              <a:t>2026-01-26</a:t>
+              <a:t>2026-01-28</a:t>
             </a:fld>
             <a:endParaRPr lang="ko-KR" altLang="en-US"/>
           </a:p>
@@ -3290,7 +3290,7 @@
           <a:p>
             <a:fld id="{038C53AF-CD6D-418E-B451-BA3CFECC6915}" type="datetimeFigureOut">
               <a:rPr lang="ko-KR" altLang="en-US" smtClean="0"/>
-              <a:t>2026-01-26</a:t>
+              <a:t>2026-01-28</a:t>
             </a:fld>
             <a:endParaRPr lang="ko-KR" altLang="en-US"/>
           </a:p>
@@ -3385,7 +3385,7 @@
           <a:p>
             <a:fld id="{038C53AF-CD6D-418E-B451-BA3CFECC6915}" type="datetimeFigureOut">
               <a:rPr lang="ko-KR" altLang="en-US" smtClean="0"/>
-              <a:t>2026-01-26</a:t>
+              <a:t>2026-01-28</a:t>
             </a:fld>
             <a:endParaRPr lang="ko-KR" altLang="en-US"/>
           </a:p>
@@ -3662,7 +3662,7 @@
           <a:p>
             <a:fld id="{038C53AF-CD6D-418E-B451-BA3CFECC6915}" type="datetimeFigureOut">
               <a:rPr lang="ko-KR" altLang="en-US" smtClean="0"/>
-              <a:t>2026-01-26</a:t>
+              <a:t>2026-01-28</a:t>
             </a:fld>
             <a:endParaRPr lang="ko-KR" altLang="en-US"/>
           </a:p>
@@ -3919,7 +3919,7 @@
           <a:p>
             <a:fld id="{038C53AF-CD6D-418E-B451-BA3CFECC6915}" type="datetimeFigureOut">
               <a:rPr lang="ko-KR" altLang="en-US" smtClean="0"/>
-              <a:t>2026-01-26</a:t>
+              <a:t>2026-01-28</a:t>
             </a:fld>
             <a:endParaRPr lang="ko-KR" altLang="en-US"/>
           </a:p>
@@ -4132,7 +4132,7 @@
           <a:p>
             <a:fld id="{038C53AF-CD6D-418E-B451-BA3CFECC6915}" type="datetimeFigureOut">
               <a:rPr lang="ko-KR" altLang="en-US" smtClean="0"/>
-              <a:t>2026-01-26</a:t>
+              <a:t>2026-01-28</a:t>
             </a:fld>
             <a:endParaRPr lang="ko-KR" altLang="en-US"/>
           </a:p>
@@ -6976,8 +6976,8 @@
             </a:fontRef>
           </p:style>
         </p:cxnSp>
-        <mc:AlternateContent xmlns:mc="http://schemas.openxmlformats.org/markup-compatibility/2006">
-          <mc:Choice xmlns:a14="http://schemas.microsoft.com/office/drawing/2010/main" Requires="a14">
+        <mc:AlternateContent xmlns:mc="http://schemas.openxmlformats.org/markup-compatibility/2006" xmlns:a14="http://schemas.microsoft.com/office/drawing/2010/main">
+          <mc:Choice Requires="a14">
             <p:sp>
               <p:nvSpPr>
                 <p:cNvPr id="269" name="TextBox 268">
@@ -7046,7 +7046,7 @@
               </p:txBody>
             </p:sp>
           </mc:Choice>
-          <mc:Fallback>
+          <mc:Fallback xmlns="">
             <p:sp>
               <p:nvSpPr>
                 <p:cNvPr id="269" name="TextBox 268">
@@ -7091,8 +7091,8 @@
             </p:sp>
           </mc:Fallback>
         </mc:AlternateContent>
-        <mc:AlternateContent xmlns:mc="http://schemas.openxmlformats.org/markup-compatibility/2006">
-          <mc:Choice xmlns:a14="http://schemas.microsoft.com/office/drawing/2010/main" Requires="a14">
+        <mc:AlternateContent xmlns:mc="http://schemas.openxmlformats.org/markup-compatibility/2006" xmlns:a14="http://schemas.microsoft.com/office/drawing/2010/main">
+          <mc:Choice Requires="a14">
             <p:sp>
               <p:nvSpPr>
                 <p:cNvPr id="270" name="TextBox 269">
@@ -7161,7 +7161,7 @@
               </p:txBody>
             </p:sp>
           </mc:Choice>
-          <mc:Fallback>
+          <mc:Fallback xmlns="">
             <p:sp>
               <p:nvSpPr>
                 <p:cNvPr id="270" name="TextBox 269">
@@ -7206,8 +7206,8 @@
             </p:sp>
           </mc:Fallback>
         </mc:AlternateContent>
-        <mc:AlternateContent xmlns:mc="http://schemas.openxmlformats.org/markup-compatibility/2006">
-          <mc:Choice xmlns:a14="http://schemas.microsoft.com/office/drawing/2010/main" Requires="a14">
+        <mc:AlternateContent xmlns:mc="http://schemas.openxmlformats.org/markup-compatibility/2006" xmlns:a14="http://schemas.microsoft.com/office/drawing/2010/main">
+          <mc:Choice Requires="a14">
             <p:sp>
               <p:nvSpPr>
                 <p:cNvPr id="271" name="TextBox 270">
@@ -7276,7 +7276,7 @@
               </p:txBody>
             </p:sp>
           </mc:Choice>
-          <mc:Fallback>
+          <mc:Fallback xmlns="">
             <p:sp>
               <p:nvSpPr>
                 <p:cNvPr id="271" name="TextBox 270">
@@ -7321,8 +7321,8 @@
             </p:sp>
           </mc:Fallback>
         </mc:AlternateContent>
-        <mc:AlternateContent xmlns:mc="http://schemas.openxmlformats.org/markup-compatibility/2006">
-          <mc:Choice xmlns:a14="http://schemas.microsoft.com/office/drawing/2010/main" Requires="a14">
+        <mc:AlternateContent xmlns:mc="http://schemas.openxmlformats.org/markup-compatibility/2006" xmlns:a14="http://schemas.microsoft.com/office/drawing/2010/main">
+          <mc:Choice Requires="a14">
             <p:sp>
               <p:nvSpPr>
                 <p:cNvPr id="272" name="TextBox 271">
@@ -7391,7 +7391,7 @@
               </p:txBody>
             </p:sp>
           </mc:Choice>
-          <mc:Fallback>
+          <mc:Fallback xmlns="">
             <p:sp>
               <p:nvSpPr>
                 <p:cNvPr id="272" name="TextBox 271">
@@ -7436,8 +7436,8 @@
             </p:sp>
           </mc:Fallback>
         </mc:AlternateContent>
-        <mc:AlternateContent xmlns:mc="http://schemas.openxmlformats.org/markup-compatibility/2006">
-          <mc:Choice xmlns:a14="http://schemas.microsoft.com/office/drawing/2010/main" Requires="a14">
+        <mc:AlternateContent xmlns:mc="http://schemas.openxmlformats.org/markup-compatibility/2006" xmlns:a14="http://schemas.microsoft.com/office/drawing/2010/main">
+          <mc:Choice Requires="a14">
             <p:sp>
               <p:nvSpPr>
                 <p:cNvPr id="273" name="TextBox 272">
@@ -7506,7 +7506,7 @@
               </p:txBody>
             </p:sp>
           </mc:Choice>
-          <mc:Fallback>
+          <mc:Fallback xmlns="">
             <p:sp>
               <p:nvSpPr>
                 <p:cNvPr id="273" name="TextBox 272">
@@ -7551,8 +7551,8 @@
             </p:sp>
           </mc:Fallback>
         </mc:AlternateContent>
-        <mc:AlternateContent xmlns:mc="http://schemas.openxmlformats.org/markup-compatibility/2006">
-          <mc:Choice xmlns:a14="http://schemas.microsoft.com/office/drawing/2010/main" Requires="a14">
+        <mc:AlternateContent xmlns:mc="http://schemas.openxmlformats.org/markup-compatibility/2006" xmlns:a14="http://schemas.microsoft.com/office/drawing/2010/main">
+          <mc:Choice Requires="a14">
             <p:sp>
               <p:nvSpPr>
                 <p:cNvPr id="274" name="TextBox 273">
@@ -7621,7 +7621,7 @@
               </p:txBody>
             </p:sp>
           </mc:Choice>
-          <mc:Fallback>
+          <mc:Fallback xmlns="">
             <p:sp>
               <p:nvSpPr>
                 <p:cNvPr id="274" name="TextBox 273">
@@ -9911,8 +9911,8 @@
                 </a:p>
               </p:txBody>
             </p:sp>
-            <mc:AlternateContent xmlns:mc="http://schemas.openxmlformats.org/markup-compatibility/2006">
-              <mc:Choice xmlns:a14="http://schemas.microsoft.com/office/drawing/2010/main" Requires="a14">
+            <mc:AlternateContent xmlns:mc="http://schemas.openxmlformats.org/markup-compatibility/2006" xmlns:a14="http://schemas.microsoft.com/office/drawing/2010/main">
+              <mc:Choice Requires="a14">
                 <p:sp>
                   <p:nvSpPr>
                     <p:cNvPr id="236" name="TextBox 235">
@@ -9979,7 +9979,7 @@
                   </p:txBody>
                 </p:sp>
               </mc:Choice>
-              <mc:Fallback>
+              <mc:Fallback xmlns="">
                 <p:sp>
                   <p:nvSpPr>
                     <p:cNvPr id="236" name="TextBox 235">
@@ -10135,8 +10135,8 @@
                 </a:p>
               </p:txBody>
             </p:sp>
-            <mc:AlternateContent xmlns:mc="http://schemas.openxmlformats.org/markup-compatibility/2006">
-              <mc:Choice xmlns:a14="http://schemas.microsoft.com/office/drawing/2010/main" Requires="a14">
+            <mc:AlternateContent xmlns:mc="http://schemas.openxmlformats.org/markup-compatibility/2006" xmlns:a14="http://schemas.microsoft.com/office/drawing/2010/main">
+              <mc:Choice Requires="a14">
                 <p:sp>
                   <p:nvSpPr>
                     <p:cNvPr id="332" name="TextBox 331">
@@ -10203,7 +10203,7 @@
                   </p:txBody>
                 </p:sp>
               </mc:Choice>
-              <mc:Fallback>
+              <mc:Fallback xmlns="">
                 <p:sp>
                   <p:nvSpPr>
                     <p:cNvPr id="332" name="TextBox 331">
@@ -10248,8 +10248,8 @@
                 </p:sp>
               </mc:Fallback>
             </mc:AlternateContent>
-            <mc:AlternateContent xmlns:mc="http://schemas.openxmlformats.org/markup-compatibility/2006">
-              <mc:Choice xmlns:a14="http://schemas.microsoft.com/office/drawing/2010/main" Requires="a14">
+            <mc:AlternateContent xmlns:mc="http://schemas.openxmlformats.org/markup-compatibility/2006" xmlns:a14="http://schemas.microsoft.com/office/drawing/2010/main">
+              <mc:Choice Requires="a14">
                 <p:sp>
                   <p:nvSpPr>
                     <p:cNvPr id="333" name="TextBox 332">
@@ -10316,7 +10316,7 @@
                   </p:txBody>
                 </p:sp>
               </mc:Choice>
-              <mc:Fallback>
+              <mc:Fallback xmlns="">
                 <p:sp>
                   <p:nvSpPr>
                     <p:cNvPr id="333" name="TextBox 332">
@@ -10361,8 +10361,8 @@
                 </p:sp>
               </mc:Fallback>
             </mc:AlternateContent>
-            <mc:AlternateContent xmlns:mc="http://schemas.openxmlformats.org/markup-compatibility/2006">
-              <mc:Choice xmlns:a14="http://schemas.microsoft.com/office/drawing/2010/main" Requires="a14">
+            <mc:AlternateContent xmlns:mc="http://schemas.openxmlformats.org/markup-compatibility/2006" xmlns:a14="http://schemas.microsoft.com/office/drawing/2010/main">
+              <mc:Choice Requires="a14">
                 <p:sp>
                   <p:nvSpPr>
                     <p:cNvPr id="334" name="TextBox 333">
@@ -10429,7 +10429,7 @@
                   </p:txBody>
                 </p:sp>
               </mc:Choice>
-              <mc:Fallback>
+              <mc:Fallback xmlns="">
                 <p:sp>
                   <p:nvSpPr>
                     <p:cNvPr id="334" name="TextBox 333">
@@ -10474,8 +10474,8 @@
                 </p:sp>
               </mc:Fallback>
             </mc:AlternateContent>
-            <mc:AlternateContent xmlns:mc="http://schemas.openxmlformats.org/markup-compatibility/2006">
-              <mc:Choice xmlns:a14="http://schemas.microsoft.com/office/drawing/2010/main" Requires="a14">
+            <mc:AlternateContent xmlns:mc="http://schemas.openxmlformats.org/markup-compatibility/2006" xmlns:a14="http://schemas.microsoft.com/office/drawing/2010/main">
+              <mc:Choice Requires="a14">
                 <p:sp>
                   <p:nvSpPr>
                     <p:cNvPr id="335" name="TextBox 334">
@@ -10534,7 +10534,7 @@
                   </p:txBody>
                 </p:sp>
               </mc:Choice>
-              <mc:Fallback>
+              <mc:Fallback xmlns="">
                 <p:sp>
                   <p:nvSpPr>
                     <p:cNvPr id="335" name="TextBox 334">
@@ -10579,8 +10579,8 @@
                 </p:sp>
               </mc:Fallback>
             </mc:AlternateContent>
-            <mc:AlternateContent xmlns:mc="http://schemas.openxmlformats.org/markup-compatibility/2006">
-              <mc:Choice xmlns:a14="http://schemas.microsoft.com/office/drawing/2010/main" Requires="a14">
+            <mc:AlternateContent xmlns:mc="http://schemas.openxmlformats.org/markup-compatibility/2006" xmlns:a14="http://schemas.microsoft.com/office/drawing/2010/main">
+              <mc:Choice Requires="a14">
                 <p:sp>
                   <p:nvSpPr>
                     <p:cNvPr id="336" name="TextBox 335">
@@ -10639,7 +10639,7 @@
                   </p:txBody>
                 </p:sp>
               </mc:Choice>
-              <mc:Fallback>
+              <mc:Fallback xmlns="">
                 <p:sp>
                   <p:nvSpPr>
                     <p:cNvPr id="336" name="TextBox 335">
@@ -10684,8 +10684,8 @@
                 </p:sp>
               </mc:Fallback>
             </mc:AlternateContent>
-            <mc:AlternateContent xmlns:mc="http://schemas.openxmlformats.org/markup-compatibility/2006">
-              <mc:Choice xmlns:a14="http://schemas.microsoft.com/office/drawing/2010/main" Requires="a14">
+            <mc:AlternateContent xmlns:mc="http://schemas.openxmlformats.org/markup-compatibility/2006" xmlns:a14="http://schemas.microsoft.com/office/drawing/2010/main">
+              <mc:Choice Requires="a14">
                 <p:sp>
                   <p:nvSpPr>
                     <p:cNvPr id="337" name="TextBox 336">
@@ -10744,7 +10744,7 @@
                   </p:txBody>
                 </p:sp>
               </mc:Choice>
-              <mc:Fallback>
+              <mc:Fallback xmlns="">
                 <p:sp>
                   <p:nvSpPr>
                     <p:cNvPr id="337" name="TextBox 336">
@@ -12696,401 +12696,284 @@
           </a:p>
         </p:txBody>
       </p:sp>
-      <p:grpSp>
-        <p:nvGrpSpPr>
-          <p:cNvPr id="108" name="그룹 107">
+      <p:graphicFrame>
+        <p:nvGraphicFramePr>
+          <p:cNvPr id="13" name="개체 12">
             <a:extLst>
               <a:ext uri="{FF2B5EF4-FFF2-40B4-BE49-F238E27FC236}">
-                <a16:creationId xmlns:a16="http://schemas.microsoft.com/office/drawing/2014/main" id="{3076F2E6-1858-809E-DA33-014F84D95B0E}"/>
+                <a16:creationId xmlns:a16="http://schemas.microsoft.com/office/drawing/2014/main" id="{6AC9440F-C5AD-60BD-76BA-02333CC9AE98}"/>
               </a:ext>
             </a:extLst>
           </p:cNvPr>
-          <p:cNvGrpSpPr/>
+          <p:cNvGraphicFramePr>
+            <a:graphicFrameLocks noChangeAspect="1"/>
+          </p:cNvGraphicFramePr>
+          <p:nvPr>
+            <p:extLst>
+              <p:ext uri="{D42A27DB-BD31-4B8C-83A1-F6EECF244321}">
+                <p14:modId xmlns:p14="http://schemas.microsoft.com/office/powerpoint/2010/main" val="1955687265"/>
+              </p:ext>
+            </p:extLst>
+          </p:nvPr>
+        </p:nvGraphicFramePr>
+        <p:xfrm>
+          <a:off x="511553" y="3272968"/>
+          <a:ext cx="2103853" cy="934350"/>
+        </p:xfrm>
+        <a:graphic>
+          <a:graphicData uri="http://schemas.openxmlformats.org/presentationml/2006/ole">
+            <mc:AlternateContent xmlns:mc="http://schemas.openxmlformats.org/markup-compatibility/2006">
+              <mc:Choice xmlns:v="urn:schemas-microsoft-com:vml" Requires="v">
+                <p:oleObj name="Graph" r:id="rId2" imgW="3734796" imgH="1658983" progId="Origin50.Graph">
+                  <p:embed/>
+                </p:oleObj>
+              </mc:Choice>
+              <mc:Fallback>
+                <p:oleObj name="Graph" r:id="rId2" imgW="3734796" imgH="1658983" progId="Origin50.Graph">
+                  <p:embed/>
+                  <p:pic>
+                    <p:nvPicPr>
+                      <p:cNvPr id="40" name="개체 39">
+                        <a:extLst>
+                          <a:ext uri="{FF2B5EF4-FFF2-40B4-BE49-F238E27FC236}">
+                            <a16:creationId xmlns:a16="http://schemas.microsoft.com/office/drawing/2014/main" id="{B82BFF56-A925-DA85-07B6-9932B4911FA6}"/>
+                          </a:ext>
+                        </a:extLst>
+                      </p:cNvPr>
+                      <p:cNvPicPr/>
+                      <p:nvPr/>
+                    </p:nvPicPr>
+                    <p:blipFill>
+                      <a:blip r:embed="rId3"/>
+                      <a:stretch>
+                        <a:fillRect/>
+                      </a:stretch>
+                    </p:blipFill>
+                    <p:spPr>
+                      <a:xfrm>
+                        <a:off x="511553" y="3272968"/>
+                        <a:ext cx="2103853" cy="934350"/>
+                      </a:xfrm>
+                      <a:prstGeom prst="rect">
+                        <a:avLst/>
+                      </a:prstGeom>
+                    </p:spPr>
+                  </p:pic>
+                </p:oleObj>
+              </mc:Fallback>
+            </mc:AlternateContent>
+          </a:graphicData>
+        </a:graphic>
+      </p:graphicFrame>
+      <p:graphicFrame>
+        <p:nvGraphicFramePr>
+          <p:cNvPr id="18" name="개체 17">
+            <a:extLst>
+              <a:ext uri="{FF2B5EF4-FFF2-40B4-BE49-F238E27FC236}">
+                <a16:creationId xmlns:a16="http://schemas.microsoft.com/office/drawing/2014/main" id="{38A4FE96-2DD0-F05D-A835-0E3D60A3FD29}"/>
+              </a:ext>
+            </a:extLst>
+          </p:cNvPr>
+          <p:cNvGraphicFramePr>
+            <a:graphicFrameLocks noChangeAspect="1"/>
+          </p:cNvGraphicFramePr>
+          <p:nvPr>
+            <p:extLst>
+              <p:ext uri="{D42A27DB-BD31-4B8C-83A1-F6EECF244321}">
+                <p14:modId xmlns:p14="http://schemas.microsoft.com/office/powerpoint/2010/main" val="80173979"/>
+              </p:ext>
+            </p:extLst>
+          </p:nvPr>
+        </p:nvGraphicFramePr>
+        <p:xfrm>
+          <a:off x="2074863" y="3273425"/>
+          <a:ext cx="2103437" cy="933450"/>
+        </p:xfrm>
+        <a:graphic>
+          <a:graphicData uri="http://schemas.openxmlformats.org/presentationml/2006/ole">
+            <mc:AlternateContent xmlns:mc="http://schemas.openxmlformats.org/markup-compatibility/2006">
+              <mc:Choice xmlns:v="urn:schemas-microsoft-com:vml" Requires="v">
+                <p:oleObj name="Graph" r:id="rId4" imgW="3734796" imgH="1658983" progId="Origin50.Graph">
+                  <p:embed/>
+                </p:oleObj>
+              </mc:Choice>
+              <mc:Fallback>
+                <p:oleObj name="Graph" r:id="rId4" imgW="3734796" imgH="1658983" progId="Origin50.Graph">
+                  <p:embed/>
+                  <p:pic>
+                    <p:nvPicPr>
+                      <p:cNvPr id="59" name="개체 58">
+                        <a:extLst>
+                          <a:ext uri="{FF2B5EF4-FFF2-40B4-BE49-F238E27FC236}">
+                            <a16:creationId xmlns:a16="http://schemas.microsoft.com/office/drawing/2014/main" id="{AAA9C498-6D1C-7684-C5AD-8C0784B709E5}"/>
+                          </a:ext>
+                        </a:extLst>
+                      </p:cNvPr>
+                      <p:cNvPicPr/>
+                      <p:nvPr/>
+                    </p:nvPicPr>
+                    <p:blipFill>
+                      <a:blip r:embed="rId5"/>
+                      <a:stretch>
+                        <a:fillRect/>
+                      </a:stretch>
+                    </p:blipFill>
+                    <p:spPr>
+                      <a:xfrm>
+                        <a:off x="2074863" y="3273425"/>
+                        <a:ext cx="2103437" cy="933450"/>
+                      </a:xfrm>
+                      <a:prstGeom prst="rect">
+                        <a:avLst/>
+                      </a:prstGeom>
+                    </p:spPr>
+                  </p:pic>
+                </p:oleObj>
+              </mc:Fallback>
+            </mc:AlternateContent>
+          </a:graphicData>
+        </a:graphic>
+      </p:graphicFrame>
+      <p:pic>
+        <p:nvPicPr>
+          <p:cNvPr id="44" name="그림 43">
+            <a:extLst>
+              <a:ext uri="{FF2B5EF4-FFF2-40B4-BE49-F238E27FC236}">
+                <a16:creationId xmlns:a16="http://schemas.microsoft.com/office/drawing/2014/main" id="{4282FAFB-AA49-AD36-3C4A-B91AF8250FAB}"/>
+              </a:ext>
+            </a:extLst>
+          </p:cNvPr>
+          <p:cNvPicPr>
+            <a:picLocks noChangeAspect="1"/>
+          </p:cNvPicPr>
           <p:nvPr/>
-        </p:nvGrpSpPr>
-        <p:grpSpPr>
+        </p:nvPicPr>
+        <p:blipFill>
+          <a:blip r:embed="rId6"/>
+          <a:stretch>
+            <a:fillRect/>
+          </a:stretch>
+        </p:blipFill>
+        <p:spPr>
           <a:xfrm>
-            <a:off x="511552" y="1877894"/>
-            <a:ext cx="3666725" cy="2329425"/>
-            <a:chOff x="511552" y="1877894"/>
-            <a:chExt cx="3666725" cy="2329425"/>
+            <a:off x="731225" y="2274767"/>
+            <a:ext cx="1666810" cy="645935"/>
           </a:xfrm>
-        </p:grpSpPr>
-        <mc:AlternateContent xmlns:mc="http://schemas.openxmlformats.org/markup-compatibility/2006">
-          <mc:Choice xmlns:a14="http://schemas.microsoft.com/office/drawing/2010/main" Requires="a14">
-            <p:graphicFrame>
-              <p:nvGraphicFramePr>
-                <p:cNvPr id="13" name="개체 12">
-                  <a:extLst>
-                    <a:ext uri="{FF2B5EF4-FFF2-40B4-BE49-F238E27FC236}">
-                      <a16:creationId xmlns:a16="http://schemas.microsoft.com/office/drawing/2014/main" id="{6AC9440F-C5AD-60BD-76BA-02333CC9AE98}"/>
-                    </a:ext>
-                  </a:extLst>
-                </p:cNvPr>
-                <p:cNvGraphicFramePr>
-                  <a:graphicFrameLocks noChangeAspect="1"/>
-                </p:cNvGraphicFramePr>
-                <p:nvPr>
-                  <p:extLst>
-                    <p:ext uri="{D42A27DB-BD31-4B8C-83A1-F6EECF244321}">
-                      <p14:modId xmlns:p14="http://schemas.microsoft.com/office/powerpoint/2010/main" val="1955687265"/>
-                    </p:ext>
-                  </p:extLst>
-                </p:nvPr>
-              </p:nvGraphicFramePr>
-              <p:xfrm>
-                <a:off x="511553" y="3272968"/>
-                <a:ext cx="2103853" cy="934350"/>
-              </p:xfrm>
-              <a:graphic>
-                <a:graphicData uri="http://schemas.openxmlformats.org/presentationml/2006/ole">
-                  <mc:AlternateContent>
-                    <mc:Choice xmlns:v="urn:schemas-microsoft-com:vml" Requires="v">
-                      <p:oleObj name="Graph" r:id="rId2" imgW="3734796" imgH="1658983" progId="Origin50.Graph">
-                        <p:embed/>
-                      </p:oleObj>
-                    </mc:Choice>
-                    <mc:Fallback>
-                      <p:oleObj name="Graph" r:id="rId2" imgW="3734796" imgH="1658983" progId="Origin50.Graph">
-                        <p:embed/>
-                        <p:pic>
-                          <p:nvPicPr>
-                            <p:cNvPr id="40" name="개체 39">
-                              <a:extLst>
-                                <a:ext uri="{FF2B5EF4-FFF2-40B4-BE49-F238E27FC236}">
-                                  <a16:creationId xmlns:a16="http://schemas.microsoft.com/office/drawing/2014/main" id="{B82BFF56-A925-DA85-07B6-9932B4911FA6}"/>
-                                </a:ext>
-                              </a:extLst>
-                            </p:cNvPr>
-                            <p:cNvPicPr/>
-                            <p:nvPr/>
-                          </p:nvPicPr>
-                          <p:blipFill>
-                            <a:blip r:embed="rId3"/>
-                            <a:stretch>
-                              <a:fillRect/>
-                            </a:stretch>
-                          </p:blipFill>
-                          <p:spPr>
-                            <a:xfrm>
-                              <a:off x="511553" y="3272968"/>
-                              <a:ext cx="2103853" cy="934350"/>
-                            </a:xfrm>
-                            <a:prstGeom prst="rect">
-                              <a:avLst/>
-                            </a:prstGeom>
-                          </p:spPr>
-                        </p:pic>
-                      </p:oleObj>
-                    </mc:Fallback>
-                  </mc:AlternateContent>
-                </a:graphicData>
-              </a:graphic>
-            </p:graphicFrame>
-          </mc:Choice>
-          <mc:Fallback>
-            <p:graphicFrame>
-              <p:nvGraphicFramePr>
-                <p:cNvPr id="13" name="개체 12">
-                  <a:extLst>
-                    <a:ext uri="{FF2B5EF4-FFF2-40B4-BE49-F238E27FC236}">
-                      <a16:creationId xmlns:a16="http://schemas.microsoft.com/office/drawing/2014/main" id="{6AC9440F-C5AD-60BD-76BA-02333CC9AE98}"/>
-                    </a:ext>
-                  </a:extLst>
-                </p:cNvPr>
-                <p:cNvGraphicFramePr>
-                  <a:graphicFrameLocks noChangeAspect="1"/>
-                </p:cNvGraphicFramePr>
-                <p:nvPr>
-                  <p:extLst>
-                    <p:ext uri="{D42A27DB-BD31-4B8C-83A1-F6EECF244321}">
-                      <p14:modId xmlns:p14="http://schemas.microsoft.com/office/powerpoint/2010/main" val="1955687265"/>
-                    </p:ext>
-                  </p:extLst>
-                </p:nvPr>
-              </p:nvGraphicFramePr>
-              <p:xfrm>
-                <a:off x="511553" y="3272968"/>
-                <a:ext cx="2103853" cy="934350"/>
-              </p:xfrm>
-              <a:graphic>
-                <a:graphicData uri="http://schemas.openxmlformats.org/presentationml/2006/ole">
-                  <mc:AlternateContent>
-                    <mc:Choice xmlns:v="urn:schemas-microsoft-com:vml" Requires="v">
-                      <p:oleObj name="Graph" r:id="rId2" imgW="3734796" imgH="1658983" progId="Origin50.Graph">
-                        <p:embed/>
-                      </p:oleObj>
-                    </mc:Choice>
-                    <mc:Fallback>
-                      <p:oleObj name="Graph" r:id="rId2" imgW="3734796" imgH="1658983" progId="Origin50.Graph">
-                        <p:embed/>
-                        <p:pic>
-                          <p:nvPicPr>
-                            <p:cNvPr id="40" name="개체 39">
-                              <a:extLst>
-                                <a:ext uri="{FF2B5EF4-FFF2-40B4-BE49-F238E27FC236}">
-                                  <a16:creationId xmlns:a16="http://schemas.microsoft.com/office/drawing/2014/main" id="{B82BFF56-A925-DA85-07B6-9932B4911FA6}"/>
-                                </a:ext>
-                              </a:extLst>
-                            </p:cNvPr>
-                            <p:cNvPicPr/>
-                            <p:nvPr/>
-                          </p:nvPicPr>
-                          <p:blipFill>
-                            <a:blip r:embed="rId3"/>
-                            <a:stretch>
-                              <a:fillRect/>
-                            </a:stretch>
-                          </p:blipFill>
-                          <p:spPr>
-                            <a:xfrm>
-                              <a:off x="511553" y="3272968"/>
-                              <a:ext cx="2103853" cy="934350"/>
-                            </a:xfrm>
-                            <a:prstGeom prst="rect">
-                              <a:avLst/>
-                            </a:prstGeom>
-                          </p:spPr>
-                        </p:pic>
-                      </p:oleObj>
-                    </mc:Fallback>
-                  </mc:AlternateContent>
-                </a:graphicData>
-              </a:graphic>
-            </p:graphicFrame>
-          </mc:Fallback>
-        </mc:AlternateContent>
-        <mc:AlternateContent xmlns:mc="http://schemas.openxmlformats.org/markup-compatibility/2006">
-          <mc:Choice xmlns:a14="http://schemas.microsoft.com/office/drawing/2010/main" Requires="a14">
-            <p:graphicFrame>
-              <p:nvGraphicFramePr>
-                <p:cNvPr id="18" name="개체 17">
-                  <a:extLst>
-                    <a:ext uri="{FF2B5EF4-FFF2-40B4-BE49-F238E27FC236}">
-                      <a16:creationId xmlns:a16="http://schemas.microsoft.com/office/drawing/2014/main" id="{38A4FE96-2DD0-F05D-A835-0E3D60A3FD29}"/>
-                    </a:ext>
-                  </a:extLst>
-                </p:cNvPr>
-                <p:cNvGraphicFramePr>
-                  <a:graphicFrameLocks noChangeAspect="1"/>
-                </p:cNvGraphicFramePr>
-                <p:nvPr>
-                  <p:extLst>
-                    <p:ext uri="{D42A27DB-BD31-4B8C-83A1-F6EECF244321}">
-                      <p14:modId xmlns:p14="http://schemas.microsoft.com/office/powerpoint/2010/main" val="80173979"/>
-                    </p:ext>
-                  </p:extLst>
-                </p:nvPr>
-              </p:nvGraphicFramePr>
-              <p:xfrm>
-                <a:off x="2074423" y="3272968"/>
-                <a:ext cx="2103854" cy="934351"/>
-              </p:xfrm>
-              <a:graphic>
-                <a:graphicData uri="http://schemas.openxmlformats.org/presentationml/2006/ole">
-                  <mc:AlternateContent>
-                    <mc:Choice xmlns:v="urn:schemas-microsoft-com:vml" Requires="v">
-                      <p:oleObj name="Graph" r:id="rId4" imgW="3734796" imgH="1658983" progId="Origin50.Graph">
-                        <p:embed/>
-                      </p:oleObj>
-                    </mc:Choice>
-                    <mc:Fallback>
-                      <p:oleObj name="Graph" r:id="rId4" imgW="3734796" imgH="1658983" progId="Origin50.Graph">
-                        <p:embed/>
-                        <p:pic>
-                          <p:nvPicPr>
-                            <p:cNvPr id="59" name="개체 58">
-                              <a:extLst>
-                                <a:ext uri="{FF2B5EF4-FFF2-40B4-BE49-F238E27FC236}">
-                                  <a16:creationId xmlns:a16="http://schemas.microsoft.com/office/drawing/2014/main" id="{AAA9C498-6D1C-7684-C5AD-8C0784B709E5}"/>
-                                </a:ext>
-                              </a:extLst>
-                            </p:cNvPr>
-                            <p:cNvPicPr/>
-                            <p:nvPr/>
-                          </p:nvPicPr>
-                          <p:blipFill>
-                            <a:blip r:embed="rId5"/>
-                            <a:stretch>
-                              <a:fillRect/>
-                            </a:stretch>
-                          </p:blipFill>
-                          <p:spPr>
-                            <a:xfrm>
-                              <a:off x="2074423" y="3272968"/>
-                              <a:ext cx="2103854" cy="934351"/>
-                            </a:xfrm>
-                            <a:prstGeom prst="rect">
-                              <a:avLst/>
-                            </a:prstGeom>
-                          </p:spPr>
-                        </p:pic>
-                      </p:oleObj>
-                    </mc:Fallback>
-                  </mc:AlternateContent>
-                </a:graphicData>
-              </a:graphic>
-            </p:graphicFrame>
-          </mc:Choice>
-          <mc:Fallback>
-            <p:graphicFrame>
-              <p:nvGraphicFramePr>
-                <p:cNvPr id="18" name="개체 17">
-                  <a:extLst>
-                    <a:ext uri="{FF2B5EF4-FFF2-40B4-BE49-F238E27FC236}">
-                      <a16:creationId xmlns:a16="http://schemas.microsoft.com/office/drawing/2014/main" id="{38A4FE96-2DD0-F05D-A835-0E3D60A3FD29}"/>
-                    </a:ext>
-                  </a:extLst>
-                </p:cNvPr>
-                <p:cNvGraphicFramePr>
-                  <a:graphicFrameLocks noChangeAspect="1"/>
-                </p:cNvGraphicFramePr>
-                <p:nvPr>
-                  <p:extLst>
-                    <p:ext uri="{D42A27DB-BD31-4B8C-83A1-F6EECF244321}">
-                      <p14:modId xmlns:p14="http://schemas.microsoft.com/office/powerpoint/2010/main" val="80173979"/>
-                    </p:ext>
-                  </p:extLst>
-                </p:nvPr>
-              </p:nvGraphicFramePr>
-              <p:xfrm>
-                <a:off x="2074423" y="3272968"/>
-                <a:ext cx="2103854" cy="934351"/>
-              </p:xfrm>
-              <a:graphic>
-                <a:graphicData uri="http://schemas.openxmlformats.org/presentationml/2006/ole">
-                  <mc:AlternateContent>
-                    <mc:Choice xmlns:v="urn:schemas-microsoft-com:vml" Requires="v">
-                      <p:oleObj name="Graph" r:id="rId4" imgW="3734796" imgH="1658983" progId="Origin50.Graph">
-                        <p:embed/>
-                      </p:oleObj>
-                    </mc:Choice>
-                    <mc:Fallback>
-                      <p:oleObj name="Graph" r:id="rId4" imgW="3734796" imgH="1658983" progId="Origin50.Graph">
-                        <p:embed/>
-                        <p:pic>
-                          <p:nvPicPr>
-                            <p:cNvPr id="59" name="개체 58">
-                              <a:extLst>
-                                <a:ext uri="{FF2B5EF4-FFF2-40B4-BE49-F238E27FC236}">
-                                  <a16:creationId xmlns:a16="http://schemas.microsoft.com/office/drawing/2014/main" id="{AAA9C498-6D1C-7684-C5AD-8C0784B709E5}"/>
-                                </a:ext>
-                              </a:extLst>
-                            </p:cNvPr>
-                            <p:cNvPicPr/>
-                            <p:nvPr/>
-                          </p:nvPicPr>
-                          <p:blipFill>
-                            <a:blip r:embed="rId5"/>
-                            <a:stretch>
-                              <a:fillRect/>
-                            </a:stretch>
-                          </p:blipFill>
-                          <p:spPr>
-                            <a:xfrm>
-                              <a:off x="2074423" y="3272968"/>
-                              <a:ext cx="2103854" cy="934351"/>
-                            </a:xfrm>
-                            <a:prstGeom prst="rect">
-                              <a:avLst/>
-                            </a:prstGeom>
-                          </p:spPr>
-                        </p:pic>
-                      </p:oleObj>
-                    </mc:Fallback>
-                  </mc:AlternateContent>
-                </a:graphicData>
-              </a:graphic>
-            </p:graphicFrame>
-          </mc:Fallback>
-        </mc:AlternateContent>
-        <p:grpSp>
-          <p:nvGrpSpPr>
-            <p:cNvPr id="20" name="그룹 19">
-              <a:extLst>
-                <a:ext uri="{FF2B5EF4-FFF2-40B4-BE49-F238E27FC236}">
-                  <a16:creationId xmlns:a16="http://schemas.microsoft.com/office/drawing/2014/main" id="{B8A5221D-6752-873F-CA5E-2A71B0194928}"/>
-                </a:ext>
-              </a:extLst>
-            </p:cNvPr>
-            <p:cNvGrpSpPr/>
-            <p:nvPr/>
-          </p:nvGrpSpPr>
-          <p:grpSpPr>
-            <a:xfrm>
-              <a:off x="731225" y="2274767"/>
-              <a:ext cx="1666810" cy="645935"/>
-              <a:chOff x="515733" y="569954"/>
-              <a:chExt cx="1666810" cy="645935"/>
-            </a:xfrm>
-          </p:grpSpPr>
-          <p:pic>
-            <p:nvPicPr>
-              <p:cNvPr id="44" name="그림 43">
+          <a:prstGeom prst="rect">
+            <a:avLst/>
+          </a:prstGeom>
+        </p:spPr>
+      </p:pic>
+      <mc:AlternateContent xmlns:mc="http://schemas.openxmlformats.org/markup-compatibility/2006">
+        <mc:Choice xmlns:a14="http://schemas.microsoft.com/office/drawing/2010/main" Requires="a14">
+          <p:sp>
+            <p:nvSpPr>
+              <p:cNvPr id="48" name="TextBox 47">
                 <a:extLst>
                   <a:ext uri="{FF2B5EF4-FFF2-40B4-BE49-F238E27FC236}">
-                    <a16:creationId xmlns:a16="http://schemas.microsoft.com/office/drawing/2014/main" id="{4282FAFB-AA49-AD36-3C4A-B91AF8250FAB}"/>
+                    <a16:creationId xmlns:a16="http://schemas.microsoft.com/office/drawing/2014/main" id="{9936A054-741E-5A88-B947-E2F034B54283}"/>
                   </a:ext>
                 </a:extLst>
               </p:cNvPr>
-              <p:cNvPicPr>
-                <a:picLocks noChangeAspect="1"/>
-              </p:cNvPicPr>
+              <p:cNvSpPr txBox="1"/>
               <p:nvPr/>
-            </p:nvPicPr>
-            <p:blipFill>
-              <a:blip r:embed="rId6"/>
-              <a:stretch>
-                <a:fillRect/>
-              </a:stretch>
-            </p:blipFill>
+            </p:nvSpPr>
             <p:spPr>
               <a:xfrm>
-                <a:off x="515733" y="569954"/>
-                <a:ext cx="1666810" cy="645935"/>
+                <a:off x="1113954" y="2679184"/>
+                <a:ext cx="931985" cy="227370"/>
               </a:xfrm>
               <a:prstGeom prst="rect">
                 <a:avLst/>
               </a:prstGeom>
+              <a:noFill/>
             </p:spPr>
-          </p:pic>
-          <mc:AlternateContent xmlns:mc="http://schemas.openxmlformats.org/markup-compatibility/2006" xmlns:a14="http://schemas.microsoft.com/office/drawing/2010/main">
-            <mc:Choice Requires="a14">
-              <p:sp>
-                <p:nvSpPr>
-                  <p:cNvPr id="48" name="TextBox 47">
-                    <a:extLst>
-                      <a:ext uri="{FF2B5EF4-FFF2-40B4-BE49-F238E27FC236}">
-                        <a16:creationId xmlns:a16="http://schemas.microsoft.com/office/drawing/2014/main" id="{9936A054-741E-5A88-B947-E2F034B54283}"/>
-                      </a:ext>
-                    </a:extLst>
-                  </p:cNvPr>
-                  <p:cNvSpPr txBox="1"/>
-                  <p:nvPr/>
-                </p:nvSpPr>
-                <p:spPr>
-                  <a:xfrm>
-                    <a:off x="898462" y="974371"/>
-                    <a:ext cx="931985" cy="227370"/>
-                  </a:xfrm>
-                  <a:prstGeom prst="rect">
-                    <a:avLst/>
-                  </a:prstGeom>
-                  <a:noFill/>
-                </p:spPr>
-                <p:txBody>
-                  <a:bodyPr wrap="none" lIns="0" tIns="0" rIns="0" bIns="0" rtlCol="0">
-                    <a:spAutoFit/>
-                  </a:bodyPr>
-                  <a:lstStyle/>
-                  <a:p>
-                    <a:pPr/>
-                    <a14:m>
-                      <m:oMathPara xmlns:m="http://schemas.openxmlformats.org/officeDocument/2006/math">
-                        <m:oMathParaPr>
-                          <m:jc m:val="centerGroup"/>
-                        </m:oMathParaPr>
-                        <m:oMath xmlns:m="http://schemas.openxmlformats.org/officeDocument/2006/math">
+            <p:txBody>
+              <a:bodyPr wrap="none" lIns="0" tIns="0" rIns="0" bIns="0" rtlCol="0">
+                <a:spAutoFit/>
+              </a:bodyPr>
+              <a:lstStyle/>
+              <a:p>
+                <a:pPr/>
+                <a14:m>
+                  <m:oMathPara xmlns:m="http://schemas.openxmlformats.org/officeDocument/2006/math">
+                    <m:oMathParaPr>
+                      <m:jc m:val="centerGroup"/>
+                    </m:oMathParaPr>
+                    <m:oMath xmlns:m="http://schemas.openxmlformats.org/officeDocument/2006/math">
+                      <m:sSub>
+                        <m:sSubPr>
+                          <m:ctrlPr>
+                            <a:rPr lang="en-US" altLang="ko-KR" sz="1100" b="0" i="1" smtClean="0">
+                              <a:latin typeface="Cambria Math" panose="02040503050406030204" pitchFamily="18" charset="0"/>
+                            </a:rPr>
+                          </m:ctrlPr>
+                        </m:sSubPr>
+                        <m:e>
+                          <m:r>
+                            <a:rPr lang="en-US" altLang="ko-KR" sz="1100" b="0" i="1" smtClean="0">
+                              <a:latin typeface="Cambria Math" panose="02040503050406030204" pitchFamily="18" charset="0"/>
+                            </a:rPr>
+                            <m:t>𝑒</m:t>
+                          </m:r>
+                        </m:e>
+                        <m:sub>
+                          <m:r>
+                            <a:rPr lang="en-US" altLang="ko-KR" sz="1100" b="0" i="1" smtClean="0">
+                              <a:latin typeface="Cambria Math" panose="02040503050406030204" pitchFamily="18" charset="0"/>
+                            </a:rPr>
+                            <m:t>𝑛</m:t>
+                          </m:r>
+                        </m:sub>
+                      </m:sSub>
+                      <m:r>
+                        <a:rPr lang="en-US" altLang="ko-KR" sz="1100" b="0" i="1" smtClean="0">
+                          <a:latin typeface="Cambria Math" panose="02040503050406030204" pitchFamily="18" charset="0"/>
+                        </a:rPr>
+                        <m:t>, </m:t>
+                      </m:r>
+                      <m:sSub>
+                        <m:sSubPr>
+                          <m:ctrlPr>
+                            <a:rPr lang="en-US" altLang="ko-KR" sz="1100" b="0" i="1" smtClean="0">
+                              <a:latin typeface="Cambria Math" panose="02040503050406030204" pitchFamily="18" charset="0"/>
+                            </a:rPr>
+                          </m:ctrlPr>
+                        </m:sSubPr>
+                        <m:e>
+                          <m:r>
+                            <a:rPr lang="en-US" altLang="ko-KR" sz="1100" b="0" i="1" smtClean="0">
+                              <a:latin typeface="Cambria Math" panose="02040503050406030204" pitchFamily="18" charset="0"/>
+                            </a:rPr>
+                            <m:t>𝑐</m:t>
+                          </m:r>
+                        </m:e>
+                        <m:sub>
+                          <m:r>
+                            <a:rPr lang="en-US" altLang="ko-KR" sz="1100" b="0" i="1" smtClean="0">
+                              <a:latin typeface="Cambria Math" panose="02040503050406030204" pitchFamily="18" charset="0"/>
+                            </a:rPr>
+                            <m:t>𝑛</m:t>
+                          </m:r>
+                        </m:sub>
+                      </m:sSub>
+                      <m:r>
+                        <a:rPr lang="en-US" altLang="ko-KR" sz="1100" b="0" i="1" smtClean="0">
+                          <a:latin typeface="Cambria Math" panose="02040503050406030204" pitchFamily="18" charset="0"/>
+                        </a:rPr>
+                        <m:t> </m:t>
+                      </m:r>
+                      <m:groupChr>
+                        <m:groupChrPr>
+                          <m:chr m:val="→"/>
+                          <m:vertJc m:val="bot"/>
+                          <m:ctrlPr>
+                            <a:rPr lang="el-GR" altLang="ko-KR" sz="1100" b="0" i="1" smtClean="0">
+                              <a:latin typeface="Cambria Math" panose="02040503050406030204" pitchFamily="18" charset="0"/>
+                            </a:rPr>
+                          </m:ctrlPr>
+                        </m:groupChrPr>
+                        <m:e>
                           <m:sSub>
                             <m:sSubPr>
                               <m:ctrlPr>
@@ -13104,7 +12987,7 @@
                                 <a:rPr lang="en-US" altLang="ko-KR" sz="1100" b="0" i="1" smtClean="0">
                                   <a:latin typeface="Cambria Math" panose="02040503050406030204" pitchFamily="18" charset="0"/>
                                 </a:rPr>
-                                <m:t>𝑒</m:t>
+                                <m:t>𝜎</m:t>
                               </m:r>
                             </m:e>
                             <m:sub>
@@ -13120,590 +13003,473 @@
                             <a:rPr lang="en-US" altLang="ko-KR" sz="1100" b="0" i="1" smtClean="0">
                               <a:latin typeface="Cambria Math" panose="02040503050406030204" pitchFamily="18" charset="0"/>
                             </a:rPr>
-                            <m:t>, </m:t>
+                            <m:t> ≈  0</m:t>
                           </m:r>
-                          <m:sSub>
-                            <m:sSubPr>
-                              <m:ctrlPr>
-                                <a:rPr lang="en-US" altLang="ko-KR" sz="1100" b="0" i="1" smtClean="0">
-                                  <a:latin typeface="Cambria Math" panose="02040503050406030204" pitchFamily="18" charset="0"/>
-                                </a:rPr>
-                              </m:ctrlPr>
-                            </m:sSubPr>
-                            <m:e>
-                              <m:r>
-                                <a:rPr lang="en-US" altLang="ko-KR" sz="1100" b="0" i="1" smtClean="0">
-                                  <a:latin typeface="Cambria Math" panose="02040503050406030204" pitchFamily="18" charset="0"/>
-                                </a:rPr>
-                                <m:t>𝑐</m:t>
-                              </m:r>
-                            </m:e>
-                            <m:sub>
-                              <m:r>
-                                <a:rPr lang="en-US" altLang="ko-KR" sz="1100" b="0" i="1" smtClean="0">
-                                  <a:latin typeface="Cambria Math" panose="02040503050406030204" pitchFamily="18" charset="0"/>
-                                </a:rPr>
-                                <m:t>𝑛</m:t>
-                              </m:r>
-                            </m:sub>
-                          </m:sSub>
-                          <m:r>
-                            <a:rPr lang="en-US" altLang="ko-KR" sz="1100" b="0" i="1" smtClean="0">
-                              <a:latin typeface="Cambria Math" panose="02040503050406030204" pitchFamily="18" charset="0"/>
-                            </a:rPr>
-                            <m:t> </m:t>
-                          </m:r>
-                          <m:groupChr>
-                            <m:groupChrPr>
-                              <m:chr m:val="→"/>
-                              <m:vertJc m:val="bot"/>
-                              <m:ctrlPr>
-                                <a:rPr lang="el-GR" altLang="ko-KR" sz="1100" b="0" i="1" smtClean="0">
-                                  <a:latin typeface="Cambria Math" panose="02040503050406030204" pitchFamily="18" charset="0"/>
-                                </a:rPr>
-                              </m:ctrlPr>
-                            </m:groupChrPr>
-                            <m:e>
-                              <m:sSub>
-                                <m:sSubPr>
-                                  <m:ctrlPr>
-                                    <a:rPr lang="en-US" altLang="ko-KR" sz="1100" b="0" i="1" smtClean="0">
-                                      <a:latin typeface="Cambria Math" panose="02040503050406030204" pitchFamily="18" charset="0"/>
-                                    </a:rPr>
-                                  </m:ctrlPr>
-                                </m:sSubPr>
-                                <m:e>
-                                  <m:r>
-                                    <a:rPr lang="en-US" altLang="ko-KR" sz="1100" b="0" i="1" smtClean="0">
-                                      <a:latin typeface="Cambria Math" panose="02040503050406030204" pitchFamily="18" charset="0"/>
-                                    </a:rPr>
-                                    <m:t>𝜎</m:t>
-                                  </m:r>
-                                </m:e>
-                                <m:sub>
-                                  <m:r>
-                                    <a:rPr lang="en-US" altLang="ko-KR" sz="1100" b="0" i="1" smtClean="0">
-                                      <a:latin typeface="Cambria Math" panose="02040503050406030204" pitchFamily="18" charset="0"/>
-                                    </a:rPr>
-                                    <m:t>𝑛</m:t>
-                                  </m:r>
-                                </m:sub>
-                              </m:sSub>
-                              <m:r>
-                                <a:rPr lang="en-US" altLang="ko-KR" sz="1100" b="0" i="1" smtClean="0">
-                                  <a:latin typeface="Cambria Math" panose="02040503050406030204" pitchFamily="18" charset="0"/>
-                                </a:rPr>
-                                <m:t> ≈  0</m:t>
-                              </m:r>
-                            </m:e>
-                          </m:groupChr>
-                          <m:r>
-                            <a:rPr lang="en-US" altLang="ko-KR" sz="1100" b="0" i="1" smtClean="0">
-                              <a:latin typeface="Cambria Math" panose="02040503050406030204" pitchFamily="18" charset="0"/>
-                            </a:rPr>
-                            <m:t>  0 </m:t>
-                          </m:r>
-                        </m:oMath>
-                      </m:oMathPara>
-                    </a14:m>
-                    <a:endParaRPr lang="ko-KR" altLang="en-US" sz="1100"/>
-                  </a:p>
-                </p:txBody>
-              </p:sp>
-            </mc:Choice>
-            <mc:Fallback xmlns="">
-              <p:sp>
-                <p:nvSpPr>
-                  <p:cNvPr id="73" name="TextBox 72">
-                    <a:extLst>
-                      <a:ext uri="{FF2B5EF4-FFF2-40B4-BE49-F238E27FC236}">
-                        <a16:creationId xmlns:a16="http://schemas.microsoft.com/office/drawing/2014/main" id="{854BD329-6770-395B-E632-D4FBC6D33D13}"/>
-                      </a:ext>
-                    </a:extLst>
-                  </p:cNvPr>
-                  <p:cNvSpPr txBox="1">
-                    <a:spLocks noRot="1" noChangeAspect="1" noMove="1" noResize="1" noEditPoints="1" noAdjustHandles="1" noChangeArrowheads="1" noChangeShapeType="1" noTextEdit="1"/>
-                  </p:cNvSpPr>
-                  <p:nvPr/>
-                </p:nvSpPr>
-                <p:spPr>
-                  <a:xfrm>
-                    <a:off x="898462" y="974371"/>
-                    <a:ext cx="931985" cy="227370"/>
-                  </a:xfrm>
-                  <a:prstGeom prst="rect">
-                    <a:avLst/>
-                  </a:prstGeom>
-                  <a:blipFill>
-                    <a:blip r:embed="rId9"/>
-                    <a:stretch>
-                      <a:fillRect l="-1961" t="-2632" b="-7895"/>
-                    </a:stretch>
-                  </a:blipFill>
-                </p:spPr>
-                <p:txBody>
-                  <a:bodyPr/>
-                  <a:lstStyle/>
-                  <a:p>
-                    <a:r>
-                      <a:rPr lang="ko-KR" altLang="en-US">
-                        <a:noFill/>
-                      </a:rPr>
-                      <a:t> </a:t>
-                    </a:r>
-                  </a:p>
-                </p:txBody>
-              </p:sp>
-            </mc:Fallback>
-          </mc:AlternateContent>
-        </p:grpSp>
-        <p:grpSp>
-          <p:nvGrpSpPr>
-            <p:cNvPr id="88" name="그룹 87">
-              <a:extLst>
-                <a:ext uri="{FF2B5EF4-FFF2-40B4-BE49-F238E27FC236}">
-                  <a16:creationId xmlns:a16="http://schemas.microsoft.com/office/drawing/2014/main" id="{AFFEBEDD-7506-6F52-A23E-C3627BA4F79D}"/>
-                </a:ext>
-              </a:extLst>
-            </p:cNvPr>
-            <p:cNvGrpSpPr/>
-            <p:nvPr/>
-          </p:nvGrpSpPr>
-          <p:grpSpPr>
-            <a:xfrm>
-              <a:off x="2567781" y="1946711"/>
-              <a:ext cx="1427212" cy="1302046"/>
-              <a:chOff x="2293570" y="4444842"/>
-              <a:chExt cx="1427212" cy="1302046"/>
-            </a:xfrm>
-          </p:grpSpPr>
-          <p:grpSp>
-            <p:nvGrpSpPr>
-              <p:cNvPr id="94" name="그룹 93">
+                        </m:e>
+                      </m:groupChr>
+                      <m:r>
+                        <a:rPr lang="en-US" altLang="ko-KR" sz="1100" b="0" i="1" smtClean="0">
+                          <a:latin typeface="Cambria Math" panose="02040503050406030204" pitchFamily="18" charset="0"/>
+                        </a:rPr>
+                        <m:t>  0 </m:t>
+                      </m:r>
+                    </m:oMath>
+                  </m:oMathPara>
+                </a14:m>
+                <a:endParaRPr lang="ko-KR" altLang="en-US" sz="1100"/>
+              </a:p>
+            </p:txBody>
+          </p:sp>
+        </mc:Choice>
+        <mc:Fallback>
+          <p:sp>
+            <p:nvSpPr>
+              <p:cNvPr id="48" name="TextBox 47">
                 <a:extLst>
                   <a:ext uri="{FF2B5EF4-FFF2-40B4-BE49-F238E27FC236}">
-                    <a16:creationId xmlns:a16="http://schemas.microsoft.com/office/drawing/2014/main" id="{606143E8-D382-CE4B-5ED2-163BD536DB88}"/>
+                    <a16:creationId xmlns:a16="http://schemas.microsoft.com/office/drawing/2014/main" id="{9936A054-741E-5A88-B947-E2F034B54283}"/>
                   </a:ext>
                 </a:extLst>
               </p:cNvPr>
-              <p:cNvGrpSpPr/>
-              <p:nvPr/>
-            </p:nvGrpSpPr>
-            <p:grpSpPr>
-              <a:xfrm>
-                <a:off x="2293570" y="4483747"/>
-                <a:ext cx="1427212" cy="1263141"/>
-                <a:chOff x="1174020" y="3383995"/>
-                <a:chExt cx="1801766" cy="1432203"/>
-              </a:xfrm>
-            </p:grpSpPr>
-            <p:pic>
-              <p:nvPicPr>
-                <p:cNvPr id="96" name="그림 95">
-                  <a:extLst>
-                    <a:ext uri="{FF2B5EF4-FFF2-40B4-BE49-F238E27FC236}">
-                      <a16:creationId xmlns:a16="http://schemas.microsoft.com/office/drawing/2014/main" id="{06CCD864-6038-980B-4C40-2DA75DFC297B}"/>
-                    </a:ext>
-                  </a:extLst>
-                </p:cNvPr>
-                <p:cNvPicPr>
-                  <a:picLocks noChangeAspect="1"/>
-                </p:cNvPicPr>
-                <p:nvPr/>
-              </p:nvPicPr>
-              <p:blipFill>
-                <a:blip r:embed="rId10"/>
-                <a:stretch>
-                  <a:fillRect/>
-                </a:stretch>
-              </p:blipFill>
-              <p:spPr>
-                <a:xfrm rot="10800000">
-                  <a:off x="1258823" y="3383995"/>
-                  <a:ext cx="1716963" cy="1344713"/>
-                </a:xfrm>
-                <a:prstGeom prst="rect">
-                  <a:avLst/>
-                </a:prstGeom>
-              </p:spPr>
-            </p:pic>
-            <p:sp>
-              <p:nvSpPr>
-                <p:cNvPr id="97" name="TextBox 96">
-                  <a:extLst>
-                    <a:ext uri="{FF2B5EF4-FFF2-40B4-BE49-F238E27FC236}">
-                      <a16:creationId xmlns:a16="http://schemas.microsoft.com/office/drawing/2014/main" id="{15F6B149-641F-E0D1-B723-77BA50026BD2}"/>
-                    </a:ext>
-                  </a:extLst>
-                </p:cNvPr>
-                <p:cNvSpPr txBox="1"/>
-                <p:nvPr/>
-              </p:nvSpPr>
-              <p:spPr>
-                <a:xfrm>
-                  <a:off x="1234144" y="3548667"/>
-                  <a:ext cx="536575" cy="271984"/>
-                </a:xfrm>
-                <a:prstGeom prst="rect">
-                  <a:avLst/>
-                </a:prstGeom>
-                <a:noFill/>
-              </p:spPr>
-              <p:txBody>
-                <a:bodyPr wrap="square" rtlCol="0">
-                  <a:spAutoFit/>
-                </a:bodyPr>
-                <a:lstStyle/>
-                <a:p>
-                  <a:r>
-                    <a:rPr lang="en-US" altLang="ko-KR" sz="800" b="1">
-                      <a:solidFill>
-                        <a:schemeClr val="bg1"/>
-                      </a:solidFill>
-                    </a:rPr>
-                    <a:t>BOX</a:t>
-                  </a:r>
-                  <a:endParaRPr lang="ko-KR" altLang="en-US" sz="800" b="1">
-                    <a:solidFill>
-                      <a:schemeClr val="bg1"/>
-                    </a:solidFill>
-                  </a:endParaRPr>
-                </a:p>
-              </p:txBody>
-            </p:sp>
-            <p:sp>
-              <p:nvSpPr>
-                <p:cNvPr id="98" name="TextBox 97">
-                  <a:extLst>
-                    <a:ext uri="{FF2B5EF4-FFF2-40B4-BE49-F238E27FC236}">
-                      <a16:creationId xmlns:a16="http://schemas.microsoft.com/office/drawing/2014/main" id="{9F58AB1A-B0C1-652D-C4FD-D08153ECDBAC}"/>
-                    </a:ext>
-                  </a:extLst>
-                </p:cNvPr>
-                <p:cNvSpPr txBox="1"/>
-                <p:nvPr/>
-              </p:nvSpPr>
-              <p:spPr>
-                <a:xfrm>
-                  <a:off x="1241982" y="3935791"/>
-                  <a:ext cx="536575" cy="271984"/>
-                </a:xfrm>
-                <a:prstGeom prst="rect">
-                  <a:avLst/>
-                </a:prstGeom>
-                <a:noFill/>
-              </p:spPr>
-              <p:txBody>
-                <a:bodyPr wrap="square" rtlCol="0">
-                  <a:spAutoFit/>
-                </a:bodyPr>
-                <a:lstStyle/>
-                <a:p>
-                  <a:r>
-                    <a:rPr lang="en-US" altLang="ko-KR" sz="800" b="1"/>
-                    <a:t>CTN</a:t>
-                  </a:r>
-                  <a:endParaRPr lang="ko-KR" altLang="en-US" sz="800" b="1"/>
-                </a:p>
-              </p:txBody>
-            </p:sp>
-            <p:sp>
-              <p:nvSpPr>
-                <p:cNvPr id="99" name="TextBox 98">
-                  <a:extLst>
-                    <a:ext uri="{FF2B5EF4-FFF2-40B4-BE49-F238E27FC236}">
-                      <a16:creationId xmlns:a16="http://schemas.microsoft.com/office/drawing/2014/main" id="{3CCBA7F1-4869-89F8-ABA4-C607790A6490}"/>
-                    </a:ext>
-                  </a:extLst>
-                </p:cNvPr>
-                <p:cNvSpPr txBox="1"/>
-                <p:nvPr/>
-              </p:nvSpPr>
-              <p:spPr>
-                <a:xfrm>
-                  <a:off x="1174020" y="4544214"/>
-                  <a:ext cx="903514" cy="271984"/>
-                </a:xfrm>
-                <a:prstGeom prst="rect">
-                  <a:avLst/>
-                </a:prstGeom>
-                <a:noFill/>
-              </p:spPr>
-              <p:txBody>
-                <a:bodyPr wrap="square" rtlCol="0">
-                  <a:spAutoFit/>
-                </a:bodyPr>
-                <a:lstStyle/>
-                <a:p>
-                  <a:r>
-                    <a:rPr lang="en-US" altLang="ko-KR" sz="800" b="1">
-                      <a:solidFill>
-                        <a:schemeClr val="bg1"/>
-                      </a:solidFill>
-                    </a:rPr>
-                    <a:t>Si-Channel</a:t>
-                  </a:r>
-                  <a:endParaRPr lang="ko-KR" altLang="en-US" sz="800" b="1">
-                    <a:solidFill>
-                      <a:schemeClr val="bg1"/>
-                    </a:solidFill>
-                  </a:endParaRPr>
-                </a:p>
-              </p:txBody>
-            </p:sp>
-            <p:sp>
-              <p:nvSpPr>
-                <p:cNvPr id="102" name="TextBox 101">
-                  <a:extLst>
-                    <a:ext uri="{FF2B5EF4-FFF2-40B4-BE49-F238E27FC236}">
-                      <a16:creationId xmlns:a16="http://schemas.microsoft.com/office/drawing/2014/main" id="{CF459982-B00F-7371-E60D-5659013439FB}"/>
-                    </a:ext>
-                  </a:extLst>
-                </p:cNvPr>
-                <p:cNvSpPr txBox="1"/>
-                <p:nvPr/>
-              </p:nvSpPr>
-              <p:spPr>
-                <a:xfrm>
-                  <a:off x="1801017" y="4309197"/>
-                  <a:ext cx="597639" cy="226831"/>
-                </a:xfrm>
-                <a:prstGeom prst="rect">
-                  <a:avLst/>
-                </a:prstGeom>
-                <a:noFill/>
-              </p:spPr>
-              <p:txBody>
-                <a:bodyPr wrap="square" rtlCol="0">
-                  <a:spAutoFit/>
-                </a:bodyPr>
-                <a:lstStyle/>
-                <a:p>
-                  <a:pPr algn="ctr"/>
-                  <a:r>
-                    <a:rPr lang="en-US" altLang="ko-KR" sz="700" b="1"/>
-                    <a:t>BETOX</a:t>
-                  </a:r>
-                  <a:endParaRPr lang="ko-KR" altLang="en-US" sz="700" b="1"/>
-                </a:p>
-              </p:txBody>
-            </p:sp>
-          </p:grpSp>
-          <p:sp>
-            <p:nvSpPr>
-              <p:cNvPr id="95" name="TextBox 94">
-                <a:extLst>
-                  <a:ext uri="{FF2B5EF4-FFF2-40B4-BE49-F238E27FC236}">
-                    <a16:creationId xmlns:a16="http://schemas.microsoft.com/office/drawing/2014/main" id="{D7ECA9DE-DFF5-50AA-50AF-AFF14E9EFDB8}"/>
-                  </a:ext>
-                </a:extLst>
-              </p:cNvPr>
-              <p:cNvSpPr txBox="1"/>
+              <p:cNvSpPr txBox="1">
+                <a:spLocks noRot="1" noChangeAspect="1" noMove="1" noResize="1" noEditPoints="1" noAdjustHandles="1" noChangeArrowheads="1" noChangeShapeType="1" noTextEdit="1"/>
+              </p:cNvSpPr>
               <p:nvPr/>
             </p:nvSpPr>
             <p:spPr>
               <a:xfrm>
-                <a:off x="2824608" y="4444842"/>
-                <a:ext cx="425031" cy="215444"/>
+                <a:off x="1113954" y="2679184"/>
+                <a:ext cx="931985" cy="227370"/>
               </a:xfrm>
               <a:prstGeom prst="rect">
                 <a:avLst/>
               </a:prstGeom>
-              <a:noFill/>
+              <a:blipFill>
+                <a:blip r:embed="rId7"/>
+                <a:stretch>
+                  <a:fillRect l="-1961" t="-2632" b="-7895"/>
+                </a:stretch>
+              </a:blipFill>
             </p:spPr>
             <p:txBody>
-              <a:bodyPr wrap="square" rtlCol="0">
-                <a:spAutoFit/>
-              </a:bodyPr>
+              <a:bodyPr/>
               <a:lstStyle/>
               <a:p>
-                <a:pPr algn="ctr"/>
                 <a:r>
-                  <a:rPr lang="en-US" altLang="ko-KR" sz="800" b="1">
-                    <a:solidFill>
-                      <a:schemeClr val="bg1"/>
-                    </a:solidFill>
+                  <a:rPr lang="ko-KR" altLang="en-US">
+                    <a:noFill/>
                   </a:rPr>
-                  <a:t>WL</a:t>
+                  <a:t> </a:t>
                 </a:r>
-                <a:endParaRPr lang="ko-KR" altLang="en-US" sz="800" b="1">
-                  <a:solidFill>
-                    <a:schemeClr val="bg1"/>
-                  </a:solidFill>
-                </a:endParaRPr>
               </a:p>
             </p:txBody>
           </p:sp>
-        </p:grpSp>
-        <p:sp>
-          <p:nvSpPr>
-            <p:cNvPr id="104" name="TextBox 103">
-              <a:extLst>
-                <a:ext uri="{FF2B5EF4-FFF2-40B4-BE49-F238E27FC236}">
-                  <a16:creationId xmlns:a16="http://schemas.microsoft.com/office/drawing/2014/main" id="{F2B501C6-3BC8-DD9A-EBB8-690057069166}"/>
-                </a:ext>
-              </a:extLst>
-            </p:cNvPr>
-            <p:cNvSpPr txBox="1"/>
-            <p:nvPr/>
-          </p:nvSpPr>
-          <p:spPr>
-            <a:xfrm>
-              <a:off x="511553" y="1877894"/>
-              <a:ext cx="360492" cy="215444"/>
-            </a:xfrm>
-            <a:prstGeom prst="rect">
-              <a:avLst/>
-            </a:prstGeom>
-            <a:noFill/>
-          </p:spPr>
-          <p:txBody>
-            <a:bodyPr wrap="square" rtlCol="0">
-              <a:spAutoFit/>
-            </a:bodyPr>
-            <a:lstStyle/>
-            <a:p>
-              <a:r>
-                <a:rPr lang="en-US" altLang="ko-KR" sz="800" b="1">
-                  <a:latin typeface="Arial" panose="020B0604020202020204" pitchFamily="34" charset="0"/>
-                  <a:cs typeface="Arial" panose="020B0604020202020204" pitchFamily="34" charset="0"/>
-                </a:rPr>
-                <a:t>(a)</a:t>
-              </a:r>
-              <a:endParaRPr lang="ko-KR" altLang="en-US" sz="800" b="1">
+        </mc:Fallback>
+      </mc:AlternateContent>
+      <p:pic>
+        <p:nvPicPr>
+          <p:cNvPr id="96" name="그림 95">
+            <a:extLst>
+              <a:ext uri="{FF2B5EF4-FFF2-40B4-BE49-F238E27FC236}">
+                <a16:creationId xmlns:a16="http://schemas.microsoft.com/office/drawing/2014/main" id="{06CCD864-6038-980B-4C40-2DA75DFC297B}"/>
+              </a:ext>
+            </a:extLst>
+          </p:cNvPr>
+          <p:cNvPicPr>
+            <a:picLocks noChangeAspect="1"/>
+          </p:cNvPicPr>
+          <p:nvPr/>
+        </p:nvPicPr>
+        <p:blipFill>
+          <a:blip r:embed="rId8"/>
+          <a:stretch>
+            <a:fillRect/>
+          </a:stretch>
+        </p:blipFill>
+        <p:spPr>
+          <a:xfrm rot="10800000">
+            <a:off x="2634955" y="1985616"/>
+            <a:ext cx="1360038" cy="1185979"/>
+          </a:xfrm>
+          <a:prstGeom prst="rect">
+            <a:avLst/>
+          </a:prstGeom>
+        </p:spPr>
+      </p:pic>
+      <p:sp>
+        <p:nvSpPr>
+          <p:cNvPr id="97" name="TextBox 96">
+            <a:extLst>
+              <a:ext uri="{FF2B5EF4-FFF2-40B4-BE49-F238E27FC236}">
+                <a16:creationId xmlns:a16="http://schemas.microsoft.com/office/drawing/2014/main" id="{15F6B149-641F-E0D1-B723-77BA50026BD2}"/>
+              </a:ext>
+            </a:extLst>
+          </p:cNvPr>
+          <p:cNvSpPr txBox="1"/>
+          <p:nvPr/>
+        </p:nvSpPr>
+        <p:spPr>
+          <a:xfrm>
+            <a:off x="2615406" y="2130850"/>
+            <a:ext cx="425031" cy="239878"/>
+          </a:xfrm>
+          <a:prstGeom prst="rect">
+            <a:avLst/>
+          </a:prstGeom>
+          <a:noFill/>
+        </p:spPr>
+        <p:txBody>
+          <a:bodyPr wrap="square" rtlCol="0">
+            <a:spAutoFit/>
+          </a:bodyPr>
+          <a:lstStyle/>
+          <a:p>
+            <a:r>
+              <a:rPr lang="en-US" altLang="ko-KR" sz="800" b="1">
+                <a:solidFill>
+                  <a:schemeClr val="bg1"/>
+                </a:solidFill>
+              </a:rPr>
+              <a:t>BOX</a:t>
+            </a:r>
+            <a:endParaRPr lang="ko-KR" altLang="en-US" sz="800" b="1">
+              <a:solidFill>
+                <a:schemeClr val="bg1"/>
+              </a:solidFill>
+            </a:endParaRPr>
+          </a:p>
+        </p:txBody>
+      </p:sp>
+      <p:sp>
+        <p:nvSpPr>
+          <p:cNvPr id="98" name="TextBox 97">
+            <a:extLst>
+              <a:ext uri="{FF2B5EF4-FFF2-40B4-BE49-F238E27FC236}">
+                <a16:creationId xmlns:a16="http://schemas.microsoft.com/office/drawing/2014/main" id="{9F58AB1A-B0C1-652D-C4FD-D08153ECDBAC}"/>
+              </a:ext>
+            </a:extLst>
+          </p:cNvPr>
+          <p:cNvSpPr txBox="1"/>
+          <p:nvPr/>
+        </p:nvSpPr>
+        <p:spPr>
+          <a:xfrm>
+            <a:off x="2621615" y="2472276"/>
+            <a:ext cx="425031" cy="239878"/>
+          </a:xfrm>
+          <a:prstGeom prst="rect">
+            <a:avLst/>
+          </a:prstGeom>
+          <a:noFill/>
+        </p:spPr>
+        <p:txBody>
+          <a:bodyPr wrap="square" rtlCol="0">
+            <a:spAutoFit/>
+          </a:bodyPr>
+          <a:lstStyle/>
+          <a:p>
+            <a:r>
+              <a:rPr lang="en-US" altLang="ko-KR" sz="800" b="1"/>
+              <a:t>CTN</a:t>
+            </a:r>
+            <a:endParaRPr lang="ko-KR" altLang="en-US" sz="800" b="1"/>
+          </a:p>
+        </p:txBody>
+      </p:sp>
+      <p:sp>
+        <p:nvSpPr>
+          <p:cNvPr id="99" name="TextBox 98">
+            <a:extLst>
+              <a:ext uri="{FF2B5EF4-FFF2-40B4-BE49-F238E27FC236}">
+                <a16:creationId xmlns:a16="http://schemas.microsoft.com/office/drawing/2014/main" id="{3CCBA7F1-4869-89F8-ABA4-C607790A6490}"/>
+              </a:ext>
+            </a:extLst>
+          </p:cNvPr>
+          <p:cNvSpPr txBox="1"/>
+          <p:nvPr/>
+        </p:nvSpPr>
+        <p:spPr>
+          <a:xfrm>
+            <a:off x="2567781" y="3008879"/>
+            <a:ext cx="715690" cy="239878"/>
+          </a:xfrm>
+          <a:prstGeom prst="rect">
+            <a:avLst/>
+          </a:prstGeom>
+          <a:noFill/>
+        </p:spPr>
+        <p:txBody>
+          <a:bodyPr wrap="square" rtlCol="0">
+            <a:spAutoFit/>
+          </a:bodyPr>
+          <a:lstStyle/>
+          <a:p>
+            <a:r>
+              <a:rPr lang="en-US" altLang="ko-KR" sz="800" b="1">
+                <a:solidFill>
+                  <a:schemeClr val="bg1"/>
+                </a:solidFill>
+              </a:rPr>
+              <a:t>Si-Channel</a:t>
+            </a:r>
+            <a:endParaRPr lang="ko-KR" altLang="en-US" sz="800" b="1">
+              <a:solidFill>
+                <a:schemeClr val="bg1"/>
+              </a:solidFill>
+            </a:endParaRPr>
+          </a:p>
+        </p:txBody>
+      </p:sp>
+      <p:sp>
+        <p:nvSpPr>
+          <p:cNvPr id="102" name="TextBox 101">
+            <a:extLst>
+              <a:ext uri="{FF2B5EF4-FFF2-40B4-BE49-F238E27FC236}">
+                <a16:creationId xmlns:a16="http://schemas.microsoft.com/office/drawing/2014/main" id="{CF459982-B00F-7371-E60D-5659013439FB}"/>
+              </a:ext>
+            </a:extLst>
+          </p:cNvPr>
+          <p:cNvSpPr txBox="1"/>
+          <p:nvPr/>
+        </p:nvSpPr>
+        <p:spPr>
+          <a:xfrm>
+            <a:off x="3064437" y="2801604"/>
+            <a:ext cx="473401" cy="200055"/>
+          </a:xfrm>
+          <a:prstGeom prst="rect">
+            <a:avLst/>
+          </a:prstGeom>
+          <a:noFill/>
+        </p:spPr>
+        <p:txBody>
+          <a:bodyPr wrap="square" rtlCol="0">
+            <a:spAutoFit/>
+          </a:bodyPr>
+          <a:lstStyle/>
+          <a:p>
+            <a:pPr algn="ctr"/>
+            <a:r>
+              <a:rPr lang="en-US" altLang="ko-KR" sz="700" b="1"/>
+              <a:t>BETOX</a:t>
+            </a:r>
+            <a:endParaRPr lang="ko-KR" altLang="en-US" sz="700" b="1"/>
+          </a:p>
+        </p:txBody>
+      </p:sp>
+      <p:sp>
+        <p:nvSpPr>
+          <p:cNvPr id="95" name="TextBox 94">
+            <a:extLst>
+              <a:ext uri="{FF2B5EF4-FFF2-40B4-BE49-F238E27FC236}">
+                <a16:creationId xmlns:a16="http://schemas.microsoft.com/office/drawing/2014/main" id="{D7ECA9DE-DFF5-50AA-50AF-AFF14E9EFDB8}"/>
+              </a:ext>
+            </a:extLst>
+          </p:cNvPr>
+          <p:cNvSpPr txBox="1"/>
+          <p:nvPr/>
+        </p:nvSpPr>
+        <p:spPr>
+          <a:xfrm>
+            <a:off x="3098819" y="1946711"/>
+            <a:ext cx="425031" cy="215444"/>
+          </a:xfrm>
+          <a:prstGeom prst="rect">
+            <a:avLst/>
+          </a:prstGeom>
+          <a:noFill/>
+        </p:spPr>
+        <p:txBody>
+          <a:bodyPr wrap="square" rtlCol="0">
+            <a:spAutoFit/>
+          </a:bodyPr>
+          <a:lstStyle/>
+          <a:p>
+            <a:pPr algn="ctr"/>
+            <a:r>
+              <a:rPr lang="en-US" altLang="ko-KR" sz="800" b="1">
+                <a:solidFill>
+                  <a:schemeClr val="bg1"/>
+                </a:solidFill>
+              </a:rPr>
+              <a:t>WL</a:t>
+            </a:r>
+            <a:endParaRPr lang="ko-KR" altLang="en-US" sz="800" b="1">
+              <a:solidFill>
+                <a:schemeClr val="bg1"/>
+              </a:solidFill>
+            </a:endParaRPr>
+          </a:p>
+        </p:txBody>
+      </p:sp>
+      <p:sp>
+        <p:nvSpPr>
+          <p:cNvPr id="104" name="TextBox 103">
+            <a:extLst>
+              <a:ext uri="{FF2B5EF4-FFF2-40B4-BE49-F238E27FC236}">
+                <a16:creationId xmlns:a16="http://schemas.microsoft.com/office/drawing/2014/main" id="{F2B501C6-3BC8-DD9A-EBB8-690057069166}"/>
+              </a:ext>
+            </a:extLst>
+          </p:cNvPr>
+          <p:cNvSpPr txBox="1"/>
+          <p:nvPr/>
+        </p:nvSpPr>
+        <p:spPr>
+          <a:xfrm>
+            <a:off x="511553" y="1877894"/>
+            <a:ext cx="360492" cy="215444"/>
+          </a:xfrm>
+          <a:prstGeom prst="rect">
+            <a:avLst/>
+          </a:prstGeom>
+          <a:noFill/>
+        </p:spPr>
+        <p:txBody>
+          <a:bodyPr wrap="square" rtlCol="0">
+            <a:spAutoFit/>
+          </a:bodyPr>
+          <a:lstStyle/>
+          <a:p>
+            <a:r>
+              <a:rPr lang="en-US" altLang="ko-KR" sz="800" b="1">
                 <a:latin typeface="Arial" panose="020B0604020202020204" pitchFamily="34" charset="0"/>
                 <a:cs typeface="Arial" panose="020B0604020202020204" pitchFamily="34" charset="0"/>
-              </a:endParaRPr>
-            </a:p>
-          </p:txBody>
-        </p:sp>
-        <p:sp>
-          <p:nvSpPr>
-            <p:cNvPr id="105" name="TextBox 104">
-              <a:extLst>
-                <a:ext uri="{FF2B5EF4-FFF2-40B4-BE49-F238E27FC236}">
-                  <a16:creationId xmlns:a16="http://schemas.microsoft.com/office/drawing/2014/main" id="{49DE782A-B425-24A1-9F09-CD71E3B91C2D}"/>
-                </a:ext>
-              </a:extLst>
-            </p:cNvPr>
-            <p:cNvSpPr txBox="1"/>
-            <p:nvPr/>
-          </p:nvSpPr>
-          <p:spPr>
-            <a:xfrm>
-              <a:off x="2326149" y="1877894"/>
-              <a:ext cx="360492" cy="215444"/>
-            </a:xfrm>
-            <a:prstGeom prst="rect">
-              <a:avLst/>
-            </a:prstGeom>
-            <a:noFill/>
-          </p:spPr>
-          <p:txBody>
-            <a:bodyPr wrap="square" rtlCol="0">
-              <a:spAutoFit/>
-            </a:bodyPr>
-            <a:lstStyle/>
-            <a:p>
-              <a:r>
-                <a:rPr lang="en-US" altLang="ko-KR" sz="800" b="1">
-                  <a:latin typeface="Arial" panose="020B0604020202020204" pitchFamily="34" charset="0"/>
-                  <a:cs typeface="Arial" panose="020B0604020202020204" pitchFamily="34" charset="0"/>
-                </a:rPr>
-                <a:t>(b)</a:t>
-              </a:r>
-              <a:endParaRPr lang="ko-KR" altLang="en-US" sz="800" b="1">
+              </a:rPr>
+              <a:t>(a)</a:t>
+            </a:r>
+            <a:endParaRPr lang="ko-KR" altLang="en-US" sz="800" b="1">
+              <a:latin typeface="Arial" panose="020B0604020202020204" pitchFamily="34" charset="0"/>
+              <a:cs typeface="Arial" panose="020B0604020202020204" pitchFamily="34" charset="0"/>
+            </a:endParaRPr>
+          </a:p>
+        </p:txBody>
+      </p:sp>
+      <p:sp>
+        <p:nvSpPr>
+          <p:cNvPr id="105" name="TextBox 104">
+            <a:extLst>
+              <a:ext uri="{FF2B5EF4-FFF2-40B4-BE49-F238E27FC236}">
+                <a16:creationId xmlns:a16="http://schemas.microsoft.com/office/drawing/2014/main" id="{49DE782A-B425-24A1-9F09-CD71E3B91C2D}"/>
+              </a:ext>
+            </a:extLst>
+          </p:cNvPr>
+          <p:cNvSpPr txBox="1"/>
+          <p:nvPr/>
+        </p:nvSpPr>
+        <p:spPr>
+          <a:xfrm>
+            <a:off x="2326149" y="1877894"/>
+            <a:ext cx="360492" cy="215444"/>
+          </a:xfrm>
+          <a:prstGeom prst="rect">
+            <a:avLst/>
+          </a:prstGeom>
+          <a:noFill/>
+        </p:spPr>
+        <p:txBody>
+          <a:bodyPr wrap="square" rtlCol="0">
+            <a:spAutoFit/>
+          </a:bodyPr>
+          <a:lstStyle/>
+          <a:p>
+            <a:r>
+              <a:rPr lang="en-US" altLang="ko-KR" sz="800" b="1">
                 <a:latin typeface="Arial" panose="020B0604020202020204" pitchFamily="34" charset="0"/>
                 <a:cs typeface="Arial" panose="020B0604020202020204" pitchFamily="34" charset="0"/>
-              </a:endParaRPr>
-            </a:p>
-          </p:txBody>
-        </p:sp>
-        <p:sp>
-          <p:nvSpPr>
-            <p:cNvPr id="106" name="TextBox 105">
-              <a:extLst>
-                <a:ext uri="{FF2B5EF4-FFF2-40B4-BE49-F238E27FC236}">
-                  <a16:creationId xmlns:a16="http://schemas.microsoft.com/office/drawing/2014/main" id="{6F27CF51-3A2F-C4F2-D601-7DC531BA7FF7}"/>
-                </a:ext>
-              </a:extLst>
-            </p:cNvPr>
-            <p:cNvSpPr txBox="1"/>
-            <p:nvPr/>
-          </p:nvSpPr>
-          <p:spPr>
-            <a:xfrm>
-              <a:off x="511552" y="3102131"/>
-              <a:ext cx="360492" cy="215444"/>
-            </a:xfrm>
-            <a:prstGeom prst="rect">
-              <a:avLst/>
-            </a:prstGeom>
-            <a:noFill/>
-          </p:spPr>
-          <p:txBody>
-            <a:bodyPr wrap="square" rtlCol="0">
-              <a:spAutoFit/>
-            </a:bodyPr>
-            <a:lstStyle/>
-            <a:p>
-              <a:r>
-                <a:rPr lang="en-US" altLang="ko-KR" sz="800" b="1">
-                  <a:latin typeface="Arial" panose="020B0604020202020204" pitchFamily="34" charset="0"/>
-                  <a:cs typeface="Arial" panose="020B0604020202020204" pitchFamily="34" charset="0"/>
-                </a:rPr>
-                <a:t>(c)</a:t>
-              </a:r>
-              <a:endParaRPr lang="ko-KR" altLang="en-US" sz="800" b="1">
+              </a:rPr>
+              <a:t>(b)</a:t>
+            </a:r>
+            <a:endParaRPr lang="ko-KR" altLang="en-US" sz="800" b="1">
+              <a:latin typeface="Arial" panose="020B0604020202020204" pitchFamily="34" charset="0"/>
+              <a:cs typeface="Arial" panose="020B0604020202020204" pitchFamily="34" charset="0"/>
+            </a:endParaRPr>
+          </a:p>
+        </p:txBody>
+      </p:sp>
+      <p:sp>
+        <p:nvSpPr>
+          <p:cNvPr id="106" name="TextBox 105">
+            <a:extLst>
+              <a:ext uri="{FF2B5EF4-FFF2-40B4-BE49-F238E27FC236}">
+                <a16:creationId xmlns:a16="http://schemas.microsoft.com/office/drawing/2014/main" id="{6F27CF51-3A2F-C4F2-D601-7DC531BA7FF7}"/>
+              </a:ext>
+            </a:extLst>
+          </p:cNvPr>
+          <p:cNvSpPr txBox="1"/>
+          <p:nvPr/>
+        </p:nvSpPr>
+        <p:spPr>
+          <a:xfrm>
+            <a:off x="511552" y="3102131"/>
+            <a:ext cx="360492" cy="215444"/>
+          </a:xfrm>
+          <a:prstGeom prst="rect">
+            <a:avLst/>
+          </a:prstGeom>
+          <a:noFill/>
+        </p:spPr>
+        <p:txBody>
+          <a:bodyPr wrap="square" rtlCol="0">
+            <a:spAutoFit/>
+          </a:bodyPr>
+          <a:lstStyle/>
+          <a:p>
+            <a:r>
+              <a:rPr lang="en-US" altLang="ko-KR" sz="800" b="1">
                 <a:latin typeface="Arial" panose="020B0604020202020204" pitchFamily="34" charset="0"/>
                 <a:cs typeface="Arial" panose="020B0604020202020204" pitchFamily="34" charset="0"/>
-              </a:endParaRPr>
-            </a:p>
-          </p:txBody>
-        </p:sp>
-        <p:sp>
-          <p:nvSpPr>
-            <p:cNvPr id="107" name="TextBox 106">
-              <a:extLst>
-                <a:ext uri="{FF2B5EF4-FFF2-40B4-BE49-F238E27FC236}">
-                  <a16:creationId xmlns:a16="http://schemas.microsoft.com/office/drawing/2014/main" id="{DF890235-D84F-7FA2-BAB0-7D73BDE3F8B2}"/>
-                </a:ext>
-              </a:extLst>
-            </p:cNvPr>
-            <p:cNvSpPr txBox="1"/>
-            <p:nvPr/>
-          </p:nvSpPr>
-          <p:spPr>
-            <a:xfrm>
-              <a:off x="2326149" y="3102131"/>
-              <a:ext cx="360492" cy="215444"/>
-            </a:xfrm>
-            <a:prstGeom prst="rect">
-              <a:avLst/>
-            </a:prstGeom>
-            <a:noFill/>
-          </p:spPr>
-          <p:txBody>
-            <a:bodyPr wrap="square" rtlCol="0">
-              <a:spAutoFit/>
-            </a:bodyPr>
-            <a:lstStyle/>
-            <a:p>
-              <a:r>
-                <a:rPr lang="en-US" altLang="ko-KR" sz="800" b="1">
-                  <a:latin typeface="Arial" panose="020B0604020202020204" pitchFamily="34" charset="0"/>
-                  <a:cs typeface="Arial" panose="020B0604020202020204" pitchFamily="34" charset="0"/>
-                </a:rPr>
-                <a:t>(d)</a:t>
-              </a:r>
-              <a:endParaRPr lang="ko-KR" altLang="en-US" sz="800" b="1">
+              </a:rPr>
+              <a:t>(c)</a:t>
+            </a:r>
+            <a:endParaRPr lang="ko-KR" altLang="en-US" sz="800" b="1">
+              <a:latin typeface="Arial" panose="020B0604020202020204" pitchFamily="34" charset="0"/>
+              <a:cs typeface="Arial" panose="020B0604020202020204" pitchFamily="34" charset="0"/>
+            </a:endParaRPr>
+          </a:p>
+        </p:txBody>
+      </p:sp>
+      <p:sp>
+        <p:nvSpPr>
+          <p:cNvPr id="107" name="TextBox 106">
+            <a:extLst>
+              <a:ext uri="{FF2B5EF4-FFF2-40B4-BE49-F238E27FC236}">
+                <a16:creationId xmlns:a16="http://schemas.microsoft.com/office/drawing/2014/main" id="{DF890235-D84F-7FA2-BAB0-7D73BDE3F8B2}"/>
+              </a:ext>
+            </a:extLst>
+          </p:cNvPr>
+          <p:cNvSpPr txBox="1"/>
+          <p:nvPr/>
+        </p:nvSpPr>
+        <p:spPr>
+          <a:xfrm>
+            <a:off x="2326149" y="3102131"/>
+            <a:ext cx="360492" cy="215444"/>
+          </a:xfrm>
+          <a:prstGeom prst="rect">
+            <a:avLst/>
+          </a:prstGeom>
+          <a:noFill/>
+        </p:spPr>
+        <p:txBody>
+          <a:bodyPr wrap="square" rtlCol="0">
+            <a:spAutoFit/>
+          </a:bodyPr>
+          <a:lstStyle/>
+          <a:p>
+            <a:r>
+              <a:rPr lang="en-US" altLang="ko-KR" sz="800" b="1">
                 <a:latin typeface="Arial" panose="020B0604020202020204" pitchFamily="34" charset="0"/>
                 <a:cs typeface="Arial" panose="020B0604020202020204" pitchFamily="34" charset="0"/>
-              </a:endParaRPr>
-            </a:p>
-          </p:txBody>
-        </p:sp>
-      </p:grpSp>
+              </a:rPr>
+              <a:t>(d)</a:t>
+            </a:r>
+            <a:endParaRPr lang="ko-KR" altLang="en-US" sz="800" b="1">
+              <a:latin typeface="Arial" panose="020B0604020202020204" pitchFamily="34" charset="0"/>
+              <a:cs typeface="Arial" panose="020B0604020202020204" pitchFamily="34" charset="0"/>
+            </a:endParaRPr>
+          </a:p>
+        </p:txBody>
+      </p:sp>
     </p:spTree>
     <p:extLst>
       <p:ext uri="{BB962C8B-B14F-4D97-AF65-F5344CB8AC3E}">

</xml_diff>

<commit_message>
commit before push due to moving seat
</commit_message>
<xml_diff>
--- a/figures/Figures-EDL202602-manuscript.pptx
+++ b/figures/Figures-EDL202602-manuscript.pptx
@@ -1409,7 +1409,7 @@
           <a:p>
             <a:fld id="{AA311422-0C2E-42D7-924E-F365B5A34ABC}" type="datetimeFigureOut">
               <a:rPr lang="ko-KR" altLang="en-US" smtClean="0"/>
-              <a:t>2026-01-30</a:t>
+              <a:t>2026-02-02</a:t>
             </a:fld>
             <a:endParaRPr lang="ko-KR" altLang="en-US"/>
           </a:p>
@@ -1807,7 +1807,7 @@
           <a:p>
             <a:fld id="{038C53AF-CD6D-418E-B451-BA3CFECC6915}" type="datetimeFigureOut">
               <a:rPr lang="ko-KR" altLang="en-US" smtClean="0"/>
-              <a:t>2026-01-30</a:t>
+              <a:t>2026-02-02</a:t>
             </a:fld>
             <a:endParaRPr lang="ko-KR" altLang="en-US"/>
           </a:p>
@@ -1977,7 +1977,7 @@
           <a:p>
             <a:fld id="{038C53AF-CD6D-418E-B451-BA3CFECC6915}" type="datetimeFigureOut">
               <a:rPr lang="ko-KR" altLang="en-US" smtClean="0"/>
-              <a:t>2026-01-30</a:t>
+              <a:t>2026-02-02</a:t>
             </a:fld>
             <a:endParaRPr lang="ko-KR" altLang="en-US"/>
           </a:p>
@@ -2157,7 +2157,7 @@
           <a:p>
             <a:fld id="{038C53AF-CD6D-418E-B451-BA3CFECC6915}" type="datetimeFigureOut">
               <a:rPr lang="ko-KR" altLang="en-US" smtClean="0"/>
-              <a:t>2026-01-30</a:t>
+              <a:t>2026-02-02</a:t>
             </a:fld>
             <a:endParaRPr lang="ko-KR" altLang="en-US"/>
           </a:p>
@@ -2327,7 +2327,7 @@
           <a:p>
             <a:fld id="{038C53AF-CD6D-418E-B451-BA3CFECC6915}" type="datetimeFigureOut">
               <a:rPr lang="ko-KR" altLang="en-US" smtClean="0"/>
-              <a:t>2026-01-30</a:t>
+              <a:t>2026-02-02</a:t>
             </a:fld>
             <a:endParaRPr lang="ko-KR" altLang="en-US"/>
           </a:p>
@@ -2573,7 +2573,7 @@
           <a:p>
             <a:fld id="{038C53AF-CD6D-418E-B451-BA3CFECC6915}" type="datetimeFigureOut">
               <a:rPr lang="ko-KR" altLang="en-US" smtClean="0"/>
-              <a:t>2026-01-30</a:t>
+              <a:t>2026-02-02</a:t>
             </a:fld>
             <a:endParaRPr lang="ko-KR" altLang="en-US"/>
           </a:p>
@@ -2805,7 +2805,7 @@
           <a:p>
             <a:fld id="{038C53AF-CD6D-418E-B451-BA3CFECC6915}" type="datetimeFigureOut">
               <a:rPr lang="ko-KR" altLang="en-US" smtClean="0"/>
-              <a:t>2026-01-30</a:t>
+              <a:t>2026-02-02</a:t>
             </a:fld>
             <a:endParaRPr lang="ko-KR" altLang="en-US"/>
           </a:p>
@@ -3172,7 +3172,7 @@
           <a:p>
             <a:fld id="{038C53AF-CD6D-418E-B451-BA3CFECC6915}" type="datetimeFigureOut">
               <a:rPr lang="ko-KR" altLang="en-US" smtClean="0"/>
-              <a:t>2026-01-30</a:t>
+              <a:t>2026-02-02</a:t>
             </a:fld>
             <a:endParaRPr lang="ko-KR" altLang="en-US"/>
           </a:p>
@@ -3290,7 +3290,7 @@
           <a:p>
             <a:fld id="{038C53AF-CD6D-418E-B451-BA3CFECC6915}" type="datetimeFigureOut">
               <a:rPr lang="ko-KR" altLang="en-US" smtClean="0"/>
-              <a:t>2026-01-30</a:t>
+              <a:t>2026-02-02</a:t>
             </a:fld>
             <a:endParaRPr lang="ko-KR" altLang="en-US"/>
           </a:p>
@@ -3385,7 +3385,7 @@
           <a:p>
             <a:fld id="{038C53AF-CD6D-418E-B451-BA3CFECC6915}" type="datetimeFigureOut">
               <a:rPr lang="ko-KR" altLang="en-US" smtClean="0"/>
-              <a:t>2026-01-30</a:t>
+              <a:t>2026-02-02</a:t>
             </a:fld>
             <a:endParaRPr lang="ko-KR" altLang="en-US"/>
           </a:p>
@@ -3662,7 +3662,7 @@
           <a:p>
             <a:fld id="{038C53AF-CD6D-418E-B451-BA3CFECC6915}" type="datetimeFigureOut">
               <a:rPr lang="ko-KR" altLang="en-US" smtClean="0"/>
-              <a:t>2026-01-30</a:t>
+              <a:t>2026-02-02</a:t>
             </a:fld>
             <a:endParaRPr lang="ko-KR" altLang="en-US"/>
           </a:p>
@@ -3919,7 +3919,7 @@
           <a:p>
             <a:fld id="{038C53AF-CD6D-418E-B451-BA3CFECC6915}" type="datetimeFigureOut">
               <a:rPr lang="ko-KR" altLang="en-US" smtClean="0"/>
-              <a:t>2026-01-30</a:t>
+              <a:t>2026-02-02</a:t>
             </a:fld>
             <a:endParaRPr lang="ko-KR" altLang="en-US"/>
           </a:p>
@@ -4132,7 +4132,7 @@
           <a:p>
             <a:fld id="{038C53AF-CD6D-418E-B451-BA3CFECC6915}" type="datetimeFigureOut">
               <a:rPr lang="ko-KR" altLang="en-US" smtClean="0"/>
-              <a:t>2026-01-30</a:t>
+              <a:t>2026-02-02</a:t>
             </a:fld>
             <a:endParaRPr lang="ko-KR" altLang="en-US"/>
           </a:p>
@@ -13163,7 +13163,7 @@
         </p:blipFill>
         <p:spPr>
           <a:xfrm>
-            <a:off x="4631714" y="4568395"/>
+            <a:off x="1223256" y="8090602"/>
             <a:ext cx="2045312" cy="1287993"/>
           </a:xfrm>
           <a:prstGeom prst="rect">
@@ -13452,10 +13452,10 @@
       </p:graphicFrame>
       <p:grpSp>
         <p:nvGrpSpPr>
-          <p:cNvPr id="36" name="그룹 35">
+          <p:cNvPr id="35" name="그룹 34">
             <a:extLst>
               <a:ext uri="{FF2B5EF4-FFF2-40B4-BE49-F238E27FC236}">
-                <a16:creationId xmlns:a16="http://schemas.microsoft.com/office/drawing/2014/main" id="{D16A00D0-26E2-B919-BD8A-19374848107E}"/>
+                <a16:creationId xmlns:a16="http://schemas.microsoft.com/office/drawing/2014/main" id="{A4D73583-B9C7-E80D-44A5-C2B61A26846B}"/>
               </a:ext>
             </a:extLst>
           </p:cNvPr>
@@ -13465,17 +13465,903 @@
         <p:grpSpPr>
           <a:xfrm>
             <a:off x="544132" y="2827561"/>
-            <a:ext cx="3237294" cy="2988598"/>
+            <a:ext cx="2801780" cy="2988598"/>
             <a:chOff x="544132" y="2827561"/>
-            <a:chExt cx="3237294" cy="2988598"/>
+            <a:chExt cx="2801780" cy="2988598"/>
           </a:xfrm>
         </p:grpSpPr>
+        <mc:AlternateContent xmlns:mc="http://schemas.openxmlformats.org/markup-compatibility/2006" xmlns:a14="http://schemas.microsoft.com/office/drawing/2010/main">
+          <mc:Choice Requires="a14">
+            <p:sp>
+              <p:nvSpPr>
+                <p:cNvPr id="20" name="TextBox 19">
+                  <a:extLst>
+                    <a:ext uri="{FF2B5EF4-FFF2-40B4-BE49-F238E27FC236}">
+                      <a16:creationId xmlns:a16="http://schemas.microsoft.com/office/drawing/2014/main" id="{C257EAA8-FA25-A456-3DC6-70313094052C}"/>
+                    </a:ext>
+                  </a:extLst>
+                </p:cNvPr>
+                <p:cNvSpPr txBox="1"/>
+                <p:nvPr/>
+              </p:nvSpPr>
+              <p:spPr>
+                <a:xfrm>
+                  <a:off x="690705" y="4120522"/>
+                  <a:ext cx="1065102" cy="220958"/>
+                </a:xfrm>
+                <a:prstGeom prst="rect">
+                  <a:avLst/>
+                </a:prstGeom>
+                <a:noFill/>
+              </p:spPr>
+              <p:txBody>
+                <a:bodyPr wrap="square" rtlCol="0">
+                  <a:spAutoFit/>
+                </a:bodyPr>
+                <a:lstStyle/>
+                <a:p>
+                  <a14:m>
+                    <m:oMath xmlns:m="http://schemas.openxmlformats.org/officeDocument/2006/math">
+                      <m:sSub>
+                        <m:sSubPr>
+                          <m:ctrlPr>
+                            <a:rPr lang="en-US" altLang="ko-KR" sz="800" b="0" i="1" smtClean="0">
+                              <a:ln w="9525">
+                                <a:solidFill>
+                                  <a:schemeClr val="tx1">
+                                    <a:alpha val="29000"/>
+                                  </a:schemeClr>
+                                </a:solidFill>
+                              </a:ln>
+                              <a:latin typeface="Cambria Math" panose="02040503050406030204" pitchFamily="18" charset="0"/>
+                              <a:ea typeface="맑은 고딕"/>
+                              <a:cs typeface="Times New Roman"/>
+                            </a:rPr>
+                          </m:ctrlPr>
+                        </m:sSubPr>
+                        <m:e>
+                          <m:r>
+                            <a:rPr lang="en-US" altLang="ko-KR" sz="800" b="0" i="1" smtClean="0">
+                              <a:ln w="9525">
+                                <a:solidFill>
+                                  <a:schemeClr val="tx1">
+                                    <a:alpha val="29000"/>
+                                  </a:schemeClr>
+                                </a:solidFill>
+                              </a:ln>
+                              <a:latin typeface="Cambria Math" panose="02040503050406030204" pitchFamily="18" charset="0"/>
+                              <a:ea typeface="맑은 고딕"/>
+                              <a:cs typeface="Times New Roman"/>
+                            </a:rPr>
+                            <m:t>𝑒</m:t>
+                          </m:r>
+                        </m:e>
+                        <m:sub>
+                          <m:r>
+                            <a:rPr lang="en-US" altLang="ko-KR" sz="800" b="0" i="1" smtClean="0">
+                              <a:ln w="9525">
+                                <a:solidFill>
+                                  <a:schemeClr val="tx1">
+                                    <a:alpha val="29000"/>
+                                  </a:schemeClr>
+                                </a:solidFill>
+                              </a:ln>
+                              <a:latin typeface="Cambria Math" panose="02040503050406030204" pitchFamily="18" charset="0"/>
+                              <a:ea typeface="맑은 고딕"/>
+                              <a:cs typeface="Times New Roman"/>
+                            </a:rPr>
+                            <m:t>𝑐h</m:t>
+                          </m:r>
+                        </m:sub>
+                      </m:sSub>
+                      <m:r>
+                        <a:rPr lang="en-US" altLang="ko-KR" sz="800" b="0" i="1" smtClean="0">
+                          <a:ln w="9525">
+                            <a:solidFill>
+                              <a:schemeClr val="tx1">
+                                <a:alpha val="29000"/>
+                              </a:schemeClr>
+                            </a:solidFill>
+                          </a:ln>
+                          <a:latin typeface="Cambria Math" panose="02040503050406030204" pitchFamily="18" charset="0"/>
+                          <a:ea typeface="맑은 고딕"/>
+                          <a:cs typeface="Times New Roman"/>
+                        </a:rPr>
+                        <m:t>=</m:t>
+                      </m:r>
+                      <m:sSub>
+                        <m:sSubPr>
+                          <m:ctrlPr>
+                            <a:rPr lang="en-US" altLang="ko-KR" sz="800" b="0" i="1" smtClean="0">
+                              <a:ln w="9525">
+                                <a:solidFill>
+                                  <a:schemeClr val="tx1">
+                                    <a:alpha val="29000"/>
+                                  </a:schemeClr>
+                                </a:solidFill>
+                              </a:ln>
+                              <a:latin typeface="Cambria Math" panose="02040503050406030204" pitchFamily="18" charset="0"/>
+                              <a:ea typeface="맑은 고딕"/>
+                              <a:cs typeface="Times New Roman"/>
+                            </a:rPr>
+                          </m:ctrlPr>
+                        </m:sSubPr>
+                        <m:e>
+                          <m:r>
+                            <a:rPr lang="en-US" altLang="ko-KR" sz="800" b="0" i="1" smtClean="0">
+                              <a:ln w="9525">
+                                <a:solidFill>
+                                  <a:schemeClr val="tx1">
+                                    <a:alpha val="29000"/>
+                                  </a:schemeClr>
+                                </a:solidFill>
+                              </a:ln>
+                              <a:latin typeface="Cambria Math" panose="02040503050406030204" pitchFamily="18" charset="0"/>
+                              <a:ea typeface="맑은 고딕"/>
+                              <a:cs typeface="Times New Roman"/>
+                            </a:rPr>
+                            <m:t>𝜈</m:t>
+                          </m:r>
+                        </m:e>
+                        <m:sub>
+                          <m:r>
+                            <a:rPr lang="en-US" altLang="ko-KR" sz="800" b="0" i="1" smtClean="0">
+                              <a:ln w="9525">
+                                <a:solidFill>
+                                  <a:schemeClr val="tx1">
+                                    <a:alpha val="29000"/>
+                                  </a:schemeClr>
+                                </a:solidFill>
+                              </a:ln>
+                              <a:latin typeface="Cambria Math" panose="02040503050406030204" pitchFamily="18" charset="0"/>
+                              <a:ea typeface="맑은 고딕"/>
+                              <a:cs typeface="Times New Roman"/>
+                            </a:rPr>
+                            <m:t>𝑐h</m:t>
+                          </m:r>
+                        </m:sub>
+                      </m:sSub>
+                      <m:r>
+                        <a:rPr lang="en-US" altLang="ko-KR" sz="800" b="0" i="1" smtClean="0">
+                          <a:ln w="9525">
+                            <a:solidFill>
+                              <a:schemeClr val="tx1">
+                                <a:alpha val="29000"/>
+                              </a:schemeClr>
+                            </a:solidFill>
+                          </a:ln>
+                          <a:latin typeface="Cambria Math" panose="02040503050406030204" pitchFamily="18" charset="0"/>
+                          <a:ea typeface="맑은 고딕"/>
+                          <a:cs typeface="Times New Roman"/>
+                        </a:rPr>
+                        <m:t>×</m:t>
+                      </m:r>
+                      <m:sSub>
+                        <m:sSubPr>
+                          <m:ctrlPr>
+                            <a:rPr lang="en-US" altLang="ko-KR" sz="800" b="0" i="1" smtClean="0">
+                              <a:ln w="9525">
+                                <a:solidFill>
+                                  <a:schemeClr val="tx1">
+                                    <a:alpha val="29000"/>
+                                  </a:schemeClr>
+                                </a:solidFill>
+                              </a:ln>
+                              <a:latin typeface="Cambria Math" panose="02040503050406030204" pitchFamily="18" charset="0"/>
+                              <a:ea typeface="맑은 고딕"/>
+                              <a:cs typeface="Times New Roman"/>
+                            </a:rPr>
+                          </m:ctrlPr>
+                        </m:sSubPr>
+                        <m:e>
+                          <m:d>
+                            <m:dPr>
+                              <m:begChr m:val="|"/>
+                              <m:endChr m:val="|"/>
+                              <m:ctrlPr>
+                                <a:rPr lang="en-US" altLang="ko-KR" sz="800" b="0" i="1" smtClean="0">
+                                  <a:ln w="9525">
+                                    <a:solidFill>
+                                      <a:schemeClr val="tx1">
+                                        <a:alpha val="29000"/>
+                                      </a:schemeClr>
+                                    </a:solidFill>
+                                  </a:ln>
+                                  <a:latin typeface="Cambria Math" panose="02040503050406030204" pitchFamily="18" charset="0"/>
+                                  <a:ea typeface="맑은 고딕"/>
+                                  <a:cs typeface="Times New Roman"/>
+                                </a:rPr>
+                              </m:ctrlPr>
+                            </m:dPr>
+                            <m:e>
+                              <m:r>
+                                <a:rPr lang="en-US" altLang="ko-KR" sz="800" b="0" i="1" smtClean="0">
+                                  <a:ln w="9525">
+                                    <a:solidFill>
+                                      <a:schemeClr val="tx1">
+                                        <a:alpha val="29000"/>
+                                      </a:schemeClr>
+                                    </a:solidFill>
+                                  </a:ln>
+                                  <a:latin typeface="Cambria Math" panose="02040503050406030204" pitchFamily="18" charset="0"/>
+                                  <a:ea typeface="맑은 고딕"/>
+                                  <a:cs typeface="Times New Roman"/>
+                                </a:rPr>
+                                <m:t>𝑇𝐶</m:t>
+                              </m:r>
+                            </m:e>
+                          </m:d>
+                        </m:e>
+                        <m:sub>
+                          <m:r>
+                            <a:rPr lang="en-US" altLang="ko-KR" sz="800" b="0" i="1" smtClean="0">
+                              <a:ln w="9525">
+                                <a:solidFill>
+                                  <a:schemeClr val="tx1">
+                                    <a:alpha val="29000"/>
+                                  </a:schemeClr>
+                                </a:solidFill>
+                              </a:ln>
+                              <a:latin typeface="Cambria Math" panose="02040503050406030204" pitchFamily="18" charset="0"/>
+                              <a:ea typeface="맑은 고딕"/>
+                              <a:cs typeface="Times New Roman"/>
+                            </a:rPr>
+                            <m:t>𝑐h</m:t>
+                          </m:r>
+                        </m:sub>
+                      </m:sSub>
+                    </m:oMath>
+                  </a14:m>
+                  <a:r>
+                    <a:rPr lang="ko-KR" altLang="en-US" sz="800" dirty="0">
+                      <a:ln w="9525">
+                        <a:solidFill>
+                          <a:schemeClr val="tx1">
+                            <a:alpha val="29000"/>
+                          </a:schemeClr>
+                        </a:solidFill>
+                      </a:ln>
+                      <a:latin typeface="Times New Roman"/>
+                      <a:ea typeface="맑은 고딕"/>
+                      <a:cs typeface="Times New Roman"/>
+                    </a:rPr>
+                    <a:t> </a:t>
+                  </a:r>
+                </a:p>
+              </p:txBody>
+            </p:sp>
+          </mc:Choice>
+          <mc:Fallback xmlns="">
+            <p:sp>
+              <p:nvSpPr>
+                <p:cNvPr id="20" name="TextBox 19">
+                  <a:extLst>
+                    <a:ext uri="{FF2B5EF4-FFF2-40B4-BE49-F238E27FC236}">
+                      <a16:creationId xmlns:a16="http://schemas.microsoft.com/office/drawing/2014/main" id="{C257EAA8-FA25-A456-3DC6-70313094052C}"/>
+                    </a:ext>
+                  </a:extLst>
+                </p:cNvPr>
+                <p:cNvSpPr txBox="1">
+                  <a:spLocks noRot="1" noChangeAspect="1" noMove="1" noResize="1" noEditPoints="1" noAdjustHandles="1" noChangeArrowheads="1" noChangeShapeType="1" noTextEdit="1"/>
+                </p:cNvSpPr>
+                <p:nvPr/>
+              </p:nvSpPr>
+              <p:spPr>
+                <a:xfrm>
+                  <a:off x="690705" y="4120522"/>
+                  <a:ext cx="1065102" cy="220958"/>
+                </a:xfrm>
+                <a:prstGeom prst="rect">
+                  <a:avLst/>
+                </a:prstGeom>
+                <a:blipFill>
+                  <a:blip r:embed="rId3"/>
+                  <a:stretch>
+                    <a:fillRect/>
+                  </a:stretch>
+                </a:blipFill>
+              </p:spPr>
+              <p:txBody>
+                <a:bodyPr/>
+                <a:lstStyle/>
+                <a:p>
+                  <a:r>
+                    <a:rPr lang="ko-KR" altLang="en-US">
+                      <a:noFill/>
+                    </a:rPr>
+                    <a:t> </a:t>
+                  </a:r>
+                </a:p>
+              </p:txBody>
+            </p:sp>
+          </mc:Fallback>
+        </mc:AlternateContent>
+        <mc:AlternateContent xmlns:mc="http://schemas.openxmlformats.org/markup-compatibility/2006" xmlns:a14="http://schemas.microsoft.com/office/drawing/2010/main">
+          <mc:Choice Requires="a14">
+            <p:sp>
+              <p:nvSpPr>
+                <p:cNvPr id="21" name="TextBox 20">
+                  <a:extLst>
+                    <a:ext uri="{FF2B5EF4-FFF2-40B4-BE49-F238E27FC236}">
+                      <a16:creationId xmlns:a16="http://schemas.microsoft.com/office/drawing/2014/main" id="{6803C50A-61E5-5F6C-A180-2212E0DA9561}"/>
+                    </a:ext>
+                  </a:extLst>
+                </p:cNvPr>
+                <p:cNvSpPr txBox="1"/>
+                <p:nvPr/>
+              </p:nvSpPr>
+              <p:spPr>
+                <a:xfrm>
+                  <a:off x="1755807" y="4120522"/>
+                  <a:ext cx="1106459" cy="220958"/>
+                </a:xfrm>
+                <a:prstGeom prst="rect">
+                  <a:avLst/>
+                </a:prstGeom>
+                <a:noFill/>
+              </p:spPr>
+              <p:txBody>
+                <a:bodyPr wrap="square" rtlCol="0">
+                  <a:spAutoFit/>
+                </a:bodyPr>
+                <a:lstStyle/>
+                <a:p>
+                  <a14:m>
+                    <m:oMath xmlns:m="http://schemas.openxmlformats.org/officeDocument/2006/math">
+                      <m:sSub>
+                        <m:sSubPr>
+                          <m:ctrlPr>
+                            <a:rPr lang="en-US" altLang="ko-KR" sz="800" b="0" i="1" smtClean="0">
+                              <a:ln w="9525">
+                                <a:solidFill>
+                                  <a:schemeClr val="tx1">
+                                    <a:alpha val="29000"/>
+                                  </a:schemeClr>
+                                </a:solidFill>
+                              </a:ln>
+                              <a:latin typeface="Cambria Math" panose="02040503050406030204" pitchFamily="18" charset="0"/>
+                              <a:ea typeface="맑은 고딕"/>
+                              <a:cs typeface="Times New Roman"/>
+                            </a:rPr>
+                          </m:ctrlPr>
+                        </m:sSubPr>
+                        <m:e>
+                          <m:r>
+                            <a:rPr lang="en-US" altLang="ko-KR" sz="800" b="0" i="1" smtClean="0">
+                              <a:ln w="9525">
+                                <a:solidFill>
+                                  <a:schemeClr val="tx1">
+                                    <a:alpha val="29000"/>
+                                  </a:schemeClr>
+                                </a:solidFill>
+                              </a:ln>
+                              <a:latin typeface="Cambria Math" panose="02040503050406030204" pitchFamily="18" charset="0"/>
+                              <a:ea typeface="맑은 고딕"/>
+                              <a:cs typeface="Times New Roman"/>
+                            </a:rPr>
+                            <m:t>𝑒</m:t>
+                          </m:r>
+                        </m:e>
+                        <m:sub>
+                          <m:r>
+                            <a:rPr lang="en-US" altLang="ko-KR" sz="800" b="0" i="1" smtClean="0">
+                              <a:ln w="9525">
+                                <a:solidFill>
+                                  <a:schemeClr val="tx1">
+                                    <a:alpha val="29000"/>
+                                  </a:schemeClr>
+                                </a:solidFill>
+                              </a:ln>
+                              <a:latin typeface="Cambria Math" panose="02040503050406030204" pitchFamily="18" charset="0"/>
+                              <a:ea typeface="맑은 고딕"/>
+                              <a:cs typeface="Times New Roman"/>
+                            </a:rPr>
+                            <m:t>𝑊𝐿</m:t>
+                          </m:r>
+                        </m:sub>
+                      </m:sSub>
+                      <m:r>
+                        <a:rPr lang="en-US" altLang="ko-KR" sz="800" b="0" i="1" smtClean="0">
+                          <a:ln w="9525">
+                            <a:solidFill>
+                              <a:schemeClr val="tx1">
+                                <a:alpha val="29000"/>
+                              </a:schemeClr>
+                            </a:solidFill>
+                          </a:ln>
+                          <a:latin typeface="Cambria Math" panose="02040503050406030204" pitchFamily="18" charset="0"/>
+                          <a:ea typeface="맑은 고딕"/>
+                          <a:cs typeface="Times New Roman"/>
+                        </a:rPr>
+                        <m:t>=</m:t>
+                      </m:r>
+                      <m:sSub>
+                        <m:sSubPr>
+                          <m:ctrlPr>
+                            <a:rPr lang="en-US" altLang="ko-KR" sz="800" b="0" i="1" smtClean="0">
+                              <a:ln w="9525">
+                                <a:solidFill>
+                                  <a:schemeClr val="tx1">
+                                    <a:alpha val="29000"/>
+                                  </a:schemeClr>
+                                </a:solidFill>
+                              </a:ln>
+                              <a:latin typeface="Cambria Math" panose="02040503050406030204" pitchFamily="18" charset="0"/>
+                              <a:ea typeface="맑은 고딕"/>
+                              <a:cs typeface="Times New Roman"/>
+                            </a:rPr>
+                          </m:ctrlPr>
+                        </m:sSubPr>
+                        <m:e>
+                          <m:r>
+                            <a:rPr lang="en-US" altLang="ko-KR" sz="800" b="0" i="1" smtClean="0">
+                              <a:ln w="9525">
+                                <a:solidFill>
+                                  <a:schemeClr val="tx1">
+                                    <a:alpha val="29000"/>
+                                  </a:schemeClr>
+                                </a:solidFill>
+                              </a:ln>
+                              <a:latin typeface="Cambria Math" panose="02040503050406030204" pitchFamily="18" charset="0"/>
+                              <a:ea typeface="맑은 고딕"/>
+                              <a:cs typeface="Times New Roman"/>
+                            </a:rPr>
+                            <m:t>𝜈</m:t>
+                          </m:r>
+                        </m:e>
+                        <m:sub>
+                          <m:r>
+                            <a:rPr lang="en-US" altLang="ko-KR" sz="800" b="0" i="1" smtClean="0">
+                              <a:ln w="9525">
+                                <a:solidFill>
+                                  <a:schemeClr val="tx1">
+                                    <a:alpha val="29000"/>
+                                  </a:schemeClr>
+                                </a:solidFill>
+                              </a:ln>
+                              <a:latin typeface="Cambria Math" panose="02040503050406030204" pitchFamily="18" charset="0"/>
+                              <a:ea typeface="맑은 고딕"/>
+                              <a:cs typeface="Times New Roman"/>
+                            </a:rPr>
+                            <m:t>𝑊𝐿</m:t>
+                          </m:r>
+                        </m:sub>
+                      </m:sSub>
+                      <m:r>
+                        <a:rPr lang="en-US" altLang="ko-KR" sz="800" b="0" i="1" smtClean="0">
+                          <a:ln w="9525">
+                            <a:solidFill>
+                              <a:schemeClr val="tx1">
+                                <a:alpha val="29000"/>
+                              </a:schemeClr>
+                            </a:solidFill>
+                          </a:ln>
+                          <a:latin typeface="Cambria Math" panose="02040503050406030204" pitchFamily="18" charset="0"/>
+                          <a:ea typeface="맑은 고딕"/>
+                          <a:cs typeface="Times New Roman"/>
+                        </a:rPr>
+                        <m:t>×</m:t>
+                      </m:r>
+                      <m:sSub>
+                        <m:sSubPr>
+                          <m:ctrlPr>
+                            <a:rPr lang="en-US" altLang="ko-KR" sz="800" b="0" i="1" smtClean="0">
+                              <a:ln w="9525">
+                                <a:solidFill>
+                                  <a:schemeClr val="tx1">
+                                    <a:alpha val="29000"/>
+                                  </a:schemeClr>
+                                </a:solidFill>
+                              </a:ln>
+                              <a:latin typeface="Cambria Math" panose="02040503050406030204" pitchFamily="18" charset="0"/>
+                              <a:ea typeface="맑은 고딕"/>
+                              <a:cs typeface="Times New Roman"/>
+                            </a:rPr>
+                          </m:ctrlPr>
+                        </m:sSubPr>
+                        <m:e>
+                          <m:d>
+                            <m:dPr>
+                              <m:begChr m:val="|"/>
+                              <m:endChr m:val="|"/>
+                              <m:ctrlPr>
+                                <a:rPr lang="en-US" altLang="ko-KR" sz="800" b="0" i="1" smtClean="0">
+                                  <a:ln w="9525">
+                                    <a:solidFill>
+                                      <a:schemeClr val="tx1">
+                                        <a:alpha val="29000"/>
+                                      </a:schemeClr>
+                                    </a:solidFill>
+                                  </a:ln>
+                                  <a:latin typeface="Cambria Math" panose="02040503050406030204" pitchFamily="18" charset="0"/>
+                                  <a:ea typeface="맑은 고딕"/>
+                                  <a:cs typeface="Times New Roman"/>
+                                </a:rPr>
+                              </m:ctrlPr>
+                            </m:dPr>
+                            <m:e>
+                              <m:r>
+                                <a:rPr lang="en-US" altLang="ko-KR" sz="800" b="0" i="1" smtClean="0">
+                                  <a:ln w="9525">
+                                    <a:solidFill>
+                                      <a:schemeClr val="tx1">
+                                        <a:alpha val="29000"/>
+                                      </a:schemeClr>
+                                    </a:solidFill>
+                                  </a:ln>
+                                  <a:latin typeface="Cambria Math" panose="02040503050406030204" pitchFamily="18" charset="0"/>
+                                  <a:ea typeface="맑은 고딕"/>
+                                  <a:cs typeface="Times New Roman"/>
+                                </a:rPr>
+                                <m:t>𝑇𝐶</m:t>
+                              </m:r>
+                            </m:e>
+                          </m:d>
+                        </m:e>
+                        <m:sub>
+                          <m:r>
+                            <a:rPr lang="en-US" altLang="ko-KR" sz="800" b="0" i="1" smtClean="0">
+                              <a:ln w="9525">
+                                <a:solidFill>
+                                  <a:schemeClr val="tx1">
+                                    <a:alpha val="29000"/>
+                                  </a:schemeClr>
+                                </a:solidFill>
+                              </a:ln>
+                              <a:latin typeface="Cambria Math" panose="02040503050406030204" pitchFamily="18" charset="0"/>
+                              <a:ea typeface="맑은 고딕"/>
+                              <a:cs typeface="Times New Roman"/>
+                            </a:rPr>
+                            <m:t>𝑊𝐿</m:t>
+                          </m:r>
+                        </m:sub>
+                      </m:sSub>
+                    </m:oMath>
+                  </a14:m>
+                  <a:r>
+                    <a:rPr lang="ko-KR" altLang="en-US" sz="800" dirty="0">
+                      <a:ln w="9525">
+                        <a:solidFill>
+                          <a:schemeClr val="tx1">
+                            <a:alpha val="29000"/>
+                          </a:schemeClr>
+                        </a:solidFill>
+                      </a:ln>
+                      <a:latin typeface="Times New Roman"/>
+                      <a:ea typeface="맑은 고딕"/>
+                      <a:cs typeface="Times New Roman"/>
+                    </a:rPr>
+                    <a:t> </a:t>
+                  </a:r>
+                </a:p>
+              </p:txBody>
+            </p:sp>
+          </mc:Choice>
+          <mc:Fallback xmlns="">
+            <p:sp>
+              <p:nvSpPr>
+                <p:cNvPr id="21" name="TextBox 20">
+                  <a:extLst>
+                    <a:ext uri="{FF2B5EF4-FFF2-40B4-BE49-F238E27FC236}">
+                      <a16:creationId xmlns:a16="http://schemas.microsoft.com/office/drawing/2014/main" id="{6803C50A-61E5-5F6C-A180-2212E0DA9561}"/>
+                    </a:ext>
+                  </a:extLst>
+                </p:cNvPr>
+                <p:cNvSpPr txBox="1">
+                  <a:spLocks noRot="1" noChangeAspect="1" noMove="1" noResize="1" noEditPoints="1" noAdjustHandles="1" noChangeArrowheads="1" noChangeShapeType="1" noTextEdit="1"/>
+                </p:cNvSpPr>
+                <p:nvPr/>
+              </p:nvSpPr>
+              <p:spPr>
+                <a:xfrm>
+                  <a:off x="1755807" y="4120522"/>
+                  <a:ext cx="1106459" cy="220958"/>
+                </a:xfrm>
+                <a:prstGeom prst="rect">
+                  <a:avLst/>
+                </a:prstGeom>
+                <a:blipFill>
+                  <a:blip r:embed="rId4"/>
+                  <a:stretch>
+                    <a:fillRect/>
+                  </a:stretch>
+                </a:blipFill>
+              </p:spPr>
+              <p:txBody>
+                <a:bodyPr/>
+                <a:lstStyle/>
+                <a:p>
+                  <a:r>
+                    <a:rPr lang="ko-KR" altLang="en-US">
+                      <a:noFill/>
+                    </a:rPr>
+                    <a:t> </a:t>
+                  </a:r>
+                </a:p>
+              </p:txBody>
+            </p:sp>
+          </mc:Fallback>
+        </mc:AlternateContent>
+        <p:sp>
+          <p:nvSpPr>
+            <p:cNvPr id="5" name="TextBox 4">
+              <a:extLst>
+                <a:ext uri="{FF2B5EF4-FFF2-40B4-BE49-F238E27FC236}">
+                  <a16:creationId xmlns:a16="http://schemas.microsoft.com/office/drawing/2014/main" id="{1CB1AD94-6D16-AB48-D166-299515E182A9}"/>
+                </a:ext>
+              </a:extLst>
+            </p:cNvPr>
+            <p:cNvSpPr txBox="1"/>
+            <p:nvPr/>
+          </p:nvSpPr>
+          <p:spPr>
+            <a:xfrm>
+              <a:off x="544132" y="2827561"/>
+              <a:ext cx="360492" cy="215444"/>
+            </a:xfrm>
+            <a:prstGeom prst="rect">
+              <a:avLst/>
+            </a:prstGeom>
+            <a:noFill/>
+          </p:spPr>
+          <p:txBody>
+            <a:bodyPr wrap="square" rtlCol="0">
+              <a:spAutoFit/>
+            </a:bodyPr>
+            <a:lstStyle/>
+            <a:p>
+              <a:r>
+                <a:rPr lang="en-US" altLang="ko-KR" sz="800" b="1" dirty="0">
+                  <a:latin typeface="Arial" panose="020B0604020202020204" pitchFamily="34" charset="0"/>
+                  <a:cs typeface="Arial" panose="020B0604020202020204" pitchFamily="34" charset="0"/>
+                </a:rPr>
+                <a:t>(a)</a:t>
+              </a:r>
+              <a:endParaRPr lang="ko-KR" altLang="en-US" sz="800" b="1" dirty="0">
+                <a:latin typeface="Arial" panose="020B0604020202020204" pitchFamily="34" charset="0"/>
+                <a:cs typeface="Arial" panose="020B0604020202020204" pitchFamily="34" charset="0"/>
+              </a:endParaRPr>
+            </a:p>
+          </p:txBody>
+        </p:sp>
+        <mc:AlternateContent xmlns:mc="http://schemas.openxmlformats.org/markup-compatibility/2006" xmlns:a14="http://schemas.microsoft.com/office/drawing/2010/main">
+          <mc:Choice Requires="a14">
+            <p:graphicFrame>
+              <p:nvGraphicFramePr>
+                <p:cNvPr id="16" name="개체 15">
+                  <a:extLst>
+                    <a:ext uri="{FF2B5EF4-FFF2-40B4-BE49-F238E27FC236}">
+                      <a16:creationId xmlns:a16="http://schemas.microsoft.com/office/drawing/2014/main" id="{FE9188F6-D8EC-1390-F1C7-A981564CDA03}"/>
+                    </a:ext>
+                  </a:extLst>
+                </p:cNvPr>
+                <p:cNvGraphicFramePr>
+                  <a:graphicFrameLocks noChangeAspect="1"/>
+                </p:cNvGraphicFramePr>
+                <p:nvPr>
+                  <p:extLst>
+                    <p:ext uri="{D42A27DB-BD31-4B8C-83A1-F6EECF244321}">
+                      <p14:modId xmlns:p14="http://schemas.microsoft.com/office/powerpoint/2010/main" val="4246772109"/>
+                    </p:ext>
+                  </p:extLst>
+                </p:nvPr>
+              </p:nvGraphicFramePr>
+              <p:xfrm>
+                <a:off x="840299" y="3559577"/>
+                <a:ext cx="2031490" cy="695292"/>
+              </p:xfrm>
+              <a:graphic>
+                <a:graphicData uri="http://schemas.openxmlformats.org/presentationml/2006/ole">
+                  <mc:AlternateContent>
+                    <mc:Choice xmlns:v="urn:schemas-microsoft-com:vml" Requires="v">
+                      <p:oleObj name="Graph" r:id="rId5" imgW="4684832" imgH="1603466" progId="Origin50.Graph">
+                        <p:embed/>
+                      </p:oleObj>
+                    </mc:Choice>
+                    <mc:Fallback>
+                      <p:oleObj name="Graph" r:id="rId5" imgW="4684832" imgH="1603466" progId="Origin50.Graph">
+                        <p:embed/>
+                        <p:pic>
+                          <p:nvPicPr>
+                            <p:cNvPr id="0" name=""/>
+                            <p:cNvPicPr/>
+                            <p:nvPr/>
+                          </p:nvPicPr>
+                          <p:blipFill>
+                            <a:blip r:embed="rId6"/>
+                            <a:stretch>
+                              <a:fillRect/>
+                            </a:stretch>
+                          </p:blipFill>
+                          <p:spPr>
+                            <a:xfrm>
+                              <a:off x="840299" y="3559577"/>
+                              <a:ext cx="2031490" cy="695292"/>
+                            </a:xfrm>
+                            <a:prstGeom prst="rect">
+                              <a:avLst/>
+                            </a:prstGeom>
+                          </p:spPr>
+                        </p:pic>
+                      </p:oleObj>
+                    </mc:Fallback>
+                  </mc:AlternateContent>
+                </a:graphicData>
+              </a:graphic>
+            </p:graphicFrame>
+          </mc:Choice>
+          <mc:Fallback xmlns="">
+            <p:graphicFrame>
+              <p:nvGraphicFramePr>
+                <p:cNvPr id="16" name="개체 15">
+                  <a:extLst>
+                    <a:ext uri="{FF2B5EF4-FFF2-40B4-BE49-F238E27FC236}">
+                      <a16:creationId xmlns:a16="http://schemas.microsoft.com/office/drawing/2014/main" id="{FE9188F6-D8EC-1390-F1C7-A981564CDA03}"/>
+                    </a:ext>
+                  </a:extLst>
+                </p:cNvPr>
+                <p:cNvGraphicFramePr>
+                  <a:graphicFrameLocks noChangeAspect="1"/>
+                </p:cNvGraphicFramePr>
+                <p:nvPr>
+                  <p:extLst>
+                    <p:ext uri="{D42A27DB-BD31-4B8C-83A1-F6EECF244321}">
+                      <p14:modId xmlns:p14="http://schemas.microsoft.com/office/powerpoint/2010/main" val="4246772109"/>
+                    </p:ext>
+                  </p:extLst>
+                </p:nvPr>
+              </p:nvGraphicFramePr>
+              <p:xfrm>
+                <a:off x="840299" y="3559577"/>
+                <a:ext cx="2031490" cy="695292"/>
+              </p:xfrm>
+              <a:graphic>
+                <a:graphicData uri="http://schemas.openxmlformats.org/presentationml/2006/ole">
+                  <mc:AlternateContent>
+                    <mc:Choice xmlns:v="urn:schemas-microsoft-com:vml" Requires="v">
+                      <p:oleObj name="Graph" r:id="rId7" imgW="4684832" imgH="1603466" progId="Origin50.Graph">
+                        <p:embed/>
+                      </p:oleObj>
+                    </mc:Choice>
+                    <mc:Fallback>
+                      <p:oleObj name="Graph" r:id="rId7" imgW="4684832" imgH="1603466" progId="Origin50.Graph">
+                        <p:embed/>
+                        <p:pic>
+                          <p:nvPicPr>
+                            <p:cNvPr id="0" name=""/>
+                            <p:cNvPicPr/>
+                            <p:nvPr/>
+                          </p:nvPicPr>
+                          <p:blipFill>
+                            <a:blip r:embed="rId8"/>
+                            <a:stretch>
+                              <a:fillRect/>
+                            </a:stretch>
+                          </p:blipFill>
+                          <p:spPr>
+                            <a:xfrm>
+                              <a:off x="840299" y="3559577"/>
+                              <a:ext cx="2031490" cy="695292"/>
+                            </a:xfrm>
+                            <a:prstGeom prst="rect">
+                              <a:avLst/>
+                            </a:prstGeom>
+                          </p:spPr>
+                        </p:pic>
+                      </p:oleObj>
+                    </mc:Fallback>
+                  </mc:AlternateContent>
+                </a:graphicData>
+              </a:graphic>
+            </p:graphicFrame>
+          </mc:Fallback>
+        </mc:AlternateContent>
+        <p:sp>
+          <p:nvSpPr>
+            <p:cNvPr id="17" name="곱하기 기호 16">
+              <a:extLst>
+                <a:ext uri="{FF2B5EF4-FFF2-40B4-BE49-F238E27FC236}">
+                  <a16:creationId xmlns:a16="http://schemas.microsoft.com/office/drawing/2014/main" id="{9388F6D5-F284-8CA6-6A1D-89F477D0E8F3}"/>
+                </a:ext>
+              </a:extLst>
+            </p:cNvPr>
+            <p:cNvSpPr/>
+            <p:nvPr/>
+          </p:nvSpPr>
+          <p:spPr>
+            <a:xfrm>
+              <a:off x="1701379" y="3931149"/>
+              <a:ext cx="108857" cy="108857"/>
+            </a:xfrm>
+            <a:prstGeom prst="mathMultiply">
+              <a:avLst>
+                <a:gd name="adj1" fmla="val 6378"/>
+              </a:avLst>
+            </a:prstGeom>
+            <a:solidFill>
+              <a:schemeClr val="tx1"/>
+            </a:solidFill>
+            <a:ln>
+              <a:solidFill>
+                <a:schemeClr val="tx1"/>
+              </a:solidFill>
+            </a:ln>
+          </p:spPr>
+          <p:style>
+            <a:lnRef idx="2">
+              <a:schemeClr val="accent1">
+                <a:shade val="20000"/>
+              </a:schemeClr>
+            </a:lnRef>
+            <a:fillRef idx="1">
+              <a:schemeClr val="accent1"/>
+            </a:fillRef>
+            <a:effectRef idx="0">
+              <a:schemeClr val="accent1"/>
+            </a:effectRef>
+            <a:fontRef idx="minor">
+              <a:schemeClr val="lt1"/>
+            </a:fontRef>
+          </p:style>
+          <p:txBody>
+            <a:bodyPr rtlCol="0" anchor="ctr"/>
+            <a:lstStyle/>
+            <a:p>
+              <a:pPr algn="ctr"/>
+              <a:endParaRPr lang="ko-KR" altLang="en-US" sz="1000"/>
+            </a:p>
+          </p:txBody>
+        </p:sp>
         <p:cxnSp>
           <p:nvCxnSpPr>
-            <p:cNvPr id="13" name="직선 화살표 연결선 12">
+            <p:cNvPr id="18" name="직선 화살표 연결선 17">
               <a:extLst>
                 <a:ext uri="{FF2B5EF4-FFF2-40B4-BE49-F238E27FC236}">
-                  <a16:creationId xmlns:a16="http://schemas.microsoft.com/office/drawing/2014/main" id="{BDBD7211-70B4-CDD9-7DF8-3F89B8CBB2CA}"/>
+                  <a16:creationId xmlns:a16="http://schemas.microsoft.com/office/drawing/2014/main" id="{6E657C14-669A-83F8-355B-F484DE978FBF}"/>
+                </a:ext>
+              </a:extLst>
+            </p:cNvPr>
+            <p:cNvCxnSpPr>
+              <a:cxnSpLocks/>
+            </p:cNvCxnSpPr>
+            <p:nvPr/>
+          </p:nvCxnSpPr>
+          <p:spPr>
+            <a:xfrm flipH="1">
+              <a:off x="952500" y="3985577"/>
+              <a:ext cx="748879" cy="0"/>
+            </a:xfrm>
+            <a:prstGeom prst="straightConnector1">
+              <a:avLst/>
+            </a:prstGeom>
+            <a:ln w="28575">
+              <a:solidFill>
+                <a:schemeClr val="tx1"/>
+              </a:solidFill>
+              <a:tailEnd type="triangle"/>
+            </a:ln>
+          </p:spPr>
+          <p:style>
+            <a:lnRef idx="1">
+              <a:schemeClr val="accent1"/>
+            </a:lnRef>
+            <a:fillRef idx="0">
+              <a:schemeClr val="accent1"/>
+            </a:fillRef>
+            <a:effectRef idx="0">
+              <a:schemeClr val="accent1"/>
+            </a:effectRef>
+            <a:fontRef idx="minor">
+              <a:schemeClr val="tx1"/>
+            </a:fontRef>
+          </p:style>
+        </p:cxnSp>
+        <p:cxnSp>
+          <p:nvCxnSpPr>
+            <p:cNvPr id="19" name="직선 화살표 연결선 18">
+              <a:extLst>
+                <a:ext uri="{FF2B5EF4-FFF2-40B4-BE49-F238E27FC236}">
+                  <a16:creationId xmlns:a16="http://schemas.microsoft.com/office/drawing/2014/main" id="{1C631D80-CFBB-5801-AFE3-2C2A6538FCBC}"/>
                 </a:ext>
               </a:extLst>
             </p:cNvPr>
@@ -13486,8 +14372,747 @@
           </p:nvCxnSpPr>
           <p:spPr>
             <a:xfrm>
-              <a:off x="3461636" y="3467801"/>
-              <a:ext cx="0" cy="1238291"/>
+              <a:off x="1810236" y="3985577"/>
+              <a:ext cx="990168" cy="0"/>
+            </a:xfrm>
+            <a:prstGeom prst="straightConnector1">
+              <a:avLst/>
+            </a:prstGeom>
+            <a:ln w="28575">
+              <a:solidFill>
+                <a:schemeClr val="tx1"/>
+              </a:solidFill>
+              <a:prstDash val="sysDash"/>
+              <a:tailEnd type="triangle"/>
+            </a:ln>
+          </p:spPr>
+          <p:style>
+            <a:lnRef idx="1">
+              <a:schemeClr val="accent1"/>
+            </a:lnRef>
+            <a:fillRef idx="0">
+              <a:schemeClr val="accent1"/>
+            </a:fillRef>
+            <a:effectRef idx="0">
+              <a:schemeClr val="accent1"/>
+            </a:effectRef>
+            <a:fontRef idx="minor">
+              <a:schemeClr val="tx1"/>
+            </a:fontRef>
+          </p:style>
+        </p:cxnSp>
+        <p:sp>
+          <p:nvSpPr>
+            <p:cNvPr id="4" name="TextBox 3">
+              <a:extLst>
+                <a:ext uri="{FF2B5EF4-FFF2-40B4-BE49-F238E27FC236}">
+                  <a16:creationId xmlns:a16="http://schemas.microsoft.com/office/drawing/2014/main" id="{66E802A9-74FD-7888-C9ED-71EE57D06572}"/>
+                </a:ext>
+              </a:extLst>
+            </p:cNvPr>
+            <p:cNvSpPr txBox="1"/>
+            <p:nvPr/>
+          </p:nvSpPr>
+          <p:spPr>
+            <a:xfrm>
+              <a:off x="544133" y="4352951"/>
+              <a:ext cx="360492" cy="215444"/>
+            </a:xfrm>
+            <a:prstGeom prst="rect">
+              <a:avLst/>
+            </a:prstGeom>
+            <a:noFill/>
+          </p:spPr>
+          <p:txBody>
+            <a:bodyPr wrap="square" rtlCol="0">
+              <a:spAutoFit/>
+            </a:bodyPr>
+            <a:lstStyle/>
+            <a:p>
+              <a:r>
+                <a:rPr lang="en-US" altLang="ko-KR" sz="800" b="1" dirty="0">
+                  <a:latin typeface="Arial" panose="020B0604020202020204" pitchFamily="34" charset="0"/>
+                  <a:cs typeface="Arial" panose="020B0604020202020204" pitchFamily="34" charset="0"/>
+                </a:rPr>
+                <a:t>(b)</a:t>
+              </a:r>
+              <a:endParaRPr lang="ko-KR" altLang="en-US" sz="800" b="1" dirty="0">
+                <a:latin typeface="Arial" panose="020B0604020202020204" pitchFamily="34" charset="0"/>
+                <a:cs typeface="Arial" panose="020B0604020202020204" pitchFamily="34" charset="0"/>
+              </a:endParaRPr>
+            </a:p>
+          </p:txBody>
+        </p:sp>
+        <mc:AlternateContent xmlns:mc="http://schemas.openxmlformats.org/markup-compatibility/2006" xmlns:a14="http://schemas.microsoft.com/office/drawing/2010/main">
+          <mc:Choice Requires="a14">
+            <p:graphicFrame>
+              <p:nvGraphicFramePr>
+                <p:cNvPr id="2" name="개체 1">
+                  <a:extLst>
+                    <a:ext uri="{FF2B5EF4-FFF2-40B4-BE49-F238E27FC236}">
+                      <a16:creationId xmlns:a16="http://schemas.microsoft.com/office/drawing/2014/main" id="{1AC33133-8D65-1B94-57AA-17E0ABA7F4BD}"/>
+                    </a:ext>
+                  </a:extLst>
+                </p:cNvPr>
+                <p:cNvGraphicFramePr>
+                  <a:graphicFrameLocks noChangeAspect="1"/>
+                </p:cNvGraphicFramePr>
+                <p:nvPr>
+                  <p:extLst>
+                    <p:ext uri="{D42A27DB-BD31-4B8C-83A1-F6EECF244321}">
+                      <p14:modId xmlns:p14="http://schemas.microsoft.com/office/powerpoint/2010/main" val="3474027108"/>
+                    </p:ext>
+                  </p:extLst>
+                </p:nvPr>
+              </p:nvGraphicFramePr>
+              <p:xfrm>
+                <a:off x="608653" y="4373462"/>
+                <a:ext cx="2737259" cy="1442697"/>
+              </p:xfrm>
+              <a:graphic>
+                <a:graphicData uri="http://schemas.openxmlformats.org/presentationml/2006/ole">
+                  <mc:AlternateContent>
+                    <mc:Choice xmlns:v="urn:schemas-microsoft-com:vml" Requires="v">
+                      <p:oleObj name="Graph" r:id="rId9" imgW="4722409" imgH="2488474" progId="Origin50.Graph">
+                        <p:embed/>
+                      </p:oleObj>
+                    </mc:Choice>
+                    <mc:Fallback>
+                      <p:oleObj name="Graph" r:id="rId9" imgW="4722409" imgH="2488474" progId="Origin50.Graph">
+                        <p:embed/>
+                        <p:pic>
+                          <p:nvPicPr>
+                            <p:cNvPr id="0" name=""/>
+                            <p:cNvPicPr/>
+                            <p:nvPr/>
+                          </p:nvPicPr>
+                          <p:blipFill>
+                            <a:blip r:embed="rId10"/>
+                            <a:stretch>
+                              <a:fillRect/>
+                            </a:stretch>
+                          </p:blipFill>
+                          <p:spPr>
+                            <a:xfrm>
+                              <a:off x="608653" y="4373462"/>
+                              <a:ext cx="2737259" cy="1442697"/>
+                            </a:xfrm>
+                            <a:prstGeom prst="rect">
+                              <a:avLst/>
+                            </a:prstGeom>
+                          </p:spPr>
+                        </p:pic>
+                      </p:oleObj>
+                    </mc:Fallback>
+                  </mc:AlternateContent>
+                </a:graphicData>
+              </a:graphic>
+            </p:graphicFrame>
+          </mc:Choice>
+          <mc:Fallback xmlns="">
+            <p:graphicFrame>
+              <p:nvGraphicFramePr>
+                <p:cNvPr id="2" name="개체 1">
+                  <a:extLst>
+                    <a:ext uri="{FF2B5EF4-FFF2-40B4-BE49-F238E27FC236}">
+                      <a16:creationId xmlns:a16="http://schemas.microsoft.com/office/drawing/2014/main" id="{1AC33133-8D65-1B94-57AA-17E0ABA7F4BD}"/>
+                    </a:ext>
+                  </a:extLst>
+                </p:cNvPr>
+                <p:cNvGraphicFramePr>
+                  <a:graphicFrameLocks noChangeAspect="1"/>
+                </p:cNvGraphicFramePr>
+                <p:nvPr>
+                  <p:extLst>
+                    <p:ext uri="{D42A27DB-BD31-4B8C-83A1-F6EECF244321}">
+                      <p14:modId xmlns:p14="http://schemas.microsoft.com/office/powerpoint/2010/main" val="3474027108"/>
+                    </p:ext>
+                  </p:extLst>
+                </p:nvPr>
+              </p:nvGraphicFramePr>
+              <p:xfrm>
+                <a:off x="608653" y="4373462"/>
+                <a:ext cx="2737259" cy="1442697"/>
+              </p:xfrm>
+              <a:graphic>
+                <a:graphicData uri="http://schemas.openxmlformats.org/presentationml/2006/ole">
+                  <mc:AlternateContent>
+                    <mc:Choice xmlns:v="urn:schemas-microsoft-com:vml" Requires="v">
+                      <p:oleObj name="Graph" r:id="rId11" imgW="4722409" imgH="2488474" progId="Origin50.Graph">
+                        <p:embed/>
+                      </p:oleObj>
+                    </mc:Choice>
+                    <mc:Fallback>
+                      <p:oleObj name="Graph" r:id="rId11" imgW="4722409" imgH="2488474" progId="Origin50.Graph">
+                        <p:embed/>
+                        <p:pic>
+                          <p:nvPicPr>
+                            <p:cNvPr id="0" name=""/>
+                            <p:cNvPicPr/>
+                            <p:nvPr/>
+                          </p:nvPicPr>
+                          <p:blipFill>
+                            <a:blip r:embed="rId12"/>
+                            <a:stretch>
+                              <a:fillRect/>
+                            </a:stretch>
+                          </p:blipFill>
+                          <p:spPr>
+                            <a:xfrm>
+                              <a:off x="608653" y="4373462"/>
+                              <a:ext cx="2737259" cy="1442697"/>
+                            </a:xfrm>
+                            <a:prstGeom prst="rect">
+                              <a:avLst/>
+                            </a:prstGeom>
+                          </p:spPr>
+                        </p:pic>
+                      </p:oleObj>
+                    </mc:Fallback>
+                  </mc:AlternateContent>
+                </a:graphicData>
+              </a:graphic>
+            </p:graphicFrame>
+          </mc:Fallback>
+        </mc:AlternateContent>
+      </p:grpSp>
+      <p:grpSp>
+        <p:nvGrpSpPr>
+          <p:cNvPr id="43" name="그룹 42">
+            <a:extLst>
+              <a:ext uri="{FF2B5EF4-FFF2-40B4-BE49-F238E27FC236}">
+                <a16:creationId xmlns:a16="http://schemas.microsoft.com/office/drawing/2014/main" id="{24EF8B61-8554-5BB1-28E5-113933794F64}"/>
+              </a:ext>
+            </a:extLst>
+          </p:cNvPr>
+          <p:cNvGrpSpPr/>
+          <p:nvPr/>
+        </p:nvGrpSpPr>
+        <p:grpSpPr>
+          <a:xfrm>
+            <a:off x="2862266" y="2826332"/>
+            <a:ext cx="1181923" cy="2655182"/>
+            <a:chOff x="2862266" y="2826332"/>
+            <a:chExt cx="1181923" cy="2655182"/>
+          </a:xfrm>
+        </p:grpSpPr>
+        <p:sp>
+          <p:nvSpPr>
+            <p:cNvPr id="24" name="사각형: 둥근 모서리 23">
+              <a:extLst>
+                <a:ext uri="{FF2B5EF4-FFF2-40B4-BE49-F238E27FC236}">
+                  <a16:creationId xmlns:a16="http://schemas.microsoft.com/office/drawing/2014/main" id="{C8EA09ED-880F-1CC4-15E9-BDC9C6ADFCD4}"/>
+                </a:ext>
+              </a:extLst>
+            </p:cNvPr>
+            <p:cNvSpPr/>
+            <p:nvPr/>
+          </p:nvSpPr>
+          <p:spPr>
+            <a:xfrm>
+              <a:off x="3132964" y="2992488"/>
+              <a:ext cx="911225" cy="530225"/>
+            </a:xfrm>
+            <a:prstGeom prst="roundRect">
+              <a:avLst/>
+            </a:prstGeom>
+            <a:noFill/>
+            <a:ln>
+              <a:solidFill>
+                <a:schemeClr val="tx1"/>
+              </a:solidFill>
+            </a:ln>
+          </p:spPr>
+          <p:style>
+            <a:lnRef idx="2">
+              <a:schemeClr val="accent1">
+                <a:shade val="15000"/>
+              </a:schemeClr>
+            </a:lnRef>
+            <a:fillRef idx="1">
+              <a:schemeClr val="accent1"/>
+            </a:fillRef>
+            <a:effectRef idx="0">
+              <a:schemeClr val="accent1"/>
+            </a:effectRef>
+            <a:fontRef idx="minor">
+              <a:schemeClr val="lt1"/>
+            </a:fontRef>
+          </p:style>
+          <p:txBody>
+            <a:bodyPr rtlCol="0" anchor="ctr"/>
+            <a:lstStyle/>
+            <a:p>
+              <a:pPr marL="0" marR="0" lvl="0" indent="0" algn="ctr" defTabSz="457200" rtl="0" eaLnBrk="1" fontAlgn="auto" latinLnBrk="0" hangingPunct="1">
+                <a:lnSpc>
+                  <a:spcPct val="100000"/>
+                </a:lnSpc>
+                <a:spcBef>
+                  <a:spcPts val="0"/>
+                </a:spcBef>
+                <a:spcAft>
+                  <a:spcPts val="0"/>
+                </a:spcAft>
+                <a:buClrTx/>
+                <a:buSzTx/>
+                <a:buFontTx/>
+                <a:buNone/>
+                <a:tabLst/>
+                <a:defRPr/>
+              </a:pPr>
+              <a:r>
+                <a:rPr kumimoji="0" lang="en-US" altLang="ko-KR" sz="800" b="0" i="0" u="none" strike="noStrike" kern="1200" cap="none" spc="0" normalizeH="0" baseline="0" noProof="0">
+                  <a:ln>
+                    <a:noFill/>
+                  </a:ln>
+                  <a:solidFill>
+                    <a:prstClr val="black"/>
+                  </a:solidFill>
+                  <a:effectLst/>
+                  <a:uLnTx/>
+                  <a:uFillTx/>
+                  <a:latin typeface="Arial" panose="020B0604020202020204" pitchFamily="34" charset="0"/>
+                  <a:ea typeface="맑은 고딕" panose="020B0503020000020004" pitchFamily="50" charset="-127"/>
+                  <a:cs typeface="Arial" panose="020B0604020202020204" pitchFamily="34" charset="0"/>
+                </a:rPr>
+                <a:t>Initial cell information</a:t>
+              </a:r>
+              <a:br>
+                <a:rPr kumimoji="0" lang="en-US" altLang="ko-KR" sz="800" b="0" i="0" u="none" strike="noStrike" kern="1200" cap="none" spc="0" normalizeH="0" baseline="0" noProof="0">
+                  <a:ln>
+                    <a:noFill/>
+                  </a:ln>
+                  <a:solidFill>
+                    <a:prstClr val="black"/>
+                  </a:solidFill>
+                  <a:effectLst/>
+                  <a:uLnTx/>
+                  <a:uFillTx/>
+                  <a:latin typeface="Arial" panose="020B0604020202020204" pitchFamily="34" charset="0"/>
+                  <a:ea typeface="맑은 고딕" panose="020B0503020000020004" pitchFamily="50" charset="-127"/>
+                  <a:cs typeface="Arial" panose="020B0604020202020204" pitchFamily="34" charset="0"/>
+                </a:rPr>
+              </a:br>
+              <a:r>
+                <a:rPr kumimoji="0" lang="en-US" altLang="ko-KR" sz="800" b="0" i="0" u="none" strike="noStrike" kern="1200" cap="none" spc="0" normalizeH="0" baseline="0" noProof="0">
+                  <a:ln>
+                    <a:noFill/>
+                  </a:ln>
+                  <a:solidFill>
+                    <a:prstClr val="black"/>
+                  </a:solidFill>
+                  <a:effectLst/>
+                  <a:uLnTx/>
+                  <a:uFillTx/>
+                  <a:latin typeface="Arial" panose="020B0604020202020204" pitchFamily="34" charset="0"/>
+                  <a:ea typeface="맑은 고딕" panose="020B0503020000020004" pitchFamily="50" charset="-127"/>
+                  <a:cs typeface="Arial" panose="020B0604020202020204" pitchFamily="34" charset="0"/>
+                </a:rPr>
+                <a:t>&amp;</a:t>
+              </a:r>
+            </a:p>
+            <a:p>
+              <a:pPr marL="0" marR="0" lvl="0" indent="0" algn="ctr" defTabSz="457200" rtl="0" eaLnBrk="1" fontAlgn="auto" latinLnBrk="0" hangingPunct="1">
+                <a:lnSpc>
+                  <a:spcPct val="100000"/>
+                </a:lnSpc>
+                <a:spcBef>
+                  <a:spcPts val="0"/>
+                </a:spcBef>
+                <a:spcAft>
+                  <a:spcPts val="0"/>
+                </a:spcAft>
+                <a:buClrTx/>
+                <a:buSzTx/>
+                <a:buFontTx/>
+                <a:buNone/>
+                <a:tabLst/>
+                <a:defRPr/>
+              </a:pPr>
+              <a:r>
+                <a:rPr kumimoji="0" lang="en-US" altLang="ko-KR" sz="800" b="0" i="0" u="none" strike="noStrike" kern="1200" cap="none" spc="0" normalizeH="0" baseline="0" noProof="0">
+                  <a:ln>
+                    <a:noFill/>
+                  </a:ln>
+                  <a:solidFill>
+                    <a:prstClr val="black"/>
+                  </a:solidFill>
+                  <a:effectLst/>
+                  <a:uLnTx/>
+                  <a:uFillTx/>
+                  <a:latin typeface="Arial" panose="020B0604020202020204" pitchFamily="34" charset="0"/>
+                  <a:ea typeface="맑은 고딕" panose="020B0503020000020004" pitchFamily="50" charset="-127"/>
+                  <a:cs typeface="Arial" panose="020B0604020202020204" pitchFamily="34" charset="0"/>
+                </a:rPr>
+                <a:t>Band profile</a:t>
+              </a:r>
+              <a:endParaRPr kumimoji="0" lang="ko-KR" altLang="en-US" sz="800" b="0" i="0" u="none" strike="noStrike" kern="1200" cap="none" spc="0" normalizeH="0" baseline="0" noProof="0">
+                <a:ln>
+                  <a:noFill/>
+                </a:ln>
+                <a:solidFill>
+                  <a:prstClr val="black"/>
+                </a:solidFill>
+                <a:effectLst/>
+                <a:uLnTx/>
+                <a:uFillTx/>
+                <a:latin typeface="Arial" panose="020B0604020202020204" pitchFamily="34" charset="0"/>
+                <a:ea typeface="맑은 고딕" panose="020B0503020000020004" pitchFamily="50" charset="-127"/>
+                <a:cs typeface="Arial" panose="020B0604020202020204" pitchFamily="34" charset="0"/>
+              </a:endParaRPr>
+            </a:p>
+          </p:txBody>
+        </p:sp>
+        <p:sp>
+          <p:nvSpPr>
+            <p:cNvPr id="25" name="사각형: 둥근 모서리 24">
+              <a:extLst>
+                <a:ext uri="{FF2B5EF4-FFF2-40B4-BE49-F238E27FC236}">
+                  <a16:creationId xmlns:a16="http://schemas.microsoft.com/office/drawing/2014/main" id="{B7D2D3C3-6AE1-1B17-5518-16A5BF4AFCCC}"/>
+                </a:ext>
+              </a:extLst>
+            </p:cNvPr>
+            <p:cNvSpPr/>
+            <p:nvPr/>
+          </p:nvSpPr>
+          <p:spPr>
+            <a:xfrm>
+              <a:off x="3132964" y="3830627"/>
+              <a:ext cx="911225" cy="530225"/>
+            </a:xfrm>
+            <a:prstGeom prst="roundRect">
+              <a:avLst/>
+            </a:prstGeom>
+            <a:noFill/>
+            <a:ln>
+              <a:solidFill>
+                <a:schemeClr val="tx1"/>
+              </a:solidFill>
+            </a:ln>
+          </p:spPr>
+          <p:style>
+            <a:lnRef idx="2">
+              <a:schemeClr val="accent1">
+                <a:shade val="15000"/>
+              </a:schemeClr>
+            </a:lnRef>
+            <a:fillRef idx="1">
+              <a:schemeClr val="accent1"/>
+            </a:fillRef>
+            <a:effectRef idx="0">
+              <a:schemeClr val="accent1"/>
+            </a:effectRef>
+            <a:fontRef idx="minor">
+              <a:schemeClr val="lt1"/>
+            </a:fontRef>
+          </p:style>
+          <p:txBody>
+            <a:bodyPr rtlCol="0" anchor="ctr"/>
+            <a:lstStyle/>
+            <a:p>
+              <a:pPr algn="ctr"/>
+              <a:r>
+                <a:rPr lang="en-US" altLang="ko-KR" sz="800">
+                  <a:solidFill>
+                    <a:schemeClr val="tx1"/>
+                  </a:solidFill>
+                  <a:latin typeface="Arial" panose="020B0604020202020204" pitchFamily="34" charset="0"/>
+                  <a:cs typeface="Arial" panose="020B0604020202020204" pitchFamily="34" charset="0"/>
+                </a:rPr>
+                <a:t>Autonomous detrapping based on</a:t>
+              </a:r>
+              <a:r>
+                <a:rPr lang="ko-KR" altLang="en-US" sz="800">
+                  <a:solidFill>
+                    <a:schemeClr val="tx1"/>
+                  </a:solidFill>
+                  <a:latin typeface="Arial" panose="020B0604020202020204" pitchFamily="34" charset="0"/>
+                  <a:cs typeface="Arial" panose="020B0604020202020204" pitchFamily="34" charset="0"/>
+                </a:rPr>
+                <a:t> </a:t>
+              </a:r>
+              <a:r>
+                <a:rPr lang="en-US" altLang="ko-KR" sz="800">
+                  <a:solidFill>
+                    <a:schemeClr val="tx1"/>
+                  </a:solidFill>
+                  <a:latin typeface="Arial" panose="020B0604020202020204" pitchFamily="34" charset="0"/>
+                  <a:cs typeface="Arial" panose="020B0604020202020204" pitchFamily="34" charset="0"/>
+                </a:rPr>
+                <a:t>emission</a:t>
+              </a:r>
+              <a:r>
+                <a:rPr lang="ko-KR" altLang="en-US" sz="800">
+                  <a:solidFill>
+                    <a:schemeClr val="tx1"/>
+                  </a:solidFill>
+                  <a:latin typeface="Arial" panose="020B0604020202020204" pitchFamily="34" charset="0"/>
+                  <a:cs typeface="Arial" panose="020B0604020202020204" pitchFamily="34" charset="0"/>
+                </a:rPr>
+                <a:t> </a:t>
+              </a:r>
+              <a:r>
+                <a:rPr lang="en-US" altLang="ko-KR" sz="800">
+                  <a:solidFill>
+                    <a:schemeClr val="tx1"/>
+                  </a:solidFill>
+                  <a:latin typeface="Arial" panose="020B0604020202020204" pitchFamily="34" charset="0"/>
+                  <a:cs typeface="Arial" panose="020B0604020202020204" pitchFamily="34" charset="0"/>
+                </a:rPr>
+                <a:t>rate</a:t>
+              </a:r>
+              <a:endParaRPr lang="ko-KR" altLang="en-US" sz="800" dirty="0">
+                <a:solidFill>
+                  <a:schemeClr val="tx1"/>
+                </a:solidFill>
+                <a:latin typeface="Arial" panose="020B0604020202020204" pitchFamily="34" charset="0"/>
+                <a:cs typeface="Arial" panose="020B0604020202020204" pitchFamily="34" charset="0"/>
+              </a:endParaRPr>
+            </a:p>
+          </p:txBody>
+        </p:sp>
+        <p:sp>
+          <p:nvSpPr>
+            <p:cNvPr id="26" name="사각형: 둥근 모서리 25">
+              <a:extLst>
+                <a:ext uri="{FF2B5EF4-FFF2-40B4-BE49-F238E27FC236}">
+                  <a16:creationId xmlns:a16="http://schemas.microsoft.com/office/drawing/2014/main" id="{785E6B8B-D1AE-D03E-FD49-A3FB7DE0C17D}"/>
+                </a:ext>
+              </a:extLst>
+            </p:cNvPr>
+            <p:cNvSpPr/>
+            <p:nvPr/>
+          </p:nvSpPr>
+          <p:spPr>
+            <a:xfrm>
+              <a:off x="3132964" y="4668766"/>
+              <a:ext cx="911225" cy="328348"/>
+            </a:xfrm>
+            <a:prstGeom prst="roundRect">
+              <a:avLst/>
+            </a:prstGeom>
+            <a:noFill/>
+            <a:ln>
+              <a:solidFill>
+                <a:schemeClr val="tx1"/>
+              </a:solidFill>
+            </a:ln>
+          </p:spPr>
+          <p:style>
+            <a:lnRef idx="2">
+              <a:schemeClr val="accent1">
+                <a:shade val="15000"/>
+              </a:schemeClr>
+            </a:lnRef>
+            <a:fillRef idx="1">
+              <a:schemeClr val="accent1"/>
+            </a:fillRef>
+            <a:effectRef idx="0">
+              <a:schemeClr val="accent1"/>
+            </a:effectRef>
+            <a:fontRef idx="minor">
+              <a:schemeClr val="lt1"/>
+            </a:fontRef>
+          </p:style>
+          <p:txBody>
+            <a:bodyPr rtlCol="0" anchor="ctr"/>
+            <a:lstStyle/>
+            <a:p>
+              <a:pPr algn="ctr"/>
+              <a:r>
+                <a:rPr lang="en-US" altLang="ko-KR" sz="800">
+                  <a:solidFill>
+                    <a:schemeClr val="tx1"/>
+                  </a:solidFill>
+                  <a:latin typeface="Arial" panose="020B0604020202020204" pitchFamily="34" charset="0"/>
+                  <a:cs typeface="Arial" panose="020B0604020202020204" pitchFamily="34" charset="0"/>
+                </a:rPr>
+                <a:t>ΔVth transition</a:t>
+              </a:r>
+              <a:endParaRPr lang="ko-KR" altLang="en-US" sz="800" dirty="0">
+                <a:solidFill>
+                  <a:schemeClr val="tx1"/>
+                </a:solidFill>
+                <a:latin typeface="Arial" panose="020B0604020202020204" pitchFamily="34" charset="0"/>
+                <a:cs typeface="Arial" panose="020B0604020202020204" pitchFamily="34" charset="0"/>
+              </a:endParaRPr>
+            </a:p>
+          </p:txBody>
+        </p:sp>
+        <p:sp>
+          <p:nvSpPr>
+            <p:cNvPr id="27" name="사각형: 둥근 모서리 26">
+              <a:extLst>
+                <a:ext uri="{FF2B5EF4-FFF2-40B4-BE49-F238E27FC236}">
+                  <a16:creationId xmlns:a16="http://schemas.microsoft.com/office/drawing/2014/main" id="{C3243A72-743F-42DB-032C-FB9E6FFA2E27}"/>
+                </a:ext>
+              </a:extLst>
+            </p:cNvPr>
+            <p:cNvSpPr/>
+            <p:nvPr/>
+          </p:nvSpPr>
+          <p:spPr>
+            <a:xfrm>
+              <a:off x="3132964" y="5305028"/>
+              <a:ext cx="911225" cy="176486"/>
+            </a:xfrm>
+            <a:prstGeom prst="roundRect">
+              <a:avLst/>
+            </a:prstGeom>
+            <a:noFill/>
+            <a:ln>
+              <a:solidFill>
+                <a:schemeClr val="tx1"/>
+              </a:solidFill>
+            </a:ln>
+          </p:spPr>
+          <p:style>
+            <a:lnRef idx="2">
+              <a:schemeClr val="accent1">
+                <a:shade val="15000"/>
+              </a:schemeClr>
+            </a:lnRef>
+            <a:fillRef idx="1">
+              <a:schemeClr val="accent1"/>
+            </a:fillRef>
+            <a:effectRef idx="0">
+              <a:schemeClr val="accent1"/>
+            </a:effectRef>
+            <a:fontRef idx="minor">
+              <a:schemeClr val="lt1"/>
+            </a:fontRef>
+          </p:style>
+          <p:txBody>
+            <a:bodyPr rtlCol="0" anchor="ctr"/>
+            <a:lstStyle/>
+            <a:p>
+              <a:pPr algn="ctr"/>
+              <a:r>
+                <a:rPr lang="en-US" altLang="ko-KR" sz="800">
+                  <a:solidFill>
+                    <a:schemeClr val="tx1"/>
+                  </a:solidFill>
+                  <a:latin typeface="Arial" panose="020B0604020202020204" pitchFamily="34" charset="0"/>
+                  <a:cs typeface="Arial" panose="020B0604020202020204" pitchFamily="34" charset="0"/>
+                </a:rPr>
+                <a:t>Result</a:t>
+              </a:r>
+              <a:endParaRPr lang="ko-KR" altLang="en-US" sz="800" dirty="0">
+                <a:solidFill>
+                  <a:schemeClr val="tx1"/>
+                </a:solidFill>
+                <a:latin typeface="Arial" panose="020B0604020202020204" pitchFamily="34" charset="0"/>
+                <a:cs typeface="Arial" panose="020B0604020202020204" pitchFamily="34" charset="0"/>
+              </a:endParaRPr>
+            </a:p>
+          </p:txBody>
+        </p:sp>
+        <p:cxnSp>
+          <p:nvCxnSpPr>
+            <p:cNvPr id="30" name="직선 화살표 연결선 29">
+              <a:extLst>
+                <a:ext uri="{FF2B5EF4-FFF2-40B4-BE49-F238E27FC236}">
+                  <a16:creationId xmlns:a16="http://schemas.microsoft.com/office/drawing/2014/main" id="{AC415680-A758-BF9E-972E-124841EC1C84}"/>
+                </a:ext>
+              </a:extLst>
+            </p:cNvPr>
+            <p:cNvCxnSpPr>
+              <a:cxnSpLocks/>
+              <a:stCxn id="24" idx="2"/>
+              <a:endCxn id="25" idx="0"/>
+            </p:cNvCxnSpPr>
+            <p:nvPr/>
+          </p:nvCxnSpPr>
+          <p:spPr>
+            <a:xfrm>
+              <a:off x="3588577" y="3522713"/>
+              <a:ext cx="0" cy="307914"/>
+            </a:xfrm>
+            <a:prstGeom prst="straightConnector1">
+              <a:avLst/>
+            </a:prstGeom>
+            <a:ln>
+              <a:tailEnd type="triangle"/>
+            </a:ln>
+          </p:spPr>
+          <p:style>
+            <a:lnRef idx="2">
+              <a:schemeClr val="accent1"/>
+            </a:lnRef>
+            <a:fillRef idx="0">
+              <a:schemeClr val="accent1"/>
+            </a:fillRef>
+            <a:effectRef idx="1">
+              <a:schemeClr val="accent1"/>
+            </a:effectRef>
+            <a:fontRef idx="minor">
+              <a:schemeClr val="tx1"/>
+            </a:fontRef>
+          </p:style>
+        </p:cxnSp>
+        <p:cxnSp>
+          <p:nvCxnSpPr>
+            <p:cNvPr id="33" name="직선 화살표 연결선 32">
+              <a:extLst>
+                <a:ext uri="{FF2B5EF4-FFF2-40B4-BE49-F238E27FC236}">
+                  <a16:creationId xmlns:a16="http://schemas.microsoft.com/office/drawing/2014/main" id="{4C4AF631-54DB-10BE-D183-DFB19CB25458}"/>
+                </a:ext>
+              </a:extLst>
+            </p:cNvPr>
+            <p:cNvCxnSpPr>
+              <a:cxnSpLocks/>
+              <a:stCxn id="25" idx="2"/>
+              <a:endCxn id="26" idx="0"/>
+            </p:cNvCxnSpPr>
+            <p:nvPr/>
+          </p:nvCxnSpPr>
+          <p:spPr>
+            <a:xfrm>
+              <a:off x="3588577" y="4360852"/>
+              <a:ext cx="0" cy="307914"/>
+            </a:xfrm>
+            <a:prstGeom prst="straightConnector1">
+              <a:avLst/>
+            </a:prstGeom>
+            <a:ln>
+              <a:tailEnd type="triangle"/>
+            </a:ln>
+          </p:spPr>
+          <p:style>
+            <a:lnRef idx="2">
+              <a:schemeClr val="accent1"/>
+            </a:lnRef>
+            <a:fillRef idx="0">
+              <a:schemeClr val="accent1"/>
+            </a:fillRef>
+            <a:effectRef idx="1">
+              <a:schemeClr val="accent1"/>
+            </a:effectRef>
+            <a:fontRef idx="minor">
+              <a:schemeClr val="tx1"/>
+            </a:fontRef>
+          </p:style>
+        </p:cxnSp>
+        <p:cxnSp>
+          <p:nvCxnSpPr>
+            <p:cNvPr id="38" name="직선 화살표 연결선 37">
+              <a:extLst>
+                <a:ext uri="{FF2B5EF4-FFF2-40B4-BE49-F238E27FC236}">
+                  <a16:creationId xmlns:a16="http://schemas.microsoft.com/office/drawing/2014/main" id="{C6CF37E7-F317-6AAC-2536-E61D982A61BD}"/>
+                </a:ext>
+              </a:extLst>
+            </p:cNvPr>
+            <p:cNvCxnSpPr>
+              <a:cxnSpLocks/>
+              <a:stCxn id="26" idx="2"/>
+              <a:endCxn id="27" idx="0"/>
+            </p:cNvCxnSpPr>
+            <p:nvPr/>
+          </p:nvCxnSpPr>
+          <p:spPr>
+            <a:xfrm>
+              <a:off x="3588577" y="4997114"/>
+              <a:ext cx="0" cy="307914"/>
             </a:xfrm>
             <a:prstGeom prst="straightConnector1">
               <a:avLst/>
@@ -13513,1274 +15138,40 @@
         </p:cxnSp>
         <p:sp>
           <p:nvSpPr>
-            <p:cNvPr id="28" name="순서도: 수동 입력 27">
+            <p:cNvPr id="42" name="TextBox 41">
               <a:extLst>
                 <a:ext uri="{FF2B5EF4-FFF2-40B4-BE49-F238E27FC236}">
-                  <a16:creationId xmlns:a16="http://schemas.microsoft.com/office/drawing/2014/main" id="{17A7DA9A-4056-05C7-4881-D917776F1806}"/>
+                  <a16:creationId xmlns:a16="http://schemas.microsoft.com/office/drawing/2014/main" id="{D54D2BF1-3A1D-1128-1F36-7F797A84013B}"/>
                 </a:ext>
               </a:extLst>
             </p:cNvPr>
-            <p:cNvSpPr/>
+            <p:cNvSpPr txBox="1"/>
             <p:nvPr/>
           </p:nvSpPr>
           <p:spPr>
             <a:xfrm>
-              <a:off x="3077632" y="3039613"/>
-              <a:ext cx="703794" cy="378252"/>
+              <a:off x="2862266" y="2826332"/>
+              <a:ext cx="360492" cy="215444"/>
             </a:xfrm>
-            <a:prstGeom prst="flowChartManualInput">
+            <a:prstGeom prst="rect">
               <a:avLst/>
             </a:prstGeom>
-            <a:solidFill>
-              <a:srgbClr val="F1D365"/>
-            </a:solidFill>
-            <a:ln>
-              <a:noFill/>
-            </a:ln>
-            <a:effectLst>
-              <a:outerShdw blurRad="50800" dist="38100" dir="2700000" algn="tl" rotWithShape="0">
-                <a:prstClr val="black">
-                  <a:alpha val="40000"/>
-                </a:prstClr>
-              </a:outerShdw>
-            </a:effectLst>
+            <a:noFill/>
           </p:spPr>
-          <p:style>
-            <a:lnRef idx="2">
-              <a:schemeClr val="accent1">
-                <a:shade val="15000"/>
-              </a:schemeClr>
-            </a:lnRef>
-            <a:fillRef idx="1">
-              <a:schemeClr val="accent1"/>
-            </a:fillRef>
-            <a:effectRef idx="0">
-              <a:schemeClr val="accent1"/>
-            </a:effectRef>
-            <a:fontRef idx="minor">
-              <a:schemeClr val="lt1"/>
-            </a:fontRef>
-          </p:style>
           <p:txBody>
-            <a:bodyPr rtlCol="0" anchor="ctr"/>
+            <a:bodyPr wrap="square" rtlCol="0">
+              <a:spAutoFit/>
+            </a:bodyPr>
             <a:lstStyle/>
             <a:p>
-              <a:pPr algn="ctr"/>
               <a:r>
-                <a:rPr lang="en-US" altLang="ko-KR" sz="800" dirty="0">
-                  <a:solidFill>
-                    <a:schemeClr val="tx1"/>
-                  </a:solidFill>
+                <a:rPr lang="en-US" altLang="ko-KR" sz="800" b="1">
                   <a:latin typeface="Arial" panose="020B0604020202020204" pitchFamily="34" charset="0"/>
                   <a:cs typeface="Arial" panose="020B0604020202020204" pitchFamily="34" charset="0"/>
                 </a:rPr>
-                <a:t>Initial information</a:t>
+                <a:t>(c)</a:t>
               </a:r>
-              <a:endParaRPr lang="ko-KR" altLang="en-US" sz="800" dirty="0">
-                <a:solidFill>
-                  <a:schemeClr val="tx1"/>
-                </a:solidFill>
-                <a:latin typeface="Arial" panose="020B0604020202020204" pitchFamily="34" charset="0"/>
-                <a:cs typeface="Arial" panose="020B0604020202020204" pitchFamily="34" charset="0"/>
-              </a:endParaRPr>
-            </a:p>
-          </p:txBody>
-        </p:sp>
-        <p:grpSp>
-          <p:nvGrpSpPr>
-            <p:cNvPr id="35" name="그룹 34">
-              <a:extLst>
-                <a:ext uri="{FF2B5EF4-FFF2-40B4-BE49-F238E27FC236}">
-                  <a16:creationId xmlns:a16="http://schemas.microsoft.com/office/drawing/2014/main" id="{A4D73583-B9C7-E80D-44A5-C2B61A26846B}"/>
-                </a:ext>
-              </a:extLst>
-            </p:cNvPr>
-            <p:cNvGrpSpPr/>
-            <p:nvPr/>
-          </p:nvGrpSpPr>
-          <p:grpSpPr>
-            <a:xfrm>
-              <a:off x="544132" y="2827561"/>
-              <a:ext cx="2801780" cy="2988598"/>
-              <a:chOff x="544132" y="2827561"/>
-              <a:chExt cx="2801780" cy="2988598"/>
-            </a:xfrm>
-          </p:grpSpPr>
-          <mc:AlternateContent xmlns:mc="http://schemas.openxmlformats.org/markup-compatibility/2006">
-            <mc:Choice xmlns:a14="http://schemas.microsoft.com/office/drawing/2010/main" Requires="a14">
-              <p:sp>
-                <p:nvSpPr>
-                  <p:cNvPr id="20" name="TextBox 19">
-                    <a:extLst>
-                      <a:ext uri="{FF2B5EF4-FFF2-40B4-BE49-F238E27FC236}">
-                        <a16:creationId xmlns:a16="http://schemas.microsoft.com/office/drawing/2014/main" id="{C257EAA8-FA25-A456-3DC6-70313094052C}"/>
-                      </a:ext>
-                    </a:extLst>
-                  </p:cNvPr>
-                  <p:cNvSpPr txBox="1"/>
-                  <p:nvPr/>
-                </p:nvSpPr>
-                <p:spPr>
-                  <a:xfrm>
-                    <a:off x="690705" y="4120522"/>
-                    <a:ext cx="1065102" cy="220958"/>
-                  </a:xfrm>
-                  <a:prstGeom prst="rect">
-                    <a:avLst/>
-                  </a:prstGeom>
-                  <a:noFill/>
-                </p:spPr>
-                <p:txBody>
-                  <a:bodyPr wrap="square" rtlCol="0">
-                    <a:spAutoFit/>
-                  </a:bodyPr>
-                  <a:lstStyle/>
-                  <a:p>
-                    <a14:m>
-                      <m:oMath xmlns:m="http://schemas.openxmlformats.org/officeDocument/2006/math">
-                        <m:sSub>
-                          <m:sSubPr>
-                            <m:ctrlPr>
-                              <a:rPr lang="en-US" altLang="ko-KR" sz="800" b="0" i="1" smtClean="0">
-                                <a:ln w="9525">
-                                  <a:solidFill>
-                                    <a:schemeClr val="tx1">
-                                      <a:alpha val="29000"/>
-                                    </a:schemeClr>
-                                  </a:solidFill>
-                                </a:ln>
-                                <a:latin typeface="Cambria Math" panose="02040503050406030204" pitchFamily="18" charset="0"/>
-                                <a:ea typeface="맑은 고딕"/>
-                                <a:cs typeface="Times New Roman"/>
-                              </a:rPr>
-                            </m:ctrlPr>
-                          </m:sSubPr>
-                          <m:e>
-                            <m:r>
-                              <a:rPr lang="en-US" altLang="ko-KR" sz="800" b="0" i="1" smtClean="0">
-                                <a:ln w="9525">
-                                  <a:solidFill>
-                                    <a:schemeClr val="tx1">
-                                      <a:alpha val="29000"/>
-                                    </a:schemeClr>
-                                  </a:solidFill>
-                                </a:ln>
-                                <a:latin typeface="Cambria Math" panose="02040503050406030204" pitchFamily="18" charset="0"/>
-                                <a:ea typeface="맑은 고딕"/>
-                                <a:cs typeface="Times New Roman"/>
-                              </a:rPr>
-                              <m:t>𝑒</m:t>
-                            </m:r>
-                          </m:e>
-                          <m:sub>
-                            <m:r>
-                              <a:rPr lang="en-US" altLang="ko-KR" sz="800" b="0" i="1" smtClean="0">
-                                <a:ln w="9525">
-                                  <a:solidFill>
-                                    <a:schemeClr val="tx1">
-                                      <a:alpha val="29000"/>
-                                    </a:schemeClr>
-                                  </a:solidFill>
-                                </a:ln>
-                                <a:latin typeface="Cambria Math" panose="02040503050406030204" pitchFamily="18" charset="0"/>
-                                <a:ea typeface="맑은 고딕"/>
-                                <a:cs typeface="Times New Roman"/>
-                              </a:rPr>
-                              <m:t>𝑐h</m:t>
-                            </m:r>
-                          </m:sub>
-                        </m:sSub>
-                        <m:r>
-                          <a:rPr lang="en-US" altLang="ko-KR" sz="800" b="0" i="1" smtClean="0">
-                            <a:ln w="9525">
-                              <a:solidFill>
-                                <a:schemeClr val="tx1">
-                                  <a:alpha val="29000"/>
-                                </a:schemeClr>
-                              </a:solidFill>
-                            </a:ln>
-                            <a:latin typeface="Cambria Math" panose="02040503050406030204" pitchFamily="18" charset="0"/>
-                            <a:ea typeface="맑은 고딕"/>
-                            <a:cs typeface="Times New Roman"/>
-                          </a:rPr>
-                          <m:t>=</m:t>
-                        </m:r>
-                        <m:sSub>
-                          <m:sSubPr>
-                            <m:ctrlPr>
-                              <a:rPr lang="en-US" altLang="ko-KR" sz="800" b="0" i="1" smtClean="0">
-                                <a:ln w="9525">
-                                  <a:solidFill>
-                                    <a:schemeClr val="tx1">
-                                      <a:alpha val="29000"/>
-                                    </a:schemeClr>
-                                  </a:solidFill>
-                                </a:ln>
-                                <a:latin typeface="Cambria Math" panose="02040503050406030204" pitchFamily="18" charset="0"/>
-                                <a:ea typeface="맑은 고딕"/>
-                                <a:cs typeface="Times New Roman"/>
-                              </a:rPr>
-                            </m:ctrlPr>
-                          </m:sSubPr>
-                          <m:e>
-                            <m:r>
-                              <a:rPr lang="en-US" altLang="ko-KR" sz="800" b="0" i="1" smtClean="0">
-                                <a:ln w="9525">
-                                  <a:solidFill>
-                                    <a:schemeClr val="tx1">
-                                      <a:alpha val="29000"/>
-                                    </a:schemeClr>
-                                  </a:solidFill>
-                                </a:ln>
-                                <a:latin typeface="Cambria Math" panose="02040503050406030204" pitchFamily="18" charset="0"/>
-                                <a:ea typeface="맑은 고딕"/>
-                                <a:cs typeface="Times New Roman"/>
-                              </a:rPr>
-                              <m:t>𝜈</m:t>
-                            </m:r>
-                          </m:e>
-                          <m:sub>
-                            <m:r>
-                              <a:rPr lang="en-US" altLang="ko-KR" sz="800" b="0" i="1" smtClean="0">
-                                <a:ln w="9525">
-                                  <a:solidFill>
-                                    <a:schemeClr val="tx1">
-                                      <a:alpha val="29000"/>
-                                    </a:schemeClr>
-                                  </a:solidFill>
-                                </a:ln>
-                                <a:latin typeface="Cambria Math" panose="02040503050406030204" pitchFamily="18" charset="0"/>
-                                <a:ea typeface="맑은 고딕"/>
-                                <a:cs typeface="Times New Roman"/>
-                              </a:rPr>
-                              <m:t>𝑐h</m:t>
-                            </m:r>
-                          </m:sub>
-                        </m:sSub>
-                        <m:r>
-                          <a:rPr lang="en-US" altLang="ko-KR" sz="800" b="0" i="1" smtClean="0">
-                            <a:ln w="9525">
-                              <a:solidFill>
-                                <a:schemeClr val="tx1">
-                                  <a:alpha val="29000"/>
-                                </a:schemeClr>
-                              </a:solidFill>
-                            </a:ln>
-                            <a:latin typeface="Cambria Math" panose="02040503050406030204" pitchFamily="18" charset="0"/>
-                            <a:ea typeface="맑은 고딕"/>
-                            <a:cs typeface="Times New Roman"/>
-                          </a:rPr>
-                          <m:t>×</m:t>
-                        </m:r>
-                        <m:sSub>
-                          <m:sSubPr>
-                            <m:ctrlPr>
-                              <a:rPr lang="en-US" altLang="ko-KR" sz="800" b="0" i="1" smtClean="0">
-                                <a:ln w="9525">
-                                  <a:solidFill>
-                                    <a:schemeClr val="tx1">
-                                      <a:alpha val="29000"/>
-                                    </a:schemeClr>
-                                  </a:solidFill>
-                                </a:ln>
-                                <a:latin typeface="Cambria Math" panose="02040503050406030204" pitchFamily="18" charset="0"/>
-                                <a:ea typeface="맑은 고딕"/>
-                                <a:cs typeface="Times New Roman"/>
-                              </a:rPr>
-                            </m:ctrlPr>
-                          </m:sSubPr>
-                          <m:e>
-                            <m:d>
-                              <m:dPr>
-                                <m:begChr m:val="|"/>
-                                <m:endChr m:val="|"/>
-                                <m:ctrlPr>
-                                  <a:rPr lang="en-US" altLang="ko-KR" sz="800" b="0" i="1" smtClean="0">
-                                    <a:ln w="9525">
-                                      <a:solidFill>
-                                        <a:schemeClr val="tx1">
-                                          <a:alpha val="29000"/>
-                                        </a:schemeClr>
-                                      </a:solidFill>
-                                    </a:ln>
-                                    <a:latin typeface="Cambria Math" panose="02040503050406030204" pitchFamily="18" charset="0"/>
-                                    <a:ea typeface="맑은 고딕"/>
-                                    <a:cs typeface="Times New Roman"/>
-                                  </a:rPr>
-                                </m:ctrlPr>
-                              </m:dPr>
-                              <m:e>
-                                <m:r>
-                                  <a:rPr lang="en-US" altLang="ko-KR" sz="800" b="0" i="1" smtClean="0">
-                                    <a:ln w="9525">
-                                      <a:solidFill>
-                                        <a:schemeClr val="tx1">
-                                          <a:alpha val="29000"/>
-                                        </a:schemeClr>
-                                      </a:solidFill>
-                                    </a:ln>
-                                    <a:latin typeface="Cambria Math" panose="02040503050406030204" pitchFamily="18" charset="0"/>
-                                    <a:ea typeface="맑은 고딕"/>
-                                    <a:cs typeface="Times New Roman"/>
-                                  </a:rPr>
-                                  <m:t>𝑇𝐶</m:t>
-                                </m:r>
-                              </m:e>
-                            </m:d>
-                          </m:e>
-                          <m:sub>
-                            <m:r>
-                              <a:rPr lang="en-US" altLang="ko-KR" sz="800" b="0" i="1" smtClean="0">
-                                <a:ln w="9525">
-                                  <a:solidFill>
-                                    <a:schemeClr val="tx1">
-                                      <a:alpha val="29000"/>
-                                    </a:schemeClr>
-                                  </a:solidFill>
-                                </a:ln>
-                                <a:latin typeface="Cambria Math" panose="02040503050406030204" pitchFamily="18" charset="0"/>
-                                <a:ea typeface="맑은 고딕"/>
-                                <a:cs typeface="Times New Roman"/>
-                              </a:rPr>
-                              <m:t>𝑐h</m:t>
-                            </m:r>
-                          </m:sub>
-                        </m:sSub>
-                      </m:oMath>
-                    </a14:m>
-                    <a:r>
-                      <a:rPr lang="ko-KR" altLang="en-US" sz="800" dirty="0">
-                        <a:ln w="9525">
-                          <a:solidFill>
-                            <a:schemeClr val="tx1">
-                              <a:alpha val="29000"/>
-                            </a:schemeClr>
-                          </a:solidFill>
-                        </a:ln>
-                        <a:latin typeface="Times New Roman"/>
-                        <a:ea typeface="맑은 고딕"/>
-                        <a:cs typeface="Times New Roman"/>
-                      </a:rPr>
-                      <a:t> </a:t>
-                    </a:r>
-                  </a:p>
-                </p:txBody>
-              </p:sp>
-            </mc:Choice>
-            <mc:Fallback>
-              <p:sp>
-                <p:nvSpPr>
-                  <p:cNvPr id="20" name="TextBox 19">
-                    <a:extLst>
-                      <a:ext uri="{FF2B5EF4-FFF2-40B4-BE49-F238E27FC236}">
-                        <a16:creationId xmlns:a16="http://schemas.microsoft.com/office/drawing/2014/main" id="{C257EAA8-FA25-A456-3DC6-70313094052C}"/>
-                      </a:ext>
-                    </a:extLst>
-                  </p:cNvPr>
-                  <p:cNvSpPr txBox="1">
-                    <a:spLocks noRot="1" noChangeAspect="1" noMove="1" noResize="1" noEditPoints="1" noAdjustHandles="1" noChangeArrowheads="1" noChangeShapeType="1" noTextEdit="1"/>
-                  </p:cNvSpPr>
-                  <p:nvPr/>
-                </p:nvSpPr>
-                <p:spPr>
-                  <a:xfrm>
-                    <a:off x="690705" y="4120522"/>
-                    <a:ext cx="1065102" cy="220958"/>
-                  </a:xfrm>
-                  <a:prstGeom prst="rect">
-                    <a:avLst/>
-                  </a:prstGeom>
-                  <a:blipFill>
-                    <a:blip r:embed="rId3"/>
-                    <a:stretch>
-                      <a:fillRect/>
-                    </a:stretch>
-                  </a:blipFill>
-                </p:spPr>
-                <p:txBody>
-                  <a:bodyPr/>
-                  <a:lstStyle/>
-                  <a:p>
-                    <a:r>
-                      <a:rPr lang="ko-KR" altLang="en-US">
-                        <a:noFill/>
-                      </a:rPr>
-                      <a:t> </a:t>
-                    </a:r>
-                  </a:p>
-                </p:txBody>
-              </p:sp>
-            </mc:Fallback>
-          </mc:AlternateContent>
-          <mc:AlternateContent xmlns:mc="http://schemas.openxmlformats.org/markup-compatibility/2006">
-            <mc:Choice xmlns:a14="http://schemas.microsoft.com/office/drawing/2010/main" Requires="a14">
-              <p:sp>
-                <p:nvSpPr>
-                  <p:cNvPr id="21" name="TextBox 20">
-                    <a:extLst>
-                      <a:ext uri="{FF2B5EF4-FFF2-40B4-BE49-F238E27FC236}">
-                        <a16:creationId xmlns:a16="http://schemas.microsoft.com/office/drawing/2014/main" id="{6803C50A-61E5-5F6C-A180-2212E0DA9561}"/>
-                      </a:ext>
-                    </a:extLst>
-                  </p:cNvPr>
-                  <p:cNvSpPr txBox="1"/>
-                  <p:nvPr/>
-                </p:nvSpPr>
-                <p:spPr>
-                  <a:xfrm>
-                    <a:off x="1755807" y="4120522"/>
-                    <a:ext cx="1106459" cy="220958"/>
-                  </a:xfrm>
-                  <a:prstGeom prst="rect">
-                    <a:avLst/>
-                  </a:prstGeom>
-                  <a:noFill/>
-                </p:spPr>
-                <p:txBody>
-                  <a:bodyPr wrap="square" rtlCol="0">
-                    <a:spAutoFit/>
-                  </a:bodyPr>
-                  <a:lstStyle/>
-                  <a:p>
-                    <a14:m>
-                      <m:oMath xmlns:m="http://schemas.openxmlformats.org/officeDocument/2006/math">
-                        <m:sSub>
-                          <m:sSubPr>
-                            <m:ctrlPr>
-                              <a:rPr lang="en-US" altLang="ko-KR" sz="800" b="0" i="1" smtClean="0">
-                                <a:ln w="9525">
-                                  <a:solidFill>
-                                    <a:schemeClr val="tx1">
-                                      <a:alpha val="29000"/>
-                                    </a:schemeClr>
-                                  </a:solidFill>
-                                </a:ln>
-                                <a:latin typeface="Cambria Math" panose="02040503050406030204" pitchFamily="18" charset="0"/>
-                                <a:ea typeface="맑은 고딕"/>
-                                <a:cs typeface="Times New Roman"/>
-                              </a:rPr>
-                            </m:ctrlPr>
-                          </m:sSubPr>
-                          <m:e>
-                            <m:r>
-                              <a:rPr lang="en-US" altLang="ko-KR" sz="800" b="0" i="1" smtClean="0">
-                                <a:ln w="9525">
-                                  <a:solidFill>
-                                    <a:schemeClr val="tx1">
-                                      <a:alpha val="29000"/>
-                                    </a:schemeClr>
-                                  </a:solidFill>
-                                </a:ln>
-                                <a:latin typeface="Cambria Math" panose="02040503050406030204" pitchFamily="18" charset="0"/>
-                                <a:ea typeface="맑은 고딕"/>
-                                <a:cs typeface="Times New Roman"/>
-                              </a:rPr>
-                              <m:t>𝑒</m:t>
-                            </m:r>
-                          </m:e>
-                          <m:sub>
-                            <m:r>
-                              <a:rPr lang="en-US" altLang="ko-KR" sz="800" b="0" i="1" smtClean="0">
-                                <a:ln w="9525">
-                                  <a:solidFill>
-                                    <a:schemeClr val="tx1">
-                                      <a:alpha val="29000"/>
-                                    </a:schemeClr>
-                                  </a:solidFill>
-                                </a:ln>
-                                <a:latin typeface="Cambria Math" panose="02040503050406030204" pitchFamily="18" charset="0"/>
-                                <a:ea typeface="맑은 고딕"/>
-                                <a:cs typeface="Times New Roman"/>
-                              </a:rPr>
-                              <m:t>𝑊𝐿</m:t>
-                            </m:r>
-                          </m:sub>
-                        </m:sSub>
-                        <m:r>
-                          <a:rPr lang="en-US" altLang="ko-KR" sz="800" b="0" i="1" smtClean="0">
-                            <a:ln w="9525">
-                              <a:solidFill>
-                                <a:schemeClr val="tx1">
-                                  <a:alpha val="29000"/>
-                                </a:schemeClr>
-                              </a:solidFill>
-                            </a:ln>
-                            <a:latin typeface="Cambria Math" panose="02040503050406030204" pitchFamily="18" charset="0"/>
-                            <a:ea typeface="맑은 고딕"/>
-                            <a:cs typeface="Times New Roman"/>
-                          </a:rPr>
-                          <m:t>=</m:t>
-                        </m:r>
-                        <m:sSub>
-                          <m:sSubPr>
-                            <m:ctrlPr>
-                              <a:rPr lang="en-US" altLang="ko-KR" sz="800" b="0" i="1" smtClean="0">
-                                <a:ln w="9525">
-                                  <a:solidFill>
-                                    <a:schemeClr val="tx1">
-                                      <a:alpha val="29000"/>
-                                    </a:schemeClr>
-                                  </a:solidFill>
-                                </a:ln>
-                                <a:latin typeface="Cambria Math" panose="02040503050406030204" pitchFamily="18" charset="0"/>
-                                <a:ea typeface="맑은 고딕"/>
-                                <a:cs typeface="Times New Roman"/>
-                              </a:rPr>
-                            </m:ctrlPr>
-                          </m:sSubPr>
-                          <m:e>
-                            <m:r>
-                              <a:rPr lang="en-US" altLang="ko-KR" sz="800" b="0" i="1" smtClean="0">
-                                <a:ln w="9525">
-                                  <a:solidFill>
-                                    <a:schemeClr val="tx1">
-                                      <a:alpha val="29000"/>
-                                    </a:schemeClr>
-                                  </a:solidFill>
-                                </a:ln>
-                                <a:latin typeface="Cambria Math" panose="02040503050406030204" pitchFamily="18" charset="0"/>
-                                <a:ea typeface="맑은 고딕"/>
-                                <a:cs typeface="Times New Roman"/>
-                              </a:rPr>
-                              <m:t>𝜈</m:t>
-                            </m:r>
-                          </m:e>
-                          <m:sub>
-                            <m:r>
-                              <a:rPr lang="en-US" altLang="ko-KR" sz="800" b="0" i="1" smtClean="0">
-                                <a:ln w="9525">
-                                  <a:solidFill>
-                                    <a:schemeClr val="tx1">
-                                      <a:alpha val="29000"/>
-                                    </a:schemeClr>
-                                  </a:solidFill>
-                                </a:ln>
-                                <a:latin typeface="Cambria Math" panose="02040503050406030204" pitchFamily="18" charset="0"/>
-                                <a:ea typeface="맑은 고딕"/>
-                                <a:cs typeface="Times New Roman"/>
-                              </a:rPr>
-                              <m:t>𝑊𝐿</m:t>
-                            </m:r>
-                          </m:sub>
-                        </m:sSub>
-                        <m:r>
-                          <a:rPr lang="en-US" altLang="ko-KR" sz="800" b="0" i="1" smtClean="0">
-                            <a:ln w="9525">
-                              <a:solidFill>
-                                <a:schemeClr val="tx1">
-                                  <a:alpha val="29000"/>
-                                </a:schemeClr>
-                              </a:solidFill>
-                            </a:ln>
-                            <a:latin typeface="Cambria Math" panose="02040503050406030204" pitchFamily="18" charset="0"/>
-                            <a:ea typeface="맑은 고딕"/>
-                            <a:cs typeface="Times New Roman"/>
-                          </a:rPr>
-                          <m:t>×</m:t>
-                        </m:r>
-                        <m:sSub>
-                          <m:sSubPr>
-                            <m:ctrlPr>
-                              <a:rPr lang="en-US" altLang="ko-KR" sz="800" b="0" i="1" smtClean="0">
-                                <a:ln w="9525">
-                                  <a:solidFill>
-                                    <a:schemeClr val="tx1">
-                                      <a:alpha val="29000"/>
-                                    </a:schemeClr>
-                                  </a:solidFill>
-                                </a:ln>
-                                <a:latin typeface="Cambria Math" panose="02040503050406030204" pitchFamily="18" charset="0"/>
-                                <a:ea typeface="맑은 고딕"/>
-                                <a:cs typeface="Times New Roman"/>
-                              </a:rPr>
-                            </m:ctrlPr>
-                          </m:sSubPr>
-                          <m:e>
-                            <m:d>
-                              <m:dPr>
-                                <m:begChr m:val="|"/>
-                                <m:endChr m:val="|"/>
-                                <m:ctrlPr>
-                                  <a:rPr lang="en-US" altLang="ko-KR" sz="800" b="0" i="1" smtClean="0">
-                                    <a:ln w="9525">
-                                      <a:solidFill>
-                                        <a:schemeClr val="tx1">
-                                          <a:alpha val="29000"/>
-                                        </a:schemeClr>
-                                      </a:solidFill>
-                                    </a:ln>
-                                    <a:latin typeface="Cambria Math" panose="02040503050406030204" pitchFamily="18" charset="0"/>
-                                    <a:ea typeface="맑은 고딕"/>
-                                    <a:cs typeface="Times New Roman"/>
-                                  </a:rPr>
-                                </m:ctrlPr>
-                              </m:dPr>
-                              <m:e>
-                                <m:r>
-                                  <a:rPr lang="en-US" altLang="ko-KR" sz="800" b="0" i="1" smtClean="0">
-                                    <a:ln w="9525">
-                                      <a:solidFill>
-                                        <a:schemeClr val="tx1">
-                                          <a:alpha val="29000"/>
-                                        </a:schemeClr>
-                                      </a:solidFill>
-                                    </a:ln>
-                                    <a:latin typeface="Cambria Math" panose="02040503050406030204" pitchFamily="18" charset="0"/>
-                                    <a:ea typeface="맑은 고딕"/>
-                                    <a:cs typeface="Times New Roman"/>
-                                  </a:rPr>
-                                  <m:t>𝑇𝐶</m:t>
-                                </m:r>
-                              </m:e>
-                            </m:d>
-                          </m:e>
-                          <m:sub>
-                            <m:r>
-                              <a:rPr lang="en-US" altLang="ko-KR" sz="800" b="0" i="1" smtClean="0">
-                                <a:ln w="9525">
-                                  <a:solidFill>
-                                    <a:schemeClr val="tx1">
-                                      <a:alpha val="29000"/>
-                                    </a:schemeClr>
-                                  </a:solidFill>
-                                </a:ln>
-                                <a:latin typeface="Cambria Math" panose="02040503050406030204" pitchFamily="18" charset="0"/>
-                                <a:ea typeface="맑은 고딕"/>
-                                <a:cs typeface="Times New Roman"/>
-                              </a:rPr>
-                              <m:t>𝑊𝐿</m:t>
-                            </m:r>
-                          </m:sub>
-                        </m:sSub>
-                      </m:oMath>
-                    </a14:m>
-                    <a:r>
-                      <a:rPr lang="ko-KR" altLang="en-US" sz="800" dirty="0">
-                        <a:ln w="9525">
-                          <a:solidFill>
-                            <a:schemeClr val="tx1">
-                              <a:alpha val="29000"/>
-                            </a:schemeClr>
-                          </a:solidFill>
-                        </a:ln>
-                        <a:latin typeface="Times New Roman"/>
-                        <a:ea typeface="맑은 고딕"/>
-                        <a:cs typeface="Times New Roman"/>
-                      </a:rPr>
-                      <a:t> </a:t>
-                    </a:r>
-                  </a:p>
-                </p:txBody>
-              </p:sp>
-            </mc:Choice>
-            <mc:Fallback>
-              <p:sp>
-                <p:nvSpPr>
-                  <p:cNvPr id="21" name="TextBox 20">
-                    <a:extLst>
-                      <a:ext uri="{FF2B5EF4-FFF2-40B4-BE49-F238E27FC236}">
-                        <a16:creationId xmlns:a16="http://schemas.microsoft.com/office/drawing/2014/main" id="{6803C50A-61E5-5F6C-A180-2212E0DA9561}"/>
-                      </a:ext>
-                    </a:extLst>
-                  </p:cNvPr>
-                  <p:cNvSpPr txBox="1">
-                    <a:spLocks noRot="1" noChangeAspect="1" noMove="1" noResize="1" noEditPoints="1" noAdjustHandles="1" noChangeArrowheads="1" noChangeShapeType="1" noTextEdit="1"/>
-                  </p:cNvSpPr>
-                  <p:nvPr/>
-                </p:nvSpPr>
-                <p:spPr>
-                  <a:xfrm>
-                    <a:off x="1755807" y="4120522"/>
-                    <a:ext cx="1106459" cy="220958"/>
-                  </a:xfrm>
-                  <a:prstGeom prst="rect">
-                    <a:avLst/>
-                  </a:prstGeom>
-                  <a:blipFill>
-                    <a:blip r:embed="rId4"/>
-                    <a:stretch>
-                      <a:fillRect/>
-                    </a:stretch>
-                  </a:blipFill>
-                </p:spPr>
-                <p:txBody>
-                  <a:bodyPr/>
-                  <a:lstStyle/>
-                  <a:p>
-                    <a:r>
-                      <a:rPr lang="ko-KR" altLang="en-US">
-                        <a:noFill/>
-                      </a:rPr>
-                      <a:t> </a:t>
-                    </a:r>
-                  </a:p>
-                </p:txBody>
-              </p:sp>
-            </mc:Fallback>
-          </mc:AlternateContent>
-          <p:sp>
-            <p:nvSpPr>
-              <p:cNvPr id="5" name="TextBox 4">
-                <a:extLst>
-                  <a:ext uri="{FF2B5EF4-FFF2-40B4-BE49-F238E27FC236}">
-                    <a16:creationId xmlns:a16="http://schemas.microsoft.com/office/drawing/2014/main" id="{1CB1AD94-6D16-AB48-D166-299515E182A9}"/>
-                  </a:ext>
-                </a:extLst>
-              </p:cNvPr>
-              <p:cNvSpPr txBox="1"/>
-              <p:nvPr/>
-            </p:nvSpPr>
-            <p:spPr>
-              <a:xfrm>
-                <a:off x="544132" y="2827561"/>
-                <a:ext cx="360492" cy="215444"/>
-              </a:xfrm>
-              <a:prstGeom prst="rect">
-                <a:avLst/>
-              </a:prstGeom>
-              <a:noFill/>
-            </p:spPr>
-            <p:txBody>
-              <a:bodyPr wrap="square" rtlCol="0">
-                <a:spAutoFit/>
-              </a:bodyPr>
-              <a:lstStyle/>
-              <a:p>
-                <a:r>
-                  <a:rPr lang="en-US" altLang="ko-KR" sz="800" b="1" dirty="0">
-                    <a:latin typeface="Arial" panose="020B0604020202020204" pitchFamily="34" charset="0"/>
-                    <a:cs typeface="Arial" panose="020B0604020202020204" pitchFamily="34" charset="0"/>
-                  </a:rPr>
-                  <a:t>(a)</a:t>
-                </a:r>
-                <a:endParaRPr lang="ko-KR" altLang="en-US" sz="800" b="1" dirty="0">
-                  <a:latin typeface="Arial" panose="020B0604020202020204" pitchFamily="34" charset="0"/>
-                  <a:cs typeface="Arial" panose="020B0604020202020204" pitchFamily="34" charset="0"/>
-                </a:endParaRPr>
-              </a:p>
-            </p:txBody>
-          </p:sp>
-          <mc:AlternateContent xmlns:mc="http://schemas.openxmlformats.org/markup-compatibility/2006">
-            <mc:Choice xmlns:a14="http://schemas.microsoft.com/office/drawing/2010/main" Requires="a14">
-              <p:graphicFrame>
-                <p:nvGraphicFramePr>
-                  <p:cNvPr id="16" name="개체 15">
-                    <a:extLst>
-                      <a:ext uri="{FF2B5EF4-FFF2-40B4-BE49-F238E27FC236}">
-                        <a16:creationId xmlns:a16="http://schemas.microsoft.com/office/drawing/2014/main" id="{FE9188F6-D8EC-1390-F1C7-A981564CDA03}"/>
-                      </a:ext>
-                    </a:extLst>
-                  </p:cNvPr>
-                  <p:cNvGraphicFramePr>
-                    <a:graphicFrameLocks noChangeAspect="1"/>
-                  </p:cNvGraphicFramePr>
-                  <p:nvPr>
-                    <p:extLst>
-                      <p:ext uri="{D42A27DB-BD31-4B8C-83A1-F6EECF244321}">
-                        <p14:modId xmlns:p14="http://schemas.microsoft.com/office/powerpoint/2010/main" val="4246772109"/>
-                      </p:ext>
-                    </p:extLst>
-                  </p:nvPr>
-                </p:nvGraphicFramePr>
-                <p:xfrm>
-                  <a:off x="840299" y="3559577"/>
-                  <a:ext cx="2031490" cy="695292"/>
-                </p:xfrm>
-                <a:graphic>
-                  <a:graphicData uri="http://schemas.openxmlformats.org/presentationml/2006/ole">
-                    <mc:AlternateContent>
-                      <mc:Choice xmlns:v="urn:schemas-microsoft-com:vml" Requires="v">
-                        <p:oleObj name="Graph" r:id="rId5" imgW="4684832" imgH="1603466" progId="Origin50.Graph">
-                          <p:embed/>
-                        </p:oleObj>
-                      </mc:Choice>
-                      <mc:Fallback>
-                        <p:oleObj name="Graph" r:id="rId5" imgW="4684832" imgH="1603466" progId="Origin50.Graph">
-                          <p:embed/>
-                          <p:pic>
-                            <p:nvPicPr>
-                              <p:cNvPr id="0" name=""/>
-                              <p:cNvPicPr/>
-                              <p:nvPr/>
-                            </p:nvPicPr>
-                            <p:blipFill>
-                              <a:blip r:embed="rId6"/>
-                              <a:stretch>
-                                <a:fillRect/>
-                              </a:stretch>
-                            </p:blipFill>
-                            <p:spPr>
-                              <a:xfrm>
-                                <a:off x="840299" y="3559577"/>
-                                <a:ext cx="2031490" cy="695292"/>
-                              </a:xfrm>
-                              <a:prstGeom prst="rect">
-                                <a:avLst/>
-                              </a:prstGeom>
-                            </p:spPr>
-                          </p:pic>
-                        </p:oleObj>
-                      </mc:Fallback>
-                    </mc:AlternateContent>
-                  </a:graphicData>
-                </a:graphic>
-              </p:graphicFrame>
-            </mc:Choice>
-            <mc:Fallback>
-              <p:graphicFrame>
-                <p:nvGraphicFramePr>
-                  <p:cNvPr id="16" name="개체 15">
-                    <a:extLst>
-                      <a:ext uri="{FF2B5EF4-FFF2-40B4-BE49-F238E27FC236}">
-                        <a16:creationId xmlns:a16="http://schemas.microsoft.com/office/drawing/2014/main" id="{FE9188F6-D8EC-1390-F1C7-A981564CDA03}"/>
-                      </a:ext>
-                    </a:extLst>
-                  </p:cNvPr>
-                  <p:cNvGraphicFramePr>
-                    <a:graphicFrameLocks noChangeAspect="1"/>
-                  </p:cNvGraphicFramePr>
-                  <p:nvPr>
-                    <p:extLst>
-                      <p:ext uri="{D42A27DB-BD31-4B8C-83A1-F6EECF244321}">
-                        <p14:modId xmlns:p14="http://schemas.microsoft.com/office/powerpoint/2010/main" val="4246772109"/>
-                      </p:ext>
-                    </p:extLst>
-                  </p:nvPr>
-                </p:nvGraphicFramePr>
-                <p:xfrm>
-                  <a:off x="840299" y="3559577"/>
-                  <a:ext cx="2031490" cy="695292"/>
-                </p:xfrm>
-                <a:graphic>
-                  <a:graphicData uri="http://schemas.openxmlformats.org/presentationml/2006/ole">
-                    <mc:AlternateContent>
-                      <mc:Choice xmlns:v="urn:schemas-microsoft-com:vml" Requires="v">
-                        <p:oleObj name="Graph" r:id="rId5" imgW="4684832" imgH="1603466" progId="Origin50.Graph">
-                          <p:embed/>
-                        </p:oleObj>
-                      </mc:Choice>
-                      <mc:Fallback>
-                        <p:oleObj name="Graph" r:id="rId5" imgW="4684832" imgH="1603466" progId="Origin50.Graph">
-                          <p:embed/>
-                          <p:pic>
-                            <p:nvPicPr>
-                              <p:cNvPr id="0" name=""/>
-                              <p:cNvPicPr/>
-                              <p:nvPr/>
-                            </p:nvPicPr>
-                            <p:blipFill>
-                              <a:blip r:embed="rId6"/>
-                              <a:stretch>
-                                <a:fillRect/>
-                              </a:stretch>
-                            </p:blipFill>
-                            <p:spPr>
-                              <a:xfrm>
-                                <a:off x="840299" y="3559577"/>
-                                <a:ext cx="2031490" cy="695292"/>
-                              </a:xfrm>
-                              <a:prstGeom prst="rect">
-                                <a:avLst/>
-                              </a:prstGeom>
-                            </p:spPr>
-                          </p:pic>
-                        </p:oleObj>
-                      </mc:Fallback>
-                    </mc:AlternateContent>
-                  </a:graphicData>
-                </a:graphic>
-              </p:graphicFrame>
-            </mc:Fallback>
-          </mc:AlternateContent>
-          <p:sp>
-            <p:nvSpPr>
-              <p:cNvPr id="17" name="곱하기 기호 16">
-                <a:extLst>
-                  <a:ext uri="{FF2B5EF4-FFF2-40B4-BE49-F238E27FC236}">
-                    <a16:creationId xmlns:a16="http://schemas.microsoft.com/office/drawing/2014/main" id="{9388F6D5-F284-8CA6-6A1D-89F477D0E8F3}"/>
-                  </a:ext>
-                </a:extLst>
-              </p:cNvPr>
-              <p:cNvSpPr/>
-              <p:nvPr/>
-            </p:nvSpPr>
-            <p:spPr>
-              <a:xfrm>
-                <a:off x="1701379" y="3931149"/>
-                <a:ext cx="108857" cy="108857"/>
-              </a:xfrm>
-              <a:prstGeom prst="mathMultiply">
-                <a:avLst>
-                  <a:gd name="adj1" fmla="val 6378"/>
-                </a:avLst>
-              </a:prstGeom>
-              <a:solidFill>
-                <a:schemeClr val="tx1"/>
-              </a:solidFill>
-              <a:ln>
-                <a:solidFill>
-                  <a:schemeClr val="tx1"/>
-                </a:solidFill>
-              </a:ln>
-            </p:spPr>
-            <p:style>
-              <a:lnRef idx="2">
-                <a:schemeClr val="accent1">
-                  <a:shade val="20000"/>
-                </a:schemeClr>
-              </a:lnRef>
-              <a:fillRef idx="1">
-                <a:schemeClr val="accent1"/>
-              </a:fillRef>
-              <a:effectRef idx="0">
-                <a:schemeClr val="accent1"/>
-              </a:effectRef>
-              <a:fontRef idx="minor">
-                <a:schemeClr val="lt1"/>
-              </a:fontRef>
-            </p:style>
-            <p:txBody>
-              <a:bodyPr rtlCol="0" anchor="ctr"/>
-              <a:lstStyle/>
-              <a:p>
-                <a:pPr algn="ctr"/>
-                <a:endParaRPr lang="ko-KR" altLang="en-US" sz="1000"/>
-              </a:p>
-            </p:txBody>
-          </p:sp>
-          <p:cxnSp>
-            <p:nvCxnSpPr>
-              <p:cNvPr id="18" name="직선 화살표 연결선 17">
-                <a:extLst>
-                  <a:ext uri="{FF2B5EF4-FFF2-40B4-BE49-F238E27FC236}">
-                    <a16:creationId xmlns:a16="http://schemas.microsoft.com/office/drawing/2014/main" id="{6E657C14-669A-83F8-355B-F484DE978FBF}"/>
-                  </a:ext>
-                </a:extLst>
-              </p:cNvPr>
-              <p:cNvCxnSpPr>
-                <a:cxnSpLocks/>
-              </p:cNvCxnSpPr>
-              <p:nvPr/>
-            </p:nvCxnSpPr>
-            <p:spPr>
-              <a:xfrm flipH="1">
-                <a:off x="952500" y="3985577"/>
-                <a:ext cx="748879" cy="0"/>
-              </a:xfrm>
-              <a:prstGeom prst="straightConnector1">
-                <a:avLst/>
-              </a:prstGeom>
-              <a:ln w="28575">
-                <a:solidFill>
-                  <a:schemeClr val="tx1"/>
-                </a:solidFill>
-                <a:tailEnd type="triangle"/>
-              </a:ln>
-            </p:spPr>
-            <p:style>
-              <a:lnRef idx="1">
-                <a:schemeClr val="accent1"/>
-              </a:lnRef>
-              <a:fillRef idx="0">
-                <a:schemeClr val="accent1"/>
-              </a:fillRef>
-              <a:effectRef idx="0">
-                <a:schemeClr val="accent1"/>
-              </a:effectRef>
-              <a:fontRef idx="minor">
-                <a:schemeClr val="tx1"/>
-              </a:fontRef>
-            </p:style>
-          </p:cxnSp>
-          <p:cxnSp>
-            <p:nvCxnSpPr>
-              <p:cNvPr id="19" name="직선 화살표 연결선 18">
-                <a:extLst>
-                  <a:ext uri="{FF2B5EF4-FFF2-40B4-BE49-F238E27FC236}">
-                    <a16:creationId xmlns:a16="http://schemas.microsoft.com/office/drawing/2014/main" id="{1C631D80-CFBB-5801-AFE3-2C2A6538FCBC}"/>
-                  </a:ext>
-                </a:extLst>
-              </p:cNvPr>
-              <p:cNvCxnSpPr>
-                <a:cxnSpLocks/>
-              </p:cNvCxnSpPr>
-              <p:nvPr/>
-            </p:nvCxnSpPr>
-            <p:spPr>
-              <a:xfrm>
-                <a:off x="1810236" y="3985577"/>
-                <a:ext cx="990168" cy="0"/>
-              </a:xfrm>
-              <a:prstGeom prst="straightConnector1">
-                <a:avLst/>
-              </a:prstGeom>
-              <a:ln w="28575">
-                <a:solidFill>
-                  <a:schemeClr val="tx1"/>
-                </a:solidFill>
-                <a:prstDash val="sysDash"/>
-                <a:tailEnd type="triangle"/>
-              </a:ln>
-            </p:spPr>
-            <p:style>
-              <a:lnRef idx="1">
-                <a:schemeClr val="accent1"/>
-              </a:lnRef>
-              <a:fillRef idx="0">
-                <a:schemeClr val="accent1"/>
-              </a:fillRef>
-              <a:effectRef idx="0">
-                <a:schemeClr val="accent1"/>
-              </a:effectRef>
-              <a:fontRef idx="minor">
-                <a:schemeClr val="tx1"/>
-              </a:fontRef>
-            </p:style>
-          </p:cxnSp>
-          <p:sp>
-            <p:nvSpPr>
-              <p:cNvPr id="4" name="TextBox 3">
-                <a:extLst>
-                  <a:ext uri="{FF2B5EF4-FFF2-40B4-BE49-F238E27FC236}">
-                    <a16:creationId xmlns:a16="http://schemas.microsoft.com/office/drawing/2014/main" id="{66E802A9-74FD-7888-C9ED-71EE57D06572}"/>
-                  </a:ext>
-                </a:extLst>
-              </p:cNvPr>
-              <p:cNvSpPr txBox="1"/>
-              <p:nvPr/>
-            </p:nvSpPr>
-            <p:spPr>
-              <a:xfrm>
-                <a:off x="544133" y="4352951"/>
-                <a:ext cx="360492" cy="215444"/>
-              </a:xfrm>
-              <a:prstGeom prst="rect">
-                <a:avLst/>
-              </a:prstGeom>
-              <a:noFill/>
-            </p:spPr>
-            <p:txBody>
-              <a:bodyPr wrap="square" rtlCol="0">
-                <a:spAutoFit/>
-              </a:bodyPr>
-              <a:lstStyle/>
-              <a:p>
-                <a:r>
-                  <a:rPr lang="en-US" altLang="ko-KR" sz="800" b="1" dirty="0">
-                    <a:latin typeface="Arial" panose="020B0604020202020204" pitchFamily="34" charset="0"/>
-                    <a:cs typeface="Arial" panose="020B0604020202020204" pitchFamily="34" charset="0"/>
-                  </a:rPr>
-                  <a:t>(b)</a:t>
-                </a:r>
-                <a:endParaRPr lang="ko-KR" altLang="en-US" sz="800" b="1" dirty="0">
-                  <a:latin typeface="Arial" panose="020B0604020202020204" pitchFamily="34" charset="0"/>
-                  <a:cs typeface="Arial" panose="020B0604020202020204" pitchFamily="34" charset="0"/>
-                </a:endParaRPr>
-              </a:p>
-            </p:txBody>
-          </p:sp>
-          <mc:AlternateContent xmlns:mc="http://schemas.openxmlformats.org/markup-compatibility/2006">
-            <mc:Choice xmlns:a14="http://schemas.microsoft.com/office/drawing/2010/main" Requires="a14">
-              <p:graphicFrame>
-                <p:nvGraphicFramePr>
-                  <p:cNvPr id="2" name="개체 1">
-                    <a:extLst>
-                      <a:ext uri="{FF2B5EF4-FFF2-40B4-BE49-F238E27FC236}">
-                        <a16:creationId xmlns:a16="http://schemas.microsoft.com/office/drawing/2014/main" id="{1AC33133-8D65-1B94-57AA-17E0ABA7F4BD}"/>
-                      </a:ext>
-                    </a:extLst>
-                  </p:cNvPr>
-                  <p:cNvGraphicFramePr>
-                    <a:graphicFrameLocks noChangeAspect="1"/>
-                  </p:cNvGraphicFramePr>
-                  <p:nvPr>
-                    <p:extLst>
-                      <p:ext uri="{D42A27DB-BD31-4B8C-83A1-F6EECF244321}">
-                        <p14:modId xmlns:p14="http://schemas.microsoft.com/office/powerpoint/2010/main" val="3474027108"/>
-                      </p:ext>
-                    </p:extLst>
-                  </p:nvPr>
-                </p:nvGraphicFramePr>
-                <p:xfrm>
-                  <a:off x="608653" y="4373462"/>
-                  <a:ext cx="2737259" cy="1442697"/>
-                </p:xfrm>
-                <a:graphic>
-                  <a:graphicData uri="http://schemas.openxmlformats.org/presentationml/2006/ole">
-                    <mc:AlternateContent>
-                      <mc:Choice xmlns:v="urn:schemas-microsoft-com:vml" Requires="v">
-                        <p:oleObj name="Graph" r:id="rId7" imgW="4722409" imgH="2488474" progId="Origin50.Graph">
-                          <p:embed/>
-                        </p:oleObj>
-                      </mc:Choice>
-                      <mc:Fallback>
-                        <p:oleObj name="Graph" r:id="rId7" imgW="4722409" imgH="2488474" progId="Origin50.Graph">
-                          <p:embed/>
-                          <p:pic>
-                            <p:nvPicPr>
-                              <p:cNvPr id="0" name=""/>
-                              <p:cNvPicPr/>
-                              <p:nvPr/>
-                            </p:nvPicPr>
-                            <p:blipFill>
-                              <a:blip r:embed="rId8"/>
-                              <a:stretch>
-                                <a:fillRect/>
-                              </a:stretch>
-                            </p:blipFill>
-                            <p:spPr>
-                              <a:xfrm>
-                                <a:off x="608653" y="4373462"/>
-                                <a:ext cx="2737259" cy="1442697"/>
-                              </a:xfrm>
-                              <a:prstGeom prst="rect">
-                                <a:avLst/>
-                              </a:prstGeom>
-                            </p:spPr>
-                          </p:pic>
-                        </p:oleObj>
-                      </mc:Fallback>
-                    </mc:AlternateContent>
-                  </a:graphicData>
-                </a:graphic>
-              </p:graphicFrame>
-            </mc:Choice>
-            <mc:Fallback>
-              <p:graphicFrame>
-                <p:nvGraphicFramePr>
-                  <p:cNvPr id="2" name="개체 1">
-                    <a:extLst>
-                      <a:ext uri="{FF2B5EF4-FFF2-40B4-BE49-F238E27FC236}">
-                        <a16:creationId xmlns:a16="http://schemas.microsoft.com/office/drawing/2014/main" id="{1AC33133-8D65-1B94-57AA-17E0ABA7F4BD}"/>
-                      </a:ext>
-                    </a:extLst>
-                  </p:cNvPr>
-                  <p:cNvGraphicFramePr>
-                    <a:graphicFrameLocks noChangeAspect="1"/>
-                  </p:cNvGraphicFramePr>
-                  <p:nvPr>
-                    <p:extLst>
-                      <p:ext uri="{D42A27DB-BD31-4B8C-83A1-F6EECF244321}">
-                        <p14:modId xmlns:p14="http://schemas.microsoft.com/office/powerpoint/2010/main" val="3474027108"/>
-                      </p:ext>
-                    </p:extLst>
-                  </p:nvPr>
-                </p:nvGraphicFramePr>
-                <p:xfrm>
-                  <a:off x="608653" y="4373462"/>
-                  <a:ext cx="2737259" cy="1442697"/>
-                </p:xfrm>
-                <a:graphic>
-                  <a:graphicData uri="http://schemas.openxmlformats.org/presentationml/2006/ole">
-                    <mc:AlternateContent>
-                      <mc:Choice xmlns:v="urn:schemas-microsoft-com:vml" Requires="v">
-                        <p:oleObj name="Graph" r:id="rId7" imgW="4722409" imgH="2488474" progId="Origin50.Graph">
-                          <p:embed/>
-                        </p:oleObj>
-                      </mc:Choice>
-                      <mc:Fallback>
-                        <p:oleObj name="Graph" r:id="rId7" imgW="4722409" imgH="2488474" progId="Origin50.Graph">
-                          <p:embed/>
-                          <p:pic>
-                            <p:nvPicPr>
-                              <p:cNvPr id="0" name=""/>
-                              <p:cNvPicPr/>
-                              <p:nvPr/>
-                            </p:nvPicPr>
-                            <p:blipFill>
-                              <a:blip r:embed="rId8"/>
-                              <a:stretch>
-                                <a:fillRect/>
-                              </a:stretch>
-                            </p:blipFill>
-                            <p:spPr>
-                              <a:xfrm>
-                                <a:off x="608653" y="4373462"/>
-                                <a:ext cx="2737259" cy="1442697"/>
-                              </a:xfrm>
-                              <a:prstGeom prst="rect">
-                                <a:avLst/>
-                              </a:prstGeom>
-                            </p:spPr>
-                          </p:pic>
-                        </p:oleObj>
-                      </mc:Fallback>
-                    </mc:AlternateContent>
-                  </a:graphicData>
-                </a:graphic>
-              </p:graphicFrame>
-            </mc:Fallback>
-          </mc:AlternateContent>
-        </p:grpSp>
-        <p:sp>
-          <p:nvSpPr>
-            <p:cNvPr id="29" name="순서도: 수동 입력 28">
-              <a:extLst>
-                <a:ext uri="{FF2B5EF4-FFF2-40B4-BE49-F238E27FC236}">
-                  <a16:creationId xmlns:a16="http://schemas.microsoft.com/office/drawing/2014/main" id="{7C41339E-36A1-E38E-5122-BAD53AF1F696}"/>
-                </a:ext>
-              </a:extLst>
-            </p:cNvPr>
-            <p:cNvSpPr/>
-            <p:nvPr/>
-          </p:nvSpPr>
-          <p:spPr>
-            <a:xfrm>
-              <a:off x="3077632" y="4785247"/>
-              <a:ext cx="703794" cy="263003"/>
-            </a:xfrm>
-            <a:prstGeom prst="flowChartManualInput">
-              <a:avLst/>
-            </a:prstGeom>
-            <a:solidFill>
-              <a:srgbClr val="AFE4FF"/>
-            </a:solidFill>
-            <a:ln>
-              <a:noFill/>
-            </a:ln>
-            <a:effectLst>
-              <a:outerShdw blurRad="50800" dist="38100" dir="2700000" algn="tl" rotWithShape="0">
-                <a:prstClr val="black">
-                  <a:alpha val="40000"/>
-                </a:prstClr>
-              </a:outerShdw>
-            </a:effectLst>
-          </p:spPr>
-          <p:style>
-            <a:lnRef idx="2">
-              <a:schemeClr val="accent1">
-                <a:shade val="15000"/>
-              </a:schemeClr>
-            </a:lnRef>
-            <a:fillRef idx="1">
-              <a:schemeClr val="accent1"/>
-            </a:fillRef>
-            <a:effectRef idx="0">
-              <a:schemeClr val="accent1"/>
-            </a:effectRef>
-            <a:fontRef idx="minor">
-              <a:schemeClr val="lt1"/>
-            </a:fontRef>
-          </p:style>
-          <p:txBody>
-            <a:bodyPr rtlCol="0" anchor="ctr"/>
-            <a:lstStyle/>
-            <a:p>
-              <a:pPr algn="ctr"/>
-              <a:r>
-                <a:rPr lang="en-US" altLang="ko-KR" sz="800" dirty="0">
-                  <a:solidFill>
-                    <a:schemeClr val="tx1"/>
-                  </a:solidFill>
-                  <a:latin typeface="Arial" panose="020B0604020202020204" pitchFamily="34" charset="0"/>
-                  <a:cs typeface="Arial" panose="020B0604020202020204" pitchFamily="34" charset="0"/>
-                </a:rPr>
-                <a:t>Result</a:t>
-              </a:r>
-              <a:endParaRPr lang="ko-KR" altLang="en-US" sz="800" dirty="0">
-                <a:solidFill>
-                  <a:schemeClr val="tx1"/>
-                </a:solidFill>
+              <a:endParaRPr lang="ko-KR" altLang="en-US" sz="800" b="1" dirty="0">
                 <a:latin typeface="Arial" panose="020B0604020202020204" pitchFamily="34" charset="0"/>
                 <a:cs typeface="Arial" panose="020B0604020202020204" pitchFamily="34" charset="0"/>
               </a:endParaRPr>

</xml_diff>

<commit_message>
Figure change, but manuscript must be done later. 감기걸려서 죽을맛이다
</commit_message>
<xml_diff>
--- a/figures/Figures-EDL202602-manuscript.pptx
+++ b/figures/Figures-EDL202602-manuscript.pptx
@@ -4836,686 +4836,610 @@
           </a:p>
         </p:txBody>
       </p:sp>
-      <p:grpSp>
-        <p:nvGrpSpPr>
-          <p:cNvPr id="30" name="그룹 29">
+      <p:pic>
+        <p:nvPicPr>
+          <p:cNvPr id="2" name="그림 1" descr="다채로움, 스크린샷, 그린, 노랑이(가) 표시된 사진&#10;&#10;AI 생성 콘텐츠는 정확하지 않을 수 있습니다.">
             <a:extLst>
               <a:ext uri="{FF2B5EF4-FFF2-40B4-BE49-F238E27FC236}">
-                <a16:creationId xmlns:a16="http://schemas.microsoft.com/office/drawing/2014/main" id="{DF2B7815-CE59-5500-60D9-FC7502FE6878}"/>
+                <a16:creationId xmlns:a16="http://schemas.microsoft.com/office/drawing/2014/main" id="{9A1CAF9D-6B6A-9F18-6A69-7163AAAD9C61}"/>
               </a:ext>
             </a:extLst>
           </p:cNvPr>
-          <p:cNvGrpSpPr/>
+          <p:cNvPicPr>
+            <a:picLocks noChangeAspect="1"/>
+          </p:cNvPicPr>
           <p:nvPr/>
-        </p:nvGrpSpPr>
-        <p:grpSpPr>
+        </p:nvPicPr>
+        <p:blipFill>
+          <a:blip r:embed="rId2"/>
+          <a:srcRect t="19521" b="24931"/>
+          <a:stretch>
+            <a:fillRect/>
+          </a:stretch>
+        </p:blipFill>
+        <p:spPr>
+          <a:xfrm rot="16200000">
+            <a:off x="5338646" y="3281180"/>
+            <a:ext cx="1252920" cy="63383"/>
+          </a:xfrm>
+          <a:prstGeom prst="rect">
+            <a:avLst/>
+          </a:prstGeom>
+        </p:spPr>
+      </p:pic>
+      <p:cxnSp>
+        <p:nvCxnSpPr>
+          <p:cNvPr id="300" name="직선 연결선 299">
+            <a:extLst>
+              <a:ext uri="{FF2B5EF4-FFF2-40B4-BE49-F238E27FC236}">
+                <a16:creationId xmlns:a16="http://schemas.microsoft.com/office/drawing/2014/main" id="{774A86F0-C443-DA34-8985-53F1D3C638BB}"/>
+              </a:ext>
+            </a:extLst>
+          </p:cNvPr>
+          <p:cNvCxnSpPr>
+            <a:cxnSpLocks/>
+          </p:cNvCxnSpPr>
+          <p:nvPr/>
+        </p:nvCxnSpPr>
+        <p:spPr>
+          <a:xfrm>
+            <a:off x="2126659" y="2092625"/>
+            <a:ext cx="0" cy="981575"/>
+          </a:xfrm>
+          <a:prstGeom prst="line">
+            <a:avLst/>
+          </a:prstGeom>
+          <a:ln w="6350">
+            <a:solidFill>
+              <a:schemeClr val="tx1"/>
+            </a:solidFill>
+            <a:prstDash val="dash"/>
+          </a:ln>
+        </p:spPr>
+        <p:style>
+          <a:lnRef idx="2">
+            <a:schemeClr val="accent1"/>
+          </a:lnRef>
+          <a:fillRef idx="0">
+            <a:schemeClr val="accent1"/>
+          </a:fillRef>
+          <a:effectRef idx="1">
+            <a:schemeClr val="accent1"/>
+          </a:effectRef>
+          <a:fontRef idx="minor">
+            <a:schemeClr val="tx1"/>
+          </a:fontRef>
+        </p:style>
+      </p:cxnSp>
+      <p:cxnSp>
+        <p:nvCxnSpPr>
+          <p:cNvPr id="301" name="직선 연결선 300">
+            <a:extLst>
+              <a:ext uri="{FF2B5EF4-FFF2-40B4-BE49-F238E27FC236}">
+                <a16:creationId xmlns:a16="http://schemas.microsoft.com/office/drawing/2014/main" id="{AE1A7C84-B0B6-9860-FA27-6C833DB2F93A}"/>
+              </a:ext>
+            </a:extLst>
+          </p:cNvPr>
+          <p:cNvCxnSpPr>
+            <a:cxnSpLocks/>
+          </p:cNvCxnSpPr>
+          <p:nvPr/>
+        </p:nvCxnSpPr>
+        <p:spPr>
+          <a:xfrm>
+            <a:off x="2895007" y="2057400"/>
+            <a:ext cx="0" cy="1008751"/>
+          </a:xfrm>
+          <a:prstGeom prst="line">
+            <a:avLst/>
+          </a:prstGeom>
+          <a:ln w="6350">
+            <a:solidFill>
+              <a:schemeClr val="tx1"/>
+            </a:solidFill>
+            <a:prstDash val="dash"/>
+          </a:ln>
+        </p:spPr>
+        <p:style>
+          <a:lnRef idx="2">
+            <a:schemeClr val="accent1"/>
+          </a:lnRef>
+          <a:fillRef idx="0">
+            <a:schemeClr val="accent1"/>
+          </a:fillRef>
+          <a:effectRef idx="1">
+            <a:schemeClr val="accent1"/>
+          </a:effectRef>
+          <a:fontRef idx="minor">
+            <a:schemeClr val="tx1"/>
+          </a:fontRef>
+        </p:style>
+      </p:cxnSp>
+      <p:sp>
+        <p:nvSpPr>
+          <p:cNvPr id="23" name="직사각형 22">
+            <a:extLst>
+              <a:ext uri="{FF2B5EF4-FFF2-40B4-BE49-F238E27FC236}">
+                <a16:creationId xmlns:a16="http://schemas.microsoft.com/office/drawing/2014/main" id="{46AF08A3-D3E3-F918-896B-35E2EADB57BA}"/>
+              </a:ext>
+            </a:extLst>
+          </p:cNvPr>
+          <p:cNvSpPr/>
+          <p:nvPr/>
+        </p:nvSpPr>
+        <p:spPr>
+          <a:xfrm>
+            <a:off x="2707599" y="2096465"/>
+            <a:ext cx="187388" cy="428288"/>
+          </a:xfrm>
+          <a:prstGeom prst="rect">
+            <a:avLst/>
+          </a:prstGeom>
+          <a:solidFill>
+            <a:srgbClr val="F9B859"/>
+          </a:solidFill>
+          <a:ln>
+            <a:solidFill>
+              <a:schemeClr val="tx1"/>
+            </a:solidFill>
+          </a:ln>
+        </p:spPr>
+        <p:style>
+          <a:lnRef idx="2">
+            <a:schemeClr val="accent1">
+              <a:shade val="15000"/>
+            </a:schemeClr>
+          </a:lnRef>
+          <a:fillRef idx="1">
+            <a:schemeClr val="accent1"/>
+          </a:fillRef>
+          <a:effectRef idx="0">
+            <a:schemeClr val="accent1"/>
+          </a:effectRef>
+          <a:fontRef idx="minor">
+            <a:schemeClr val="lt1"/>
+          </a:fontRef>
+        </p:style>
+        <p:txBody>
+          <a:bodyPr rtlCol="0" anchor="ctr"/>
+          <a:lstStyle/>
+          <a:p>
+            <a:pPr algn="ctr"/>
+            <a:endParaRPr lang="ko-KR" altLang="en-US" sz="300" b="1" baseline="-25000"/>
+          </a:p>
+        </p:txBody>
+      </p:sp>
+      <p:cxnSp>
+        <p:nvCxnSpPr>
+          <p:cNvPr id="16" name="직선 화살표 연결선 15">
+            <a:extLst>
+              <a:ext uri="{FF2B5EF4-FFF2-40B4-BE49-F238E27FC236}">
+                <a16:creationId xmlns:a16="http://schemas.microsoft.com/office/drawing/2014/main" id="{819B03E9-80AF-7243-754C-5E0F2216C4DD}"/>
+              </a:ext>
+            </a:extLst>
+          </p:cNvPr>
+          <p:cNvCxnSpPr>
+            <a:cxnSpLocks/>
+          </p:cNvCxnSpPr>
+          <p:nvPr/>
+        </p:nvCxnSpPr>
+        <p:spPr>
+          <a:xfrm>
+            <a:off x="2004533" y="2524110"/>
+            <a:ext cx="1064186" cy="0"/>
+          </a:xfrm>
+          <a:prstGeom prst="straightConnector1">
+            <a:avLst/>
+          </a:prstGeom>
+          <a:ln>
+            <a:solidFill>
+              <a:schemeClr val="tx1"/>
+            </a:solidFill>
+            <a:tailEnd type="triangle"/>
+          </a:ln>
+        </p:spPr>
+        <p:style>
+          <a:lnRef idx="2">
+            <a:schemeClr val="accent1"/>
+          </a:lnRef>
+          <a:fillRef idx="0">
+            <a:schemeClr val="accent1"/>
+          </a:fillRef>
+          <a:effectRef idx="1">
+            <a:schemeClr val="accent1"/>
+          </a:effectRef>
+          <a:fontRef idx="minor">
+            <a:schemeClr val="tx1"/>
+          </a:fontRef>
+        </p:style>
+      </p:cxnSp>
+      <p:sp>
+        <p:nvSpPr>
+          <p:cNvPr id="340" name="TextBox 339">
+            <a:extLst>
+              <a:ext uri="{FF2B5EF4-FFF2-40B4-BE49-F238E27FC236}">
+                <a16:creationId xmlns:a16="http://schemas.microsoft.com/office/drawing/2014/main" id="{A092FB95-3CFD-EA9D-410B-F92547721757}"/>
+              </a:ext>
+            </a:extLst>
+          </p:cNvPr>
+          <p:cNvSpPr txBox="1"/>
+          <p:nvPr/>
+        </p:nvSpPr>
+        <p:spPr>
           <a:xfrm>
             <a:off x="1337549" y="1906859"/>
-            <a:ext cx="1731170" cy="1167341"/>
-            <a:chOff x="1337549" y="1906859"/>
-            <a:chExt cx="1731170" cy="1167341"/>
+            <a:ext cx="360492" cy="200055"/>
           </a:xfrm>
-        </p:grpSpPr>
-        <p:cxnSp>
-          <p:nvCxnSpPr>
-            <p:cNvPr id="300" name="직선 연결선 299">
-              <a:extLst>
-                <a:ext uri="{FF2B5EF4-FFF2-40B4-BE49-F238E27FC236}">
-                  <a16:creationId xmlns:a16="http://schemas.microsoft.com/office/drawing/2014/main" id="{774A86F0-C443-DA34-8985-53F1D3C638BB}"/>
-                </a:ext>
-              </a:extLst>
-            </p:cNvPr>
-            <p:cNvCxnSpPr>
-              <a:cxnSpLocks/>
-            </p:cNvCxnSpPr>
-            <p:nvPr/>
-          </p:nvCxnSpPr>
-          <p:spPr>
-            <a:xfrm>
-              <a:off x="2126659" y="2092625"/>
-              <a:ext cx="0" cy="981575"/>
-            </a:xfrm>
-            <a:prstGeom prst="line">
-              <a:avLst/>
-            </a:prstGeom>
-            <a:ln w="6350">
-              <a:solidFill>
-                <a:schemeClr val="tx1"/>
-              </a:solidFill>
-              <a:prstDash val="dash"/>
-            </a:ln>
-          </p:spPr>
-          <p:style>
-            <a:lnRef idx="2">
-              <a:schemeClr val="accent1"/>
-            </a:lnRef>
-            <a:fillRef idx="0">
-              <a:schemeClr val="accent1"/>
-            </a:fillRef>
-            <a:effectRef idx="1">
-              <a:schemeClr val="accent1"/>
-            </a:effectRef>
-            <a:fontRef idx="minor">
-              <a:schemeClr val="tx1"/>
-            </a:fontRef>
-          </p:style>
-        </p:cxnSp>
-        <p:cxnSp>
-          <p:nvCxnSpPr>
-            <p:cNvPr id="301" name="직선 연결선 300">
-              <a:extLst>
-                <a:ext uri="{FF2B5EF4-FFF2-40B4-BE49-F238E27FC236}">
-                  <a16:creationId xmlns:a16="http://schemas.microsoft.com/office/drawing/2014/main" id="{AE1A7C84-B0B6-9860-FA27-6C833DB2F93A}"/>
-                </a:ext>
-              </a:extLst>
-            </p:cNvPr>
-            <p:cNvCxnSpPr>
-              <a:cxnSpLocks/>
-            </p:cNvCxnSpPr>
-            <p:nvPr/>
-          </p:nvCxnSpPr>
-          <p:spPr>
-            <a:xfrm>
-              <a:off x="2895007" y="2057400"/>
-              <a:ext cx="0" cy="1008751"/>
-            </a:xfrm>
-            <a:prstGeom prst="line">
-              <a:avLst/>
-            </a:prstGeom>
-            <a:ln w="6350">
-              <a:solidFill>
-                <a:schemeClr val="tx1"/>
-              </a:solidFill>
-              <a:prstDash val="dash"/>
-            </a:ln>
-          </p:spPr>
-          <p:style>
-            <a:lnRef idx="2">
-              <a:schemeClr val="accent1"/>
-            </a:lnRef>
-            <a:fillRef idx="0">
-              <a:schemeClr val="accent1"/>
-            </a:fillRef>
-            <a:effectRef idx="1">
-              <a:schemeClr val="accent1"/>
-            </a:effectRef>
-            <a:fontRef idx="minor">
-              <a:schemeClr val="tx1"/>
-            </a:fontRef>
-          </p:style>
-        </p:cxnSp>
-        <p:sp>
-          <p:nvSpPr>
-            <p:cNvPr id="23" name="직사각형 22">
-              <a:extLst>
-                <a:ext uri="{FF2B5EF4-FFF2-40B4-BE49-F238E27FC236}">
-                  <a16:creationId xmlns:a16="http://schemas.microsoft.com/office/drawing/2014/main" id="{46AF08A3-D3E3-F918-896B-35E2EADB57BA}"/>
-                </a:ext>
-              </a:extLst>
-            </p:cNvPr>
-            <p:cNvSpPr/>
-            <p:nvPr/>
-          </p:nvSpPr>
-          <p:spPr>
-            <a:xfrm>
-              <a:off x="2707599" y="2096465"/>
-              <a:ext cx="187388" cy="428288"/>
-            </a:xfrm>
-            <a:prstGeom prst="rect">
-              <a:avLst/>
-            </a:prstGeom>
-            <a:solidFill>
-              <a:srgbClr val="9FD6EF"/>
-            </a:solidFill>
-            <a:ln>
-              <a:solidFill>
-                <a:schemeClr val="tx1"/>
-              </a:solidFill>
-            </a:ln>
-          </p:spPr>
-          <p:style>
-            <a:lnRef idx="2">
-              <a:schemeClr val="accent1">
-                <a:shade val="15000"/>
-              </a:schemeClr>
-            </a:lnRef>
-            <a:fillRef idx="1">
-              <a:schemeClr val="accent1"/>
-            </a:fillRef>
-            <a:effectRef idx="0">
-              <a:schemeClr val="accent1"/>
-            </a:effectRef>
-            <a:fontRef idx="minor">
-              <a:schemeClr val="lt1"/>
-            </a:fontRef>
-          </p:style>
-          <p:txBody>
-            <a:bodyPr rtlCol="0" anchor="ctr"/>
-            <a:lstStyle/>
-            <a:p>
-              <a:pPr algn="ctr"/>
-              <a:endParaRPr lang="ko-KR" altLang="en-US" sz="300" b="1" baseline="-25000"/>
-            </a:p>
-          </p:txBody>
-        </p:sp>
-        <p:sp>
-          <p:nvSpPr>
-            <p:cNvPr id="25" name="직사각형 24">
-              <a:extLst>
-                <a:ext uri="{FF2B5EF4-FFF2-40B4-BE49-F238E27FC236}">
-                  <a16:creationId xmlns:a16="http://schemas.microsoft.com/office/drawing/2014/main" id="{EDFD40AF-F4A1-5E80-FF8A-34B90C3CAC20}"/>
-                </a:ext>
-              </a:extLst>
-            </p:cNvPr>
-            <p:cNvSpPr/>
-            <p:nvPr/>
-          </p:nvSpPr>
-          <p:spPr>
-            <a:xfrm flipV="1">
-              <a:off x="2130437" y="2402585"/>
-              <a:ext cx="576195" cy="121525"/>
-            </a:xfrm>
-            <a:prstGeom prst="rect">
-              <a:avLst/>
-            </a:prstGeom>
-            <a:solidFill>
-              <a:srgbClr val="F9B859"/>
-            </a:solidFill>
-            <a:ln>
-              <a:solidFill>
-                <a:schemeClr val="tx1"/>
-              </a:solidFill>
-            </a:ln>
-          </p:spPr>
-          <p:style>
-            <a:lnRef idx="2">
-              <a:schemeClr val="accent1">
-                <a:shade val="15000"/>
-              </a:schemeClr>
-            </a:lnRef>
-            <a:fillRef idx="1">
-              <a:schemeClr val="accent1"/>
-            </a:fillRef>
-            <a:effectRef idx="0">
-              <a:schemeClr val="accent1"/>
-            </a:effectRef>
-            <a:fontRef idx="minor">
-              <a:schemeClr val="lt1"/>
-            </a:fontRef>
-          </p:style>
-          <p:txBody>
-            <a:bodyPr rtlCol="0" anchor="ctr"/>
-            <a:lstStyle/>
-            <a:p>
-              <a:pPr algn="ctr"/>
-              <a:endParaRPr lang="ko-KR" altLang="en-US" sz="600" b="1" baseline="-25000"/>
-            </a:p>
-          </p:txBody>
-        </p:sp>
-        <p:cxnSp>
-          <p:nvCxnSpPr>
-            <p:cNvPr id="16" name="직선 화살표 연결선 15">
-              <a:extLst>
-                <a:ext uri="{FF2B5EF4-FFF2-40B4-BE49-F238E27FC236}">
-                  <a16:creationId xmlns:a16="http://schemas.microsoft.com/office/drawing/2014/main" id="{819B03E9-80AF-7243-754C-5E0F2216C4DD}"/>
-                </a:ext>
-              </a:extLst>
-            </p:cNvPr>
-            <p:cNvCxnSpPr>
-              <a:cxnSpLocks/>
-            </p:cNvCxnSpPr>
-            <p:nvPr/>
-          </p:nvCxnSpPr>
-          <p:spPr>
-            <a:xfrm>
-              <a:off x="2004533" y="2524110"/>
-              <a:ext cx="1064186" cy="0"/>
-            </a:xfrm>
-            <a:prstGeom prst="straightConnector1">
-              <a:avLst/>
-            </a:prstGeom>
-            <a:ln>
-              <a:solidFill>
-                <a:schemeClr val="tx1"/>
-              </a:solidFill>
-              <a:tailEnd type="triangle"/>
-            </a:ln>
-          </p:spPr>
-          <p:style>
-            <a:lnRef idx="2">
-              <a:schemeClr val="accent1"/>
-            </a:lnRef>
-            <a:fillRef idx="0">
-              <a:schemeClr val="accent1"/>
-            </a:fillRef>
-            <a:effectRef idx="1">
-              <a:schemeClr val="accent1"/>
-            </a:effectRef>
-            <a:fontRef idx="minor">
-              <a:schemeClr val="tx1"/>
-            </a:fontRef>
-          </p:style>
-        </p:cxnSp>
-        <p:sp>
-          <p:nvSpPr>
-            <p:cNvPr id="58" name="TextBox 57">
-              <a:extLst>
-                <a:ext uri="{FF2B5EF4-FFF2-40B4-BE49-F238E27FC236}">
-                  <a16:creationId xmlns:a16="http://schemas.microsoft.com/office/drawing/2014/main" id="{90CA2C53-B26A-7338-72EA-F64E20762673}"/>
-                </a:ext>
-              </a:extLst>
-            </p:cNvPr>
-            <p:cNvSpPr txBox="1"/>
-            <p:nvPr/>
-          </p:nvSpPr>
-          <p:spPr>
-            <a:xfrm>
-              <a:off x="2738776" y="2361337"/>
-              <a:ext cx="125034" cy="107722"/>
-            </a:xfrm>
-            <a:prstGeom prst="rect">
-              <a:avLst/>
-            </a:prstGeom>
-            <a:noFill/>
-          </p:spPr>
-          <p:txBody>
-            <a:bodyPr wrap="none" lIns="0" tIns="0" rIns="0" bIns="0" rtlCol="0">
-              <a:spAutoFit/>
-            </a:bodyPr>
-            <a:lstStyle/>
-            <a:p>
-              <a:pPr algn="ctr"/>
-              <a:r>
-                <a:rPr lang="en-US" altLang="ko-KR" sz="700" b="1" dirty="0" err="1"/>
-                <a:t>qh</a:t>
-              </a:r>
-              <a:r>
-                <a:rPr lang="en-US" altLang="ko-KR" sz="700" b="1" baseline="-25000" dirty="0" err="1"/>
-                <a:t>t</a:t>
-              </a:r>
-              <a:endParaRPr lang="ko-KR" altLang="en-US" sz="700" b="1" baseline="-25000" dirty="0"/>
-            </a:p>
-          </p:txBody>
-        </p:sp>
-        <p:sp>
-          <p:nvSpPr>
-            <p:cNvPr id="283" name="TextBox 282">
-              <a:extLst>
-                <a:ext uri="{FF2B5EF4-FFF2-40B4-BE49-F238E27FC236}">
-                  <a16:creationId xmlns:a16="http://schemas.microsoft.com/office/drawing/2014/main" id="{2EF5FDA5-D0D5-4482-17FF-7298970615AE}"/>
-                </a:ext>
-              </a:extLst>
-            </p:cNvPr>
-            <p:cNvSpPr txBox="1"/>
-            <p:nvPr/>
-          </p:nvSpPr>
-          <p:spPr>
-            <a:xfrm>
-              <a:off x="2340788" y="2396555"/>
-              <a:ext cx="155492" cy="107722"/>
-            </a:xfrm>
-            <a:prstGeom prst="rect">
-              <a:avLst/>
-            </a:prstGeom>
-            <a:noFill/>
-          </p:spPr>
-          <p:txBody>
-            <a:bodyPr wrap="none" lIns="0" tIns="0" rIns="0" bIns="0" rtlCol="0">
-              <a:spAutoFit/>
-            </a:bodyPr>
-            <a:lstStyle/>
-            <a:p>
-              <a:pPr algn="ctr"/>
-              <a:r>
-                <a:rPr lang="en-US" altLang="ko-KR" sz="700" b="1" dirty="0"/>
-                <a:t>-</a:t>
-              </a:r>
-              <a:r>
-                <a:rPr lang="en-US" altLang="ko-KR" sz="700" b="1" dirty="0" err="1"/>
-                <a:t>qn</a:t>
-              </a:r>
-              <a:r>
-                <a:rPr lang="en-US" altLang="ko-KR" sz="700" b="1" baseline="-25000" dirty="0" err="1"/>
-                <a:t>t</a:t>
-              </a:r>
-              <a:endParaRPr lang="ko-KR" altLang="en-US" sz="700" b="1" baseline="-25000" dirty="0"/>
-            </a:p>
-          </p:txBody>
-        </p:sp>
-        <p:sp>
-          <p:nvSpPr>
-            <p:cNvPr id="340" name="TextBox 339">
-              <a:extLst>
-                <a:ext uri="{FF2B5EF4-FFF2-40B4-BE49-F238E27FC236}">
-                  <a16:creationId xmlns:a16="http://schemas.microsoft.com/office/drawing/2014/main" id="{A092FB95-3CFD-EA9D-410B-F92547721757}"/>
-                </a:ext>
-              </a:extLst>
-            </p:cNvPr>
-            <p:cNvSpPr txBox="1"/>
-            <p:nvPr/>
-          </p:nvSpPr>
-          <p:spPr>
-            <a:xfrm>
-              <a:off x="1337549" y="1906859"/>
-              <a:ext cx="360492" cy="200055"/>
-            </a:xfrm>
-            <a:prstGeom prst="rect">
-              <a:avLst/>
-            </a:prstGeom>
-            <a:noFill/>
-          </p:spPr>
-          <p:txBody>
-            <a:bodyPr wrap="square" rtlCol="0">
-              <a:spAutoFit/>
-            </a:bodyPr>
-            <a:lstStyle/>
-            <a:p>
-              <a:r>
-                <a:rPr lang="en-US" altLang="ko-KR" sz="700" b="1" dirty="0">
-                  <a:latin typeface="Arial" panose="020B0604020202020204" pitchFamily="34" charset="0"/>
-                  <a:cs typeface="Arial" panose="020B0604020202020204" pitchFamily="34" charset="0"/>
-                </a:rPr>
-                <a:t>(b)</a:t>
-              </a:r>
-              <a:endParaRPr lang="ko-KR" altLang="en-US" sz="700" b="1" dirty="0">
+          <a:prstGeom prst="rect">
+            <a:avLst/>
+          </a:prstGeom>
+          <a:noFill/>
+        </p:spPr>
+        <p:txBody>
+          <a:bodyPr wrap="square" rtlCol="0">
+            <a:spAutoFit/>
+          </a:bodyPr>
+          <a:lstStyle/>
+          <a:p>
+            <a:r>
+              <a:rPr lang="en-US" altLang="ko-KR" sz="700" b="1" dirty="0">
                 <a:latin typeface="Arial" panose="020B0604020202020204" pitchFamily="34" charset="0"/>
                 <a:cs typeface="Arial" panose="020B0604020202020204" pitchFamily="34" charset="0"/>
-              </a:endParaRPr>
-            </a:p>
-          </p:txBody>
-        </p:sp>
-        <p:cxnSp>
-          <p:nvCxnSpPr>
-            <p:cNvPr id="289" name="직선 화살표 연결선 288">
-              <a:extLst>
-                <a:ext uri="{FF2B5EF4-FFF2-40B4-BE49-F238E27FC236}">
-                  <a16:creationId xmlns:a16="http://schemas.microsoft.com/office/drawing/2014/main" id="{BF7303CF-4083-ABBE-6FCF-C2DABD2F6544}"/>
-                </a:ext>
-              </a:extLst>
-            </p:cNvPr>
-            <p:cNvCxnSpPr>
-              <a:cxnSpLocks/>
-            </p:cNvCxnSpPr>
-            <p:nvPr/>
-          </p:nvCxnSpPr>
-          <p:spPr>
-            <a:xfrm>
-              <a:off x="2135189" y="2262116"/>
-              <a:ext cx="760771" cy="0"/>
-            </a:xfrm>
-            <a:prstGeom prst="straightConnector1">
-              <a:avLst/>
-            </a:prstGeom>
-            <a:ln w="9525">
-              <a:solidFill>
-                <a:schemeClr val="tx1"/>
-              </a:solidFill>
-              <a:headEnd type="triangle" w="sm" len="sm"/>
-              <a:tailEnd type="triangle" w="sm" len="sm"/>
-            </a:ln>
-          </p:spPr>
-          <p:style>
-            <a:lnRef idx="2">
-              <a:schemeClr val="accent1"/>
-            </a:lnRef>
-            <a:fillRef idx="0">
-              <a:schemeClr val="accent1"/>
-            </a:fillRef>
-            <a:effectRef idx="1">
-              <a:schemeClr val="accent1"/>
-            </a:effectRef>
-            <a:fontRef idx="minor">
+              </a:rPr>
+              <a:t>(b)</a:t>
+            </a:r>
+            <a:endParaRPr lang="ko-KR" altLang="en-US" sz="700" b="1" dirty="0">
+              <a:latin typeface="Arial" panose="020B0604020202020204" pitchFamily="34" charset="0"/>
+              <a:cs typeface="Arial" panose="020B0604020202020204" pitchFamily="34" charset="0"/>
+            </a:endParaRPr>
+          </a:p>
+        </p:txBody>
+      </p:sp>
+      <p:cxnSp>
+        <p:nvCxnSpPr>
+          <p:cNvPr id="289" name="직선 화살표 연결선 288">
+            <a:extLst>
+              <a:ext uri="{FF2B5EF4-FFF2-40B4-BE49-F238E27FC236}">
+                <a16:creationId xmlns:a16="http://schemas.microsoft.com/office/drawing/2014/main" id="{BF7303CF-4083-ABBE-6FCF-C2DABD2F6544}"/>
+              </a:ext>
+            </a:extLst>
+          </p:cNvPr>
+          <p:cNvCxnSpPr>
+            <a:cxnSpLocks/>
+          </p:cNvCxnSpPr>
+          <p:nvPr/>
+        </p:nvCxnSpPr>
+        <p:spPr>
+          <a:xfrm>
+            <a:off x="2135189" y="2262116"/>
+            <a:ext cx="760771" cy="0"/>
+          </a:xfrm>
+          <a:prstGeom prst="straightConnector1">
+            <a:avLst/>
+          </a:prstGeom>
+          <a:ln w="9525">
+            <a:solidFill>
               <a:schemeClr val="tx1"/>
-            </a:fontRef>
-          </p:style>
-        </p:cxnSp>
-        <p:sp>
-          <p:nvSpPr>
-            <p:cNvPr id="305" name="TextBox 304">
-              <a:extLst>
-                <a:ext uri="{FF2B5EF4-FFF2-40B4-BE49-F238E27FC236}">
-                  <a16:creationId xmlns:a16="http://schemas.microsoft.com/office/drawing/2014/main" id="{EC124455-F295-98AF-7E49-DFD62B80281D}"/>
-                </a:ext>
-              </a:extLst>
-            </p:cNvPr>
-            <p:cNvSpPr txBox="1"/>
-            <p:nvPr/>
-          </p:nvSpPr>
-          <p:spPr>
-            <a:xfrm>
-              <a:off x="2311925" y="2092625"/>
-              <a:ext cx="407298" cy="215444"/>
-            </a:xfrm>
-            <a:prstGeom prst="rect">
-              <a:avLst/>
-            </a:prstGeom>
-            <a:noFill/>
-          </p:spPr>
-          <p:txBody>
-            <a:bodyPr wrap="square" rtlCol="0">
-              <a:spAutoFit/>
-            </a:bodyPr>
-            <a:lstStyle/>
-            <a:p>
-              <a:pPr algn="ctr"/>
-              <a:r>
-                <a:rPr lang="en-US" altLang="ko-KR" sz="800"/>
-                <a:t>t</a:t>
-              </a:r>
-              <a:r>
-                <a:rPr lang="en-US" altLang="ko-KR" sz="800" baseline="-25000"/>
-                <a:t>CTN</a:t>
-              </a:r>
-              <a:endParaRPr lang="ko-KR" altLang="en-US" sz="800" baseline="-25000"/>
-            </a:p>
-          </p:txBody>
-        </p:sp>
-        <p:cxnSp>
-          <p:nvCxnSpPr>
-            <p:cNvPr id="541" name="직선 연결선 540">
-              <a:extLst>
-                <a:ext uri="{FF2B5EF4-FFF2-40B4-BE49-F238E27FC236}">
-                  <a16:creationId xmlns:a16="http://schemas.microsoft.com/office/drawing/2014/main" id="{B56972B8-31DD-C20F-602D-A49D0AAD5ACE}"/>
-                </a:ext>
-              </a:extLst>
-            </p:cNvPr>
-            <p:cNvCxnSpPr>
-              <a:cxnSpLocks/>
-            </p:cNvCxnSpPr>
-            <p:nvPr/>
-          </p:nvCxnSpPr>
-          <p:spPr>
-            <a:xfrm flipV="1">
-              <a:off x="2169702" y="2196967"/>
-              <a:ext cx="0" cy="324000"/>
-            </a:xfrm>
-            <a:prstGeom prst="line">
-              <a:avLst/>
-            </a:prstGeom>
-            <a:ln w="3175">
-              <a:prstDash val="dash"/>
-            </a:ln>
-          </p:spPr>
-          <p:style>
-            <a:lnRef idx="2">
-              <a:schemeClr val="accent1"/>
-            </a:lnRef>
-            <a:fillRef idx="0">
-              <a:schemeClr val="accent1"/>
-            </a:fillRef>
-            <a:effectRef idx="1">
-              <a:schemeClr val="accent1"/>
-            </a:effectRef>
-            <a:fontRef idx="minor">
+            </a:solidFill>
+            <a:headEnd type="triangle" w="sm" len="sm"/>
+            <a:tailEnd type="triangle" w="sm" len="sm"/>
+          </a:ln>
+        </p:spPr>
+        <p:style>
+          <a:lnRef idx="2">
+            <a:schemeClr val="accent1"/>
+          </a:lnRef>
+          <a:fillRef idx="0">
+            <a:schemeClr val="accent1"/>
+          </a:fillRef>
+          <a:effectRef idx="1">
+            <a:schemeClr val="accent1"/>
+          </a:effectRef>
+          <a:fontRef idx="minor">
+            <a:schemeClr val="tx1"/>
+          </a:fontRef>
+        </p:style>
+      </p:cxnSp>
+      <p:sp>
+        <p:nvSpPr>
+          <p:cNvPr id="305" name="TextBox 304">
+            <a:extLst>
+              <a:ext uri="{FF2B5EF4-FFF2-40B4-BE49-F238E27FC236}">
+                <a16:creationId xmlns:a16="http://schemas.microsoft.com/office/drawing/2014/main" id="{EC124455-F295-98AF-7E49-DFD62B80281D}"/>
+              </a:ext>
+            </a:extLst>
+          </p:cNvPr>
+          <p:cNvSpPr txBox="1"/>
+          <p:nvPr/>
+        </p:nvSpPr>
+        <p:spPr>
+          <a:xfrm>
+            <a:off x="2311925" y="2092625"/>
+            <a:ext cx="407298" cy="215444"/>
+          </a:xfrm>
+          <a:prstGeom prst="rect">
+            <a:avLst/>
+          </a:prstGeom>
+          <a:noFill/>
+        </p:spPr>
+        <p:txBody>
+          <a:bodyPr wrap="square" rtlCol="0">
+            <a:spAutoFit/>
+          </a:bodyPr>
+          <a:lstStyle/>
+          <a:p>
+            <a:pPr algn="ctr"/>
+            <a:r>
+              <a:rPr lang="en-US" altLang="ko-KR" sz="800"/>
+              <a:t>t</a:t>
+            </a:r>
+            <a:r>
+              <a:rPr lang="en-US" altLang="ko-KR" sz="800" baseline="-25000"/>
+              <a:t>CTN</a:t>
+            </a:r>
+            <a:endParaRPr lang="ko-KR" altLang="en-US" sz="800" baseline="-25000"/>
+          </a:p>
+        </p:txBody>
+      </p:sp>
+      <p:cxnSp>
+        <p:nvCxnSpPr>
+          <p:cNvPr id="541" name="직선 연결선 540">
+            <a:extLst>
+              <a:ext uri="{FF2B5EF4-FFF2-40B4-BE49-F238E27FC236}">
+                <a16:creationId xmlns:a16="http://schemas.microsoft.com/office/drawing/2014/main" id="{B56972B8-31DD-C20F-602D-A49D0AAD5ACE}"/>
+              </a:ext>
+            </a:extLst>
+          </p:cNvPr>
+          <p:cNvCxnSpPr>
+            <a:cxnSpLocks/>
+          </p:cNvCxnSpPr>
+          <p:nvPr/>
+        </p:nvCxnSpPr>
+        <p:spPr>
+          <a:xfrm flipV="1">
+            <a:off x="2169702" y="2196967"/>
+            <a:ext cx="0" cy="324000"/>
+          </a:xfrm>
+          <a:prstGeom prst="line">
+            <a:avLst/>
+          </a:prstGeom>
+          <a:ln w="3175">
+            <a:prstDash val="dash"/>
+          </a:ln>
+        </p:spPr>
+        <p:style>
+          <a:lnRef idx="2">
+            <a:schemeClr val="accent1"/>
+          </a:lnRef>
+          <a:fillRef idx="0">
+            <a:schemeClr val="accent1"/>
+          </a:fillRef>
+          <a:effectRef idx="1">
+            <a:schemeClr val="accent1"/>
+          </a:effectRef>
+          <a:fontRef idx="minor">
+            <a:schemeClr val="tx1"/>
+          </a:fontRef>
+        </p:style>
+      </p:cxnSp>
+      <p:cxnSp>
+        <p:nvCxnSpPr>
+          <p:cNvPr id="542" name="직선 연결선 541">
+            <a:extLst>
+              <a:ext uri="{FF2B5EF4-FFF2-40B4-BE49-F238E27FC236}">
+                <a16:creationId xmlns:a16="http://schemas.microsoft.com/office/drawing/2014/main" id="{6D248263-98BD-D746-842D-E51F3DDDA3F1}"/>
+              </a:ext>
+            </a:extLst>
+          </p:cNvPr>
+          <p:cNvCxnSpPr>
+            <a:cxnSpLocks/>
+          </p:cNvCxnSpPr>
+          <p:nvPr/>
+        </p:nvCxnSpPr>
+        <p:spPr>
+          <a:xfrm flipV="1">
+            <a:off x="2215705" y="2196967"/>
+            <a:ext cx="0" cy="324000"/>
+          </a:xfrm>
+          <a:prstGeom prst="line">
+            <a:avLst/>
+          </a:prstGeom>
+          <a:ln w="3175">
+            <a:prstDash val="dash"/>
+          </a:ln>
+        </p:spPr>
+        <p:style>
+          <a:lnRef idx="2">
+            <a:schemeClr val="accent1"/>
+          </a:lnRef>
+          <a:fillRef idx="0">
+            <a:schemeClr val="accent1"/>
+          </a:fillRef>
+          <a:effectRef idx="1">
+            <a:schemeClr val="accent1"/>
+          </a:effectRef>
+          <a:fontRef idx="minor">
+            <a:schemeClr val="tx1"/>
+          </a:fontRef>
+        </p:style>
+      </p:cxnSp>
+      <p:cxnSp>
+        <p:nvCxnSpPr>
+          <p:cNvPr id="546" name="직선 연결선 545">
+            <a:extLst>
+              <a:ext uri="{FF2B5EF4-FFF2-40B4-BE49-F238E27FC236}">
+                <a16:creationId xmlns:a16="http://schemas.microsoft.com/office/drawing/2014/main" id="{8B0B6F77-0AA7-642D-AE13-C4441142C942}"/>
+              </a:ext>
+            </a:extLst>
+          </p:cNvPr>
+          <p:cNvCxnSpPr>
+            <a:cxnSpLocks/>
+          </p:cNvCxnSpPr>
+          <p:nvPr/>
+        </p:nvCxnSpPr>
+        <p:spPr>
+          <a:xfrm flipV="1">
+            <a:off x="2261708" y="2196967"/>
+            <a:ext cx="0" cy="324000"/>
+          </a:xfrm>
+          <a:prstGeom prst="line">
+            <a:avLst/>
+          </a:prstGeom>
+          <a:ln w="3175">
+            <a:prstDash val="dash"/>
+          </a:ln>
+        </p:spPr>
+        <p:style>
+          <a:lnRef idx="2">
+            <a:schemeClr val="accent1"/>
+          </a:lnRef>
+          <a:fillRef idx="0">
+            <a:schemeClr val="accent1"/>
+          </a:fillRef>
+          <a:effectRef idx="1">
+            <a:schemeClr val="accent1"/>
+          </a:effectRef>
+          <a:fontRef idx="minor">
+            <a:schemeClr val="tx1"/>
+          </a:fontRef>
+        </p:style>
+      </p:cxnSp>
+      <p:cxnSp>
+        <p:nvCxnSpPr>
+          <p:cNvPr id="549" name="직선 연결선 548">
+            <a:extLst>
+              <a:ext uri="{FF2B5EF4-FFF2-40B4-BE49-F238E27FC236}">
+                <a16:creationId xmlns:a16="http://schemas.microsoft.com/office/drawing/2014/main" id="{96BB6338-B3BA-D9DF-7D39-0503C83479CE}"/>
+              </a:ext>
+            </a:extLst>
+          </p:cNvPr>
+          <p:cNvCxnSpPr>
+            <a:cxnSpLocks/>
+          </p:cNvCxnSpPr>
+          <p:nvPr/>
+        </p:nvCxnSpPr>
+        <p:spPr>
+          <a:xfrm flipV="1">
+            <a:off x="2852337" y="2092625"/>
+            <a:ext cx="0" cy="412467"/>
+          </a:xfrm>
+          <a:prstGeom prst="line">
+            <a:avLst/>
+          </a:prstGeom>
+          <a:ln w="3175">
+            <a:prstDash val="dash"/>
+          </a:ln>
+        </p:spPr>
+        <p:style>
+          <a:lnRef idx="2">
+            <a:schemeClr val="accent1"/>
+          </a:lnRef>
+          <a:fillRef idx="0">
+            <a:schemeClr val="accent1"/>
+          </a:fillRef>
+          <a:effectRef idx="1">
+            <a:schemeClr val="accent1"/>
+          </a:effectRef>
+          <a:fontRef idx="minor">
+            <a:schemeClr val="tx1"/>
+          </a:fontRef>
+        </p:style>
+      </p:cxnSp>
+      <p:cxnSp>
+        <p:nvCxnSpPr>
+          <p:cNvPr id="582" name="직선 연결선 581">
+            <a:extLst>
+              <a:ext uri="{FF2B5EF4-FFF2-40B4-BE49-F238E27FC236}">
+                <a16:creationId xmlns:a16="http://schemas.microsoft.com/office/drawing/2014/main" id="{8C26E27A-63D4-A7D4-55CC-FDFA523EC57B}"/>
+              </a:ext>
+            </a:extLst>
+          </p:cNvPr>
+          <p:cNvCxnSpPr>
+            <a:cxnSpLocks/>
+          </p:cNvCxnSpPr>
+          <p:nvPr/>
+        </p:nvCxnSpPr>
+        <p:spPr>
+          <a:xfrm flipV="1">
+            <a:off x="2807609" y="2092625"/>
+            <a:ext cx="0" cy="412467"/>
+          </a:xfrm>
+          <a:prstGeom prst="line">
+            <a:avLst/>
+          </a:prstGeom>
+          <a:ln w="3175">
+            <a:prstDash val="dash"/>
+          </a:ln>
+        </p:spPr>
+        <p:style>
+          <a:lnRef idx="2">
+            <a:schemeClr val="accent1"/>
+          </a:lnRef>
+          <a:fillRef idx="0">
+            <a:schemeClr val="accent1"/>
+          </a:fillRef>
+          <a:effectRef idx="1">
+            <a:schemeClr val="accent1"/>
+          </a:effectRef>
+          <a:fontRef idx="minor">
+            <a:schemeClr val="tx1"/>
+          </a:fontRef>
+        </p:style>
+      </p:cxnSp>
+      <p:sp>
+        <p:nvSpPr>
+          <p:cNvPr id="25" name="직사각형 24">
+            <a:extLst>
+              <a:ext uri="{FF2B5EF4-FFF2-40B4-BE49-F238E27FC236}">
+                <a16:creationId xmlns:a16="http://schemas.microsoft.com/office/drawing/2014/main" id="{EDFD40AF-F4A1-5E80-FF8A-34B90C3CAC20}"/>
+              </a:ext>
+            </a:extLst>
+          </p:cNvPr>
+          <p:cNvSpPr/>
+          <p:nvPr/>
+        </p:nvSpPr>
+        <p:spPr>
+          <a:xfrm flipV="1">
+            <a:off x="2130437" y="2402585"/>
+            <a:ext cx="576195" cy="121525"/>
+          </a:xfrm>
+          <a:prstGeom prst="rect">
+            <a:avLst/>
+          </a:prstGeom>
+          <a:solidFill>
+            <a:srgbClr val="F9B859"/>
+          </a:solidFill>
+          <a:ln>
+            <a:solidFill>
               <a:schemeClr val="tx1"/>
-            </a:fontRef>
-          </p:style>
-        </p:cxnSp>
-        <p:cxnSp>
-          <p:nvCxnSpPr>
-            <p:cNvPr id="542" name="직선 연결선 541">
-              <a:extLst>
-                <a:ext uri="{FF2B5EF4-FFF2-40B4-BE49-F238E27FC236}">
-                  <a16:creationId xmlns:a16="http://schemas.microsoft.com/office/drawing/2014/main" id="{6D248263-98BD-D746-842D-E51F3DDDA3F1}"/>
-                </a:ext>
-              </a:extLst>
-            </p:cNvPr>
-            <p:cNvCxnSpPr>
-              <a:cxnSpLocks/>
-            </p:cNvCxnSpPr>
-            <p:nvPr/>
-          </p:nvCxnSpPr>
-          <p:spPr>
-            <a:xfrm flipV="1">
-              <a:off x="2215705" y="2196967"/>
-              <a:ext cx="0" cy="324000"/>
-            </a:xfrm>
-            <a:prstGeom prst="line">
-              <a:avLst/>
-            </a:prstGeom>
-            <a:ln w="3175">
-              <a:prstDash val="dash"/>
-            </a:ln>
-          </p:spPr>
-          <p:style>
-            <a:lnRef idx="2">
-              <a:schemeClr val="accent1"/>
-            </a:lnRef>
-            <a:fillRef idx="0">
-              <a:schemeClr val="accent1"/>
-            </a:fillRef>
-            <a:effectRef idx="1">
-              <a:schemeClr val="accent1"/>
-            </a:effectRef>
-            <a:fontRef idx="minor">
-              <a:schemeClr val="tx1"/>
-            </a:fontRef>
-          </p:style>
-        </p:cxnSp>
-        <p:cxnSp>
-          <p:nvCxnSpPr>
-            <p:cNvPr id="546" name="직선 연결선 545">
-              <a:extLst>
-                <a:ext uri="{FF2B5EF4-FFF2-40B4-BE49-F238E27FC236}">
-                  <a16:creationId xmlns:a16="http://schemas.microsoft.com/office/drawing/2014/main" id="{8B0B6F77-0AA7-642D-AE13-C4441142C942}"/>
-                </a:ext>
-              </a:extLst>
-            </p:cNvPr>
-            <p:cNvCxnSpPr>
-              <a:cxnSpLocks/>
-            </p:cNvCxnSpPr>
-            <p:nvPr/>
-          </p:nvCxnSpPr>
-          <p:spPr>
-            <a:xfrm flipV="1">
-              <a:off x="2261708" y="2196967"/>
-              <a:ext cx="0" cy="324000"/>
-            </a:xfrm>
-            <a:prstGeom prst="line">
-              <a:avLst/>
-            </a:prstGeom>
-            <a:ln w="3175">
-              <a:prstDash val="dash"/>
-            </a:ln>
-          </p:spPr>
-          <p:style>
-            <a:lnRef idx="2">
-              <a:schemeClr val="accent1"/>
-            </a:lnRef>
-            <a:fillRef idx="0">
-              <a:schemeClr val="accent1"/>
-            </a:fillRef>
-            <a:effectRef idx="1">
-              <a:schemeClr val="accent1"/>
-            </a:effectRef>
-            <a:fontRef idx="minor">
-              <a:schemeClr val="tx1"/>
-            </a:fontRef>
-          </p:style>
-        </p:cxnSp>
-        <p:cxnSp>
-          <p:nvCxnSpPr>
-            <p:cNvPr id="549" name="직선 연결선 548">
-              <a:extLst>
-                <a:ext uri="{FF2B5EF4-FFF2-40B4-BE49-F238E27FC236}">
-                  <a16:creationId xmlns:a16="http://schemas.microsoft.com/office/drawing/2014/main" id="{96BB6338-B3BA-D9DF-7D39-0503C83479CE}"/>
-                </a:ext>
-              </a:extLst>
-            </p:cNvPr>
-            <p:cNvCxnSpPr>
-              <a:cxnSpLocks/>
-            </p:cNvCxnSpPr>
-            <p:nvPr/>
-          </p:nvCxnSpPr>
-          <p:spPr>
-            <a:xfrm flipV="1">
-              <a:off x="2852337" y="2092625"/>
-              <a:ext cx="0" cy="412467"/>
-            </a:xfrm>
-            <a:prstGeom prst="line">
-              <a:avLst/>
-            </a:prstGeom>
-            <a:ln w="3175">
-              <a:prstDash val="dash"/>
-            </a:ln>
-          </p:spPr>
-          <p:style>
-            <a:lnRef idx="2">
-              <a:schemeClr val="accent1"/>
-            </a:lnRef>
-            <a:fillRef idx="0">
-              <a:schemeClr val="accent1"/>
-            </a:fillRef>
-            <a:effectRef idx="1">
-              <a:schemeClr val="accent1"/>
-            </a:effectRef>
-            <a:fontRef idx="minor">
-              <a:schemeClr val="tx1"/>
-            </a:fontRef>
-          </p:style>
-        </p:cxnSp>
-        <p:cxnSp>
-          <p:nvCxnSpPr>
-            <p:cNvPr id="582" name="직선 연결선 581">
-              <a:extLst>
-                <a:ext uri="{FF2B5EF4-FFF2-40B4-BE49-F238E27FC236}">
-                  <a16:creationId xmlns:a16="http://schemas.microsoft.com/office/drawing/2014/main" id="{8C26E27A-63D4-A7D4-55CC-FDFA523EC57B}"/>
-                </a:ext>
-              </a:extLst>
-            </p:cNvPr>
-            <p:cNvCxnSpPr>
-              <a:cxnSpLocks/>
-            </p:cNvCxnSpPr>
-            <p:nvPr/>
-          </p:nvCxnSpPr>
-          <p:spPr>
-            <a:xfrm flipV="1">
-              <a:off x="2807609" y="2092625"/>
-              <a:ext cx="0" cy="412467"/>
-            </a:xfrm>
-            <a:prstGeom prst="line">
-              <a:avLst/>
-            </a:prstGeom>
-            <a:ln w="3175">
-              <a:prstDash val="dash"/>
-            </a:ln>
-          </p:spPr>
-          <p:style>
-            <a:lnRef idx="2">
-              <a:schemeClr val="accent1"/>
-            </a:lnRef>
-            <a:fillRef idx="0">
-              <a:schemeClr val="accent1"/>
-            </a:fillRef>
-            <a:effectRef idx="1">
-              <a:schemeClr val="accent1"/>
-            </a:effectRef>
-            <a:fontRef idx="minor">
-              <a:schemeClr val="tx1"/>
-            </a:fontRef>
-          </p:style>
-        </p:cxnSp>
-      </p:grpSp>
+            </a:solidFill>
+          </a:ln>
+        </p:spPr>
+        <p:style>
+          <a:lnRef idx="2">
+            <a:schemeClr val="accent1">
+              <a:shade val="15000"/>
+            </a:schemeClr>
+          </a:lnRef>
+          <a:fillRef idx="1">
+            <a:schemeClr val="accent1"/>
+          </a:fillRef>
+          <a:effectRef idx="0">
+            <a:schemeClr val="accent1"/>
+          </a:effectRef>
+          <a:fontRef idx="minor">
+            <a:schemeClr val="lt1"/>
+          </a:fontRef>
+        </p:style>
+        <p:txBody>
+          <a:bodyPr rtlCol="0" anchor="ctr"/>
+          <a:lstStyle/>
+          <a:p>
+            <a:pPr algn="ctr"/>
+            <a:endParaRPr lang="ko-KR" altLang="en-US" sz="600" b="1" baseline="-25000"/>
+          </a:p>
+        </p:txBody>
+      </p:sp>
       <p:grpSp>
         <p:nvGrpSpPr>
           <p:cNvPr id="602" name="그룹 601">
@@ -7285,7 +7209,7 @@
               <p:nvPr/>
             </p:nvPicPr>
             <p:blipFill>
-              <a:blip r:embed="rId2"/>
+              <a:blip r:embed="rId3"/>
               <a:srcRect l="3428" t="5993" r="1651" b="26690"/>
               <a:stretch>
                 <a:fillRect/>
@@ -12933,37 +12857,6 @@
           </a:graphic>
         </p:graphicFrame>
       </p:grpSp>
-      <p:pic>
-        <p:nvPicPr>
-          <p:cNvPr id="2" name="그림 1" descr="다채로움, 스크린샷, 그린, 노랑이(가) 표시된 사진&#10;&#10;AI 생성 콘텐츠는 정확하지 않을 수 있습니다.">
-            <a:extLst>
-              <a:ext uri="{FF2B5EF4-FFF2-40B4-BE49-F238E27FC236}">
-                <a16:creationId xmlns:a16="http://schemas.microsoft.com/office/drawing/2014/main" id="{9A1CAF9D-6B6A-9F18-6A69-7163AAAD9C61}"/>
-              </a:ext>
-            </a:extLst>
-          </p:cNvPr>
-          <p:cNvPicPr>
-            <a:picLocks noChangeAspect="1"/>
-          </p:cNvPicPr>
-          <p:nvPr/>
-        </p:nvPicPr>
-        <p:blipFill>
-          <a:blip r:embed="rId19"/>
-          <a:srcRect t="19521" b="24931"/>
-          <a:stretch>
-            <a:fillRect/>
-          </a:stretch>
-        </p:blipFill>
-        <p:spPr>
-          <a:xfrm rot="16200000">
-            <a:off x="5338646" y="3281180"/>
-            <a:ext cx="1252920" cy="63383"/>
-          </a:xfrm>
-          <a:prstGeom prst="rect">
-            <a:avLst/>
-          </a:prstGeom>
-        </p:spPr>
-      </p:pic>
       <mc:AlternateContent xmlns:mc="http://schemas.openxmlformats.org/markup-compatibility/2006">
         <mc:Choice xmlns:a14="http://schemas.microsoft.com/office/drawing/2010/main" Requires="a14">
           <p:sp>
@@ -13249,7 +13142,7 @@
                 <a:avLst/>
               </a:prstGeom>
               <a:blipFill>
-                <a:blip r:embed="rId20"/>
+                <a:blip r:embed="rId19"/>
                 <a:stretch>
                   <a:fillRect/>
                 </a:stretch>
@@ -13555,7 +13448,7 @@
                 <a:avLst/>
               </a:prstGeom>
               <a:blipFill>
-                <a:blip r:embed="rId21"/>
+                <a:blip r:embed="rId20"/>
                 <a:stretch>
                   <a:fillRect/>
                 </a:stretch>
@@ -13721,6 +13614,51 @@
           </a:fontRef>
         </p:style>
       </p:cxnSp>
+      <p:sp>
+        <p:nvSpPr>
+          <p:cNvPr id="283" name="TextBox 282">
+            <a:extLst>
+              <a:ext uri="{FF2B5EF4-FFF2-40B4-BE49-F238E27FC236}">
+                <a16:creationId xmlns:a16="http://schemas.microsoft.com/office/drawing/2014/main" id="{2EF5FDA5-D0D5-4482-17FF-7298970615AE}"/>
+              </a:ext>
+            </a:extLst>
+          </p:cNvPr>
+          <p:cNvSpPr txBox="1"/>
+          <p:nvPr/>
+        </p:nvSpPr>
+        <p:spPr>
+          <a:xfrm>
+            <a:off x="2340788" y="2396555"/>
+            <a:ext cx="155492" cy="107722"/>
+          </a:xfrm>
+          <a:prstGeom prst="rect">
+            <a:avLst/>
+          </a:prstGeom>
+          <a:noFill/>
+        </p:spPr>
+        <p:txBody>
+          <a:bodyPr wrap="none" lIns="0" tIns="0" rIns="0" bIns="0" rtlCol="0">
+            <a:spAutoFit/>
+          </a:bodyPr>
+          <a:lstStyle/>
+          <a:p>
+            <a:pPr algn="ctr"/>
+            <a:r>
+              <a:rPr lang="en-US" altLang="ko-KR" sz="700" b="1" dirty="0"/>
+              <a:t>-</a:t>
+            </a:r>
+            <a:r>
+              <a:rPr lang="en-US" altLang="ko-KR" sz="700" b="1" dirty="0" err="1"/>
+              <a:t>qn</a:t>
+            </a:r>
+            <a:r>
+              <a:rPr lang="en-US" altLang="ko-KR" sz="700" b="1" baseline="-25000" dirty="0" err="1"/>
+              <a:t>t</a:t>
+            </a:r>
+            <a:endParaRPr lang="ko-KR" altLang="en-US" sz="700" b="1" baseline="-25000" dirty="0"/>
+          </a:p>
+        </p:txBody>
+      </p:sp>
     </p:spTree>
     <p:extLst>
       <p:ext uri="{BB962C8B-B14F-4D97-AF65-F5344CB8AC3E}">

</xml_diff>